<commit_message>
Use the separate FietsWas example before independent practice
</commit_message>
<xml_diff>
--- a/Boek 2 - Kosten, opbrengsten, elasticiteit en surplus/edities/chat-2026/bronnen/H1/paragrafen/2.1.4 Gemengde opgaven/2.1.4 Gemengde opgaven – presentatie.pptx
+++ b/Boek 2 - Kosten, opbrengsten, elasticiteit en surplus/edities/chat-2026/bronnen/H1/paragrafen/2.1.4 Gemengde opgaven/2.1.4 Gemengde opgaven – presentatie.pptx
@@ -2,36 +2,36 @@
 <file path=ppt/presentation.xml><?xml version="1.0" encoding="utf-8"?>
 <p:presentation xmlns:p="http://schemas.openxmlformats.org/presentationml/2006/main">
   <p:sldMasterIdLst>
-    <p:sldMasterId xmlns:r="http://schemas.openxmlformats.org/officeDocument/2006/relationships" id="2147483648" r:id="Rf74d3cbe5d034b4a"/>
+    <p:sldMasterId xmlns:r="http://schemas.openxmlformats.org/officeDocument/2006/relationships" id="2147483648" r:id="Rff6c2153c6ea4ad9"/>
   </p:sldMasterIdLst>
   <p:notesMasterIdLst>
-    <p:notesMasterId xmlns:r="http://schemas.openxmlformats.org/officeDocument/2006/relationships" r:id="Rb0d97689d10e4a23"/>
+    <p:notesMasterId xmlns:r="http://schemas.openxmlformats.org/officeDocument/2006/relationships" r:id="R5f2191f8a4cc4b77"/>
   </p:notesMasterIdLst>
   <p:sldIdLst>
-    <p:sldId xmlns:r="http://schemas.openxmlformats.org/officeDocument/2006/relationships" id="256" r:id="Rbb4842db50fa4e0c"/>
-    <p:sldId xmlns:r="http://schemas.openxmlformats.org/officeDocument/2006/relationships" id="257" r:id="Rf414dc63a8f247b5"/>
-    <p:sldId xmlns:r="http://schemas.openxmlformats.org/officeDocument/2006/relationships" id="258" r:id="Rd81ecdea910e4f52"/>
-    <p:sldId xmlns:r="http://schemas.openxmlformats.org/officeDocument/2006/relationships" id="259" r:id="Rbe3c32ba981942e1"/>
-    <p:sldId xmlns:r="http://schemas.openxmlformats.org/officeDocument/2006/relationships" id="260" r:id="Rfbdb06175e634c22"/>
-    <p:sldId xmlns:r="http://schemas.openxmlformats.org/officeDocument/2006/relationships" id="261" r:id="R655a7e0106ff4433"/>
-    <p:sldId xmlns:r="http://schemas.openxmlformats.org/officeDocument/2006/relationships" id="262" r:id="R5e4e32a009c54bc2"/>
-    <p:sldId xmlns:r="http://schemas.openxmlformats.org/officeDocument/2006/relationships" id="263" r:id="Re144d6a876e14129"/>
-    <p:sldId xmlns:r="http://schemas.openxmlformats.org/officeDocument/2006/relationships" id="264" r:id="Rcbabca595e9c4c8c"/>
-    <p:sldId xmlns:r="http://schemas.openxmlformats.org/officeDocument/2006/relationships" id="265" r:id="R85e46b3cf0734d88"/>
-    <p:sldId xmlns:r="http://schemas.openxmlformats.org/officeDocument/2006/relationships" id="266" r:id="Rba091534a3e14176"/>
-    <p:sldId xmlns:r="http://schemas.openxmlformats.org/officeDocument/2006/relationships" id="267" r:id="R8c690ebd1aa34a47"/>
-    <p:sldId xmlns:r="http://schemas.openxmlformats.org/officeDocument/2006/relationships" id="268" r:id="Rffa1857c63da4ea2"/>
-    <p:sldId xmlns:r="http://schemas.openxmlformats.org/officeDocument/2006/relationships" id="269" r:id="R4df2e763bca743bd"/>
-    <p:sldId xmlns:r="http://schemas.openxmlformats.org/officeDocument/2006/relationships" id="270" r:id="Rfbe8ba1aa4b24232"/>
-    <p:sldId xmlns:r="http://schemas.openxmlformats.org/officeDocument/2006/relationships" id="271" r:id="R18ebdb06a26e4f94"/>
-    <p:sldId xmlns:r="http://schemas.openxmlformats.org/officeDocument/2006/relationships" id="272" r:id="Raf311d5f58584285"/>
-    <p:sldId xmlns:r="http://schemas.openxmlformats.org/officeDocument/2006/relationships" id="273" r:id="R0f3379b0c0c54322"/>
-    <p:sldId xmlns:r="http://schemas.openxmlformats.org/officeDocument/2006/relationships" id="274" r:id="R7e85645e8bef414d"/>
-    <p:sldId xmlns:r="http://schemas.openxmlformats.org/officeDocument/2006/relationships" id="275" r:id="R74a212352579490c"/>
-    <p:sldId xmlns:r="http://schemas.openxmlformats.org/officeDocument/2006/relationships" id="276" r:id="R1b96ab31d7ff46cb"/>
-    <p:sldId xmlns:r="http://schemas.openxmlformats.org/officeDocument/2006/relationships" id="277" r:id="R461e34fc40a04a8d"/>
-    <p:sldId xmlns:r="http://schemas.openxmlformats.org/officeDocument/2006/relationships" id="278" r:id="R0e078532c8204812"/>
-    <p:sldId xmlns:r="http://schemas.openxmlformats.org/officeDocument/2006/relationships" id="279" r:id="Re2d4c3b0801f49eb"/>
+    <p:sldId xmlns:r="http://schemas.openxmlformats.org/officeDocument/2006/relationships" id="256" r:id="Rd2a3b7ce96bd4ace"/>
+    <p:sldId xmlns:r="http://schemas.openxmlformats.org/officeDocument/2006/relationships" id="257" r:id="R18c87ffce60c4f29"/>
+    <p:sldId xmlns:r="http://schemas.openxmlformats.org/officeDocument/2006/relationships" id="258" r:id="Rdc93bb5ecb6043f2"/>
+    <p:sldId xmlns:r="http://schemas.openxmlformats.org/officeDocument/2006/relationships" id="259" r:id="R50a053fce0824b55"/>
+    <p:sldId xmlns:r="http://schemas.openxmlformats.org/officeDocument/2006/relationships" id="260" r:id="Re5020da9d1194286"/>
+    <p:sldId xmlns:r="http://schemas.openxmlformats.org/officeDocument/2006/relationships" id="261" r:id="R74e1d8bc57464069"/>
+    <p:sldId xmlns:r="http://schemas.openxmlformats.org/officeDocument/2006/relationships" id="262" r:id="Re8790dfd5e67444a"/>
+    <p:sldId xmlns:r="http://schemas.openxmlformats.org/officeDocument/2006/relationships" id="263" r:id="Rb14776a8e84645be"/>
+    <p:sldId xmlns:r="http://schemas.openxmlformats.org/officeDocument/2006/relationships" id="264" r:id="R9131d4572e9849d4"/>
+    <p:sldId xmlns:r="http://schemas.openxmlformats.org/officeDocument/2006/relationships" id="265" r:id="R4a907b665abb479b"/>
+    <p:sldId xmlns:r="http://schemas.openxmlformats.org/officeDocument/2006/relationships" id="266" r:id="R2dfed7cc828d41b5"/>
+    <p:sldId xmlns:r="http://schemas.openxmlformats.org/officeDocument/2006/relationships" id="267" r:id="R8e2bb81b792a48e2"/>
+    <p:sldId xmlns:r="http://schemas.openxmlformats.org/officeDocument/2006/relationships" id="268" r:id="R78ed3a76cd64443b"/>
+    <p:sldId xmlns:r="http://schemas.openxmlformats.org/officeDocument/2006/relationships" id="269" r:id="R470c125284b24703"/>
+    <p:sldId xmlns:r="http://schemas.openxmlformats.org/officeDocument/2006/relationships" id="270" r:id="R978fbb65fcdd45bb"/>
+    <p:sldId xmlns:r="http://schemas.openxmlformats.org/officeDocument/2006/relationships" id="271" r:id="Rde9d128bfefc4da9"/>
+    <p:sldId xmlns:r="http://schemas.openxmlformats.org/officeDocument/2006/relationships" id="272" r:id="R866e769625be42b6"/>
+    <p:sldId xmlns:r="http://schemas.openxmlformats.org/officeDocument/2006/relationships" id="273" r:id="Rdc8544ce638d4551"/>
+    <p:sldId xmlns:r="http://schemas.openxmlformats.org/officeDocument/2006/relationships" id="274" r:id="R29d4f6b53ee3437f"/>
+    <p:sldId xmlns:r="http://schemas.openxmlformats.org/officeDocument/2006/relationships" id="275" r:id="R993f3c5d0cb54ef3"/>
+    <p:sldId xmlns:r="http://schemas.openxmlformats.org/officeDocument/2006/relationships" id="276" r:id="R094157aa2b324dbf"/>
+    <p:sldId xmlns:r="http://schemas.openxmlformats.org/officeDocument/2006/relationships" id="277" r:id="Rb2e4e8eb6be045b9"/>
+    <p:sldId xmlns:r="http://schemas.openxmlformats.org/officeDocument/2006/relationships" id="278" r:id="R60897df33b8d4b3a"/>
+    <p:sldId xmlns:r="http://schemas.openxmlformats.org/officeDocument/2006/relationships" id="279" r:id="R0872a9b1acf44813"/>
   </p:sldIdLst>
   <p:sldSz cx="15240000" cy="8572500"/>
   <p:notesSz cx="6858000" cy="9144000"/>
@@ -1943,7 +1943,7 @@
           <a:p xmlns:a="http://schemas.openxmlformats.org/drawingml/2006/main">
             <a:r>
               <a:rPr sz="1400"/>
-              <a:t>Overgang: Gebruik de startopgave als kort uitgewerkt voorbeeld.</a:t>
+              <a:t>Overgang: Demonstreer de aanpak met het aparte FietsWas-voorbeeld. Eventuele feedback op de al gemaakte startopdracht kiest de docent afzonderlijk.</a:t>
             </a:r>
           </a:p>
           <a:p xmlns:a="http://schemas.openxmlformats.org/drawingml/2006/main">
@@ -2693,7 +2693,7 @@
           <a:p xmlns:a="http://schemas.openxmlformats.org/drawingml/2006/main">
             <a:r>
               <a:rPr sz="1400"/>
-              <a:t>Vraag: Welke bedragen veranderen in totaal als er meer shirts komen?</a:t>
+              <a:t>Vraag: Welk totaal verandert als er meer fietsen worden gewassen?</a:t>
             </a:r>
           </a:p>
           <a:p xmlns:a="http://schemas.openxmlformats.org/drawingml/2006/main">
@@ -2705,7 +2705,7 @@
           <a:p xmlns:a="http://schemas.openxmlformats.org/drawingml/2006/main">
             <a:r>
               <a:rPr sz="1400"/>
-              <a:t>Uitleg: Na de startopdracht: tel de vaste bedragen en de variabele bedragen per shirt apart op. Q is het aantal gemaakte én verkochte shirts voor dit feest. TK en TO staan in euro voor het schoolfeest, geldig tot en met 300 shirts. De bezoekverwachting heb je niet nodig om de functies te maken.</a:t>
+              <a:t>Uitleg: FietsWas is een apart, zelfgemaakt voorbeeld. De constante kosten zijn 36 euro per dag. De variabele kosten zijn 2 euro per gewassen fiets. Alle gewassen fietsen worden betaald tegen 5 euro. Daardoor zijn TK = 36 + 2Q en TO = 5Q, binnen maximaal 40 fietsen per dag.</a:t>
             </a:r>
           </a:p>
           <a:p xmlns:a="http://schemas.openxmlformats.org/drawingml/2006/main">
@@ -2717,7 +2717,7 @@
           <a:p xmlns:a="http://schemas.openxmlformats.org/drawingml/2006/main">
             <a:r>
               <a:rPr sz="1400"/>
-              <a:t>Misvatting: Een vast bedrag per shirt betekent geen constante totale kosten.</a:t>
+              <a:t>Misvatting: Een vast bedrag per fiets betekent geen constante totale kosten.</a:t>
             </a:r>
           </a:p>
           <a:p xmlns:a="http://schemas.openxmlformats.org/drawingml/2006/main">
@@ -2729,7 +2729,7 @@
           <a:p xmlns:a="http://schemas.openxmlformats.org/drawingml/2006/main">
             <a:r>
               <a:rPr sz="1400"/>
-              <a:t>Overgang: Vul de gevraagde hoeveelheid in.</a:t>
+              <a:t>Overgang: Vergelijk totale winst en gemiddelde kosten bij twintig fietsen.</a:t>
             </a:r>
           </a:p>
           <a:p xmlns:a="http://schemas.openxmlformats.org/drawingml/2006/main">
@@ -2741,19 +2741,7 @@
           <a:p xmlns:a="http://schemas.openxmlformats.org/drawingml/2006/main">
             <a:r>
               <a:rPr sz="1400"/>
-              <a:t>Bron: leerlingenboek Boek 2, chatuitgave 2026, revisie 21 september 2026, gedrukte pagina 29. https://github.com/meijer1973/4veco-lessen/blob/08d7fd27830b5c42d1dbebc7fcb73b882b4d67a4/Boek%202%20-%20Kosten%2C%20opbrengsten%2C%20elasticiteit%20en%20surplus/edities/chat-2026/boek/Boek_2_Compleet.pdf</a:t>
-            </a:r>
-          </a:p>
-          <a:p xmlns:a="http://schemas.openxmlformats.org/drawingml/2006/main">
-            <a:r>
-              <a:rPr sz="1400"/>
-              <a:t>Antwoordmodel: https://github.com/meijer1973/4veco-lessen/blob/08d7fd27830b5c42d1dbebc7fcb73b882b4d67a4/Boek%202%20-%20Kosten%2C%20opbrengsten%2C%20elasticiteit%20en%20surplus/edities/chat-2026/bronnen/H1/2.1%20Kosten%20en%20opbrengsten%20%E2%80%93%20antwoorden.md</a:t>
-            </a:r>
-          </a:p>
-          <a:p xmlns:a="http://schemas.openxmlformats.org/drawingml/2006/main">
-            <a:r>
-              <a:rPr sz="1400"/>
-              <a:t>Docentenroute: https://github.com/meijer1973/4veco-lessen/blob/08d7fd27830b5c42d1dbebc7fcb73b882b4d67a4/Boek%202%20-%20Kosten%2C%20opbrengsten%2C%20elasticiteit%20en%20surplus/edities/chat-2026/bronnen/H1/Docenten_en_bouwverantwoording.md</a:t>
+              <a:t>Bron: Zelfgemaakt uitlegvoorbeeld FietsWas, niet uit het boek. Context en getallen zijn voor deze uitleg gekozen en vormen geen boekopgave of huiswerk. De onderliggende methoden sluiten aan bij Boek 2, chatuitgave 2026, §2.1.1–2.1.3: kostenfuncties, totale/gemiddelde bedragen, break-even en marginale veranderingen. https://github.com/meijer1973/4veco-lessen/blob/08d7fd27830b5c42d1dbebc7fcb73b882b4d67a4/Boek%202%20-%20Kosten%2C%20opbrengsten%2C%20elasticiteit%20en%20surplus/edities/chat-2026/boek/Boek_2_Compleet.pdf</a:t>
             </a:r>
           </a:p>
         </p:txBody>
@@ -2824,7 +2812,7 @@
           <a:p xmlns:a="http://schemas.openxmlformats.org/drawingml/2006/main">
             <a:r>
               <a:rPr sz="1400"/>
-              <a:t>Vraag: Waarom deel je bij GTK wel door 150 en bij winst niet?</a:t>
+              <a:t>Vraag: Waarom deel je bij GTK door twintig en bij winst niet?</a:t>
             </a:r>
           </a:p>
           <a:p xmlns:a="http://schemas.openxmlformats.org/drawingml/2006/main">
@@ -2836,7 +2824,7 @@
           <a:p xmlns:a="http://schemas.openxmlformats.org/drawingml/2006/main">
             <a:r>
               <a:rPr sz="1400"/>
-              <a:t>Uitleg: Werk steeds via formule, invullen en uitkomst met eenheid. De winst van 300 euro hoort bij alle 150 shirts samen. De gemiddelde totale kosten verdelen 1350 euro over 150 shirts.</a:t>
+              <a:t>Uitleg: Trek twee totalen af om de winst van 24 euro per dag te vinden. Deel de totale kosten van 76 euro door twintig fietsen om GTK van 3,80 euro per fiets te vinden. Benoem het verschil in bewerking en eenheid.</a:t>
             </a:r>
           </a:p>
           <a:p xmlns:a="http://schemas.openxmlformats.org/drawingml/2006/main">
@@ -2848,7 +2836,7 @@
           <a:p xmlns:a="http://schemas.openxmlformats.org/drawingml/2006/main">
             <a:r>
               <a:rPr sz="1400"/>
-              <a:t>Misvatting: Eenheid euro per shirt hoort niet bij totale winst.</a:t>
+              <a:t>Misvatting: 24 euro is de totale dagwinst, niet de winst per fiets.</a:t>
             </a:r>
           </a:p>
           <a:p xmlns:a="http://schemas.openxmlformats.org/drawingml/2006/main">
@@ -2860,7 +2848,7 @@
           <a:p xmlns:a="http://schemas.openxmlformats.org/drawingml/2006/main">
             <a:r>
               <a:rPr sz="1400"/>
-              <a:t>Overgang: Zoek vervolgens waar de totale opbrengst alle kosten dekt.</a:t>
+              <a:t>Overgang: Zoek waar de totale opbrengst precies alle kosten dekt.</a:t>
             </a:r>
           </a:p>
           <a:p xmlns:a="http://schemas.openxmlformats.org/drawingml/2006/main">
@@ -2872,19 +2860,7 @@
           <a:p xmlns:a="http://schemas.openxmlformats.org/drawingml/2006/main">
             <a:r>
               <a:rPr sz="1400"/>
-              <a:t>Bron: leerlingenboek Boek 2, chatuitgave 2026, revisie 21 september 2026, gedrukte pagina 29. https://github.com/meijer1973/4veco-lessen/blob/08d7fd27830b5c42d1dbebc7fcb73b882b4d67a4/Boek%202%20-%20Kosten%2C%20opbrengsten%2C%20elasticiteit%20en%20surplus/edities/chat-2026/boek/Boek_2_Compleet.pdf</a:t>
-            </a:r>
-          </a:p>
-          <a:p xmlns:a="http://schemas.openxmlformats.org/drawingml/2006/main">
-            <a:r>
-              <a:rPr sz="1400"/>
-              <a:t>Antwoordmodel: https://github.com/meijer1973/4veco-lessen/blob/08d7fd27830b5c42d1dbebc7fcb73b882b4d67a4/Boek%202%20-%20Kosten%2C%20opbrengsten%2C%20elasticiteit%20en%20surplus/edities/chat-2026/bronnen/H1/2.1%20Kosten%20en%20opbrengsten%20%E2%80%93%20antwoorden.md</a:t>
-            </a:r>
-          </a:p>
-          <a:p xmlns:a="http://schemas.openxmlformats.org/drawingml/2006/main">
-            <a:r>
-              <a:rPr sz="1400"/>
-              <a:t>Docentenroute: https://github.com/meijer1973/4veco-lessen/blob/08d7fd27830b5c42d1dbebc7fcb73b882b4d67a4/Boek%202%20-%20Kosten%2C%20opbrengsten%2C%20elasticiteit%20en%20surplus/edities/chat-2026/bronnen/H1/Docenten_en_bouwverantwoording.md</a:t>
+              <a:t>Bron: Zelfgemaakt uitlegvoorbeeld FietsWas, niet uit het boek. Context en getallen zijn voor deze uitleg gekozen en vormen geen boekopgave of huiswerk. De onderliggende methoden sluiten aan bij Boek 2, chatuitgave 2026, §2.1.1–2.1.3: kostenfuncties, totale/gemiddelde bedragen, break-even en marginale veranderingen. https://github.com/meijer1973/4veco-lessen/blob/08d7fd27830b5c42d1dbebc7fcb73b882b4d67a4/Boek%202%20-%20Kosten%2C%20opbrengsten%2C%20elasticiteit%20en%20surplus/edities/chat-2026/boek/Boek_2_Compleet.pdf</a:t>
             </a:r>
           </a:p>
         </p:txBody>
@@ -2955,7 +2931,7 @@
           <a:p xmlns:a="http://schemas.openxmlformats.org/drawingml/2006/main">
             <a:r>
               <a:rPr sz="1400"/>
-              <a:t>Vraag: Is break-even hetzelfde als geen verkoopopbrengst?</a:t>
+              <a:t>Vraag: Welke coördinaten horen bij dit break-evenpunt?</a:t>
             </a:r>
           </a:p>
           <a:p xmlns:a="http://schemas.openxmlformats.org/drawingml/2006/main">
@@ -2967,7 +2943,7 @@
           <a:p xmlns:a="http://schemas.openxmlformats.org/drawingml/2006/main">
             <a:r>
               <a:rPr sz="1400"/>
-              <a:t>Uitleg: Bij 100 shirts: TO = 11 × 100 = 1100; TK = 600 + 5 × 100 = 1100 euro. De uitkomst past binnen 300 shirts capaciteit. De kassa is niet leeg: er is 1100 euro verkoopopbrengst, maar die dekt precies de kosten.</a:t>
+              <a:t>Uitleg: Bij twaalf fietsen: TO = 5 × 12 = 60 en TK = 36 + 2 × 12 = 60 euro per dag. Twaalf is een geheel aantal binnen de capaciteit. Het grafiekpunt wordt (12; 60). Winst nul betekent dat de opbrengst de kosten precies dekt.</a:t>
             </a:r>
           </a:p>
           <a:p xmlns:a="http://schemas.openxmlformats.org/drawingml/2006/main">
@@ -2979,7 +2955,7 @@
           <a:p xmlns:a="http://schemas.openxmlformats.org/drawingml/2006/main">
             <a:r>
               <a:rPr sz="1400"/>
-              <a:t>Misvatting: Winst nul betekent niet dat TO nul is.</a:t>
+              <a:t>Misvatting: Twaalf is een hoeveelheid fietsen, zestig is een totaalbedrag in euro per dag.</a:t>
             </a:r>
           </a:p>
           <a:p xmlns:a="http://schemas.openxmlformats.org/drawingml/2006/main">
@@ -2991,7 +2967,7 @@
           <a:p xmlns:a="http://schemas.openxmlformats.org/drawingml/2006/main">
             <a:r>
               <a:rPr sz="1400"/>
-              <a:t>Overgang: Herhaal kort de marginale rekenstap uit een tabel.</a:t>
+              <a:t>Overgang: Bereken nu de verandering als er vijf fietsen bijkomen.</a:t>
             </a:r>
           </a:p>
           <a:p xmlns:a="http://schemas.openxmlformats.org/drawingml/2006/main">
@@ -3003,19 +2979,7 @@
           <a:p xmlns:a="http://schemas.openxmlformats.org/drawingml/2006/main">
             <a:r>
               <a:rPr sz="1400"/>
-              <a:t>Bron: leerlingenboek Boek 2, chatuitgave 2026, revisie 21 september 2026, gedrukte pagina 29. https://github.com/meijer1973/4veco-lessen/blob/08d7fd27830b5c42d1dbebc7fcb73b882b4d67a4/Boek%202%20-%20Kosten%2C%20opbrengsten%2C%20elasticiteit%20en%20surplus/edities/chat-2026/boek/Boek_2_Compleet.pdf</a:t>
-            </a:r>
-          </a:p>
-          <a:p xmlns:a="http://schemas.openxmlformats.org/drawingml/2006/main">
-            <a:r>
-              <a:rPr sz="1400"/>
-              <a:t>Antwoordmodel: https://github.com/meijer1973/4veco-lessen/blob/08d7fd27830b5c42d1dbebc7fcb73b882b4d67a4/Boek%202%20-%20Kosten%2C%20opbrengsten%2C%20elasticiteit%20en%20surplus/edities/chat-2026/bronnen/H1/2.1%20Kosten%20en%20opbrengsten%20%E2%80%93%20antwoorden.md</a:t>
-            </a:r>
-          </a:p>
-          <a:p xmlns:a="http://schemas.openxmlformats.org/drawingml/2006/main">
-            <a:r>
-              <a:rPr sz="1400"/>
-              <a:t>Docentenroute: https://github.com/meijer1973/4veco-lessen/blob/08d7fd27830b5c42d1dbebc7fcb73b882b4d67a4/Boek%202%20-%20Kosten%2C%20opbrengsten%2C%20elasticiteit%20en%20surplus/edities/chat-2026/bronnen/H1/Docenten_en_bouwverantwoording.md</a:t>
+              <a:t>Bron: Zelfgemaakt uitlegvoorbeeld FietsWas, niet uit het boek. Context en getallen zijn voor deze uitleg gekozen en vormen geen boekopgave of huiswerk. De onderliggende methoden sluiten aan bij Boek 2, chatuitgave 2026, §2.1.1–2.1.3: kostenfuncties, totale/gemiddelde bedragen, break-even en marginale veranderingen. https://github.com/meijer1973/4veco-lessen/blob/08d7fd27830b5c42d1dbebc7fcb73b882b4d67a4/Boek%202%20-%20Kosten%2C%20opbrengsten%2C%20elasticiteit%20en%20surplus/edities/chat-2026/boek/Boek_2_Compleet.pdf</a:t>
             </a:r>
           </a:p>
         </p:txBody>
@@ -3086,7 +3050,7 @@
           <a:p xmlns:a="http://schemas.openxmlformats.org/drawingml/2006/main">
             <a:r>
               <a:rPr sz="1400"/>
-              <a:t>Vraag: Waarom deel je door tien en niet door twintig?</a:t>
+              <a:t>Vraag: Waarom deel je door vijf en niet door vijfentwintig?</a:t>
             </a:r>
           </a:p>
           <a:p xmlns:a="http://schemas.openxmlformats.org/drawingml/2006/main">
@@ -3098,7 +3062,7 @@
           <a:p xmlns:a="http://schemas.openxmlformats.org/drawingml/2006/main">
             <a:r>
               <a:rPr sz="1400"/>
-              <a:t>Uitleg: De teller is het verschil tussen de totale bedragen, de noemer het verschil tussen de hoeveelheden. Δ betekent verandering. Bij een groep van tien gaat het om het gemiddelde extra bedrag per extra beurt binnen die stap. Dit is korte herhaling van §2.1.3 met één echte tabelstap, geen nieuwe theorie. De capaciteit van SkateService is 30 beurten per week.</a:t>
+              <a:t>Uitleg: De extra kosten zijn 10 euro en de extra opbrengst 25 euro voor vijf extra fietsen. Deel elk verschil door ΔQ = 5. In dit voorbeeld blijft MK gelijk door de functie TK = 36 + 2Q. Bij een andere kostentabel bereken je MK opnieuw voor iedere stap; neem niet automatisch een vast bedrag aan.</a:t>
             </a:r>
           </a:p>
           <a:p xmlns:a="http://schemas.openxmlformats.org/drawingml/2006/main">
@@ -3110,7 +3074,7 @@
           <a:p xmlns:a="http://schemas.openxmlformats.org/drawingml/2006/main">
             <a:r>
               <a:rPr sz="1400"/>
-              <a:t>Misvatting: MK is niet TK / Q. Dat laatste is GTK.</a:t>
+              <a:t>Misvatting: MK is ΔTK / ΔQ. GTK is TK / Q. Dat zijn andere vragen.</a:t>
             </a:r>
           </a:p>
           <a:p xmlns:a="http://schemas.openxmlformats.org/drawingml/2006/main">
@@ -3122,7 +3086,7 @@
           <a:p xmlns:a="http://schemas.openxmlformats.org/drawingml/2006/main">
             <a:r>
               <a:rPr sz="1400"/>
-              <a:t>Overgang: Verbind vervolgens totalen met een grafiek.</a:t>
+              <a:t>Overgang: Verbind de eerder berekende totalen met de grafiek.</a:t>
             </a:r>
           </a:p>
           <a:p xmlns:a="http://schemas.openxmlformats.org/drawingml/2006/main">
@@ -3134,19 +3098,7 @@
           <a:p xmlns:a="http://schemas.openxmlformats.org/drawingml/2006/main">
             <a:r>
               <a:rPr sz="1400"/>
-              <a:t>Bron: leerlingenboek Boek 2, chatuitgave 2026, revisie 21 september 2026, gedrukte pagina 31. https://github.com/meijer1973/4veco-lessen/blob/08d7fd27830b5c42d1dbebc7fcb73b882b4d67a4/Boek%202%20-%20Kosten%2C%20opbrengsten%2C%20elasticiteit%20en%20surplus/edities/chat-2026/boek/Boek_2_Compleet.pdf</a:t>
-            </a:r>
-          </a:p>
-          <a:p xmlns:a="http://schemas.openxmlformats.org/drawingml/2006/main">
-            <a:r>
-              <a:rPr sz="1400"/>
-              <a:t>Antwoordmodel: https://github.com/meijer1973/4veco-lessen/blob/08d7fd27830b5c42d1dbebc7fcb73b882b4d67a4/Boek%202%20-%20Kosten%2C%20opbrengsten%2C%20elasticiteit%20en%20surplus/edities/chat-2026/bronnen/H1/2.1%20Kosten%20en%20opbrengsten%20%E2%80%93%20antwoorden.md</a:t>
-            </a:r>
-          </a:p>
-          <a:p xmlns:a="http://schemas.openxmlformats.org/drawingml/2006/main">
-            <a:r>
-              <a:rPr sz="1400"/>
-              <a:t>Docentenroute: https://github.com/meijer1973/4veco-lessen/blob/08d7fd27830b5c42d1dbebc7fcb73b882b4d67a4/Boek%202%20-%20Kosten%2C%20opbrengsten%2C%20elasticiteit%20en%20surplus/edities/chat-2026/bronnen/H1/Docenten_en_bouwverantwoording.md</a:t>
+              <a:t>Bron: Zelfgemaakt uitlegvoorbeeld FietsWas, niet uit het boek. Context en getallen zijn voor deze uitleg gekozen en vormen geen boekopgave of huiswerk. De onderliggende methoden sluiten aan bij Boek 2, chatuitgave 2026, §2.1.1–2.1.3: kostenfuncties, totale/gemiddelde bedragen, break-even en marginale veranderingen. https://github.com/meijer1973/4veco-lessen/blob/08d7fd27830b5c42d1dbebc7fcb73b882b4d67a4/Boek%202%20-%20Kosten%2C%20opbrengsten%2C%20elasticiteit%20en%20surplus/edities/chat-2026/boek/Boek_2_Compleet.pdf</a:t>
             </a:r>
           </a:p>
         </p:txBody>
@@ -3217,7 +3169,7 @@
           <a:p xmlns:a="http://schemas.openxmlformats.org/drawingml/2006/main">
             <a:r>
               <a:rPr sz="1400"/>
-              <a:t>Vraag: Waarom kun je hier geen driehoek als winst inkleuren?</a:t>
+              <a:t>Vraag: Waarom is winst hier een verticale afstand?</a:t>
             </a:r>
           </a:p>
           <a:p xmlns:a="http://schemas.openxmlformats.org/drawingml/2006/main">
@@ -3229,7 +3181,7 @@
           <a:p xmlns:a="http://schemas.openxmlformats.org/drawingml/2006/main">
             <a:r>
               <a:rPr sz="1400"/>
-              <a:t>Uitleg: Dit is de grafiek van FotoFun uit opgave 2 met het verticale antwoordlijnstuk bij Q = 90. De volledige TK-lijn loopt van (0; 240) tot (120; 480), TO van (0; 0) tot (120; 720). De capaciteit is 120 foto’s. Lees bij dezelfde Q twee hoogten: 540 en 420 euro. Hun verschil is 120 euro winst. Dit bereidt de grafiekbewerking van SmoothBox voor.</a:t>
+              <a:t>Uitleg: Het break-evenpunt ligt bij (12; 60). De hulplijnen wijzen naar dezelfde aswaarden. Bij Q = 20 loopt het verticale winstlijnstuk van 76 naar 100 euro per dag: 24 euro. Beide functielijnen stoppen bij de capaciteit van veertig fietsen per dag. De verdere asruimte is voor leesbare labels.</a:t>
             </a:r>
           </a:p>
           <a:p xmlns:a="http://schemas.openxmlformats.org/drawingml/2006/main">
@@ -3241,7 +3193,7 @@
           <a:p xmlns:a="http://schemas.openxmlformats.org/drawingml/2006/main">
             <a:r>
               <a:rPr sz="1400"/>
-              <a:t>Misvatting: De verticale as bevat al totale eurobedragen. Een oppervlakte vermenigvuldigt ook met hoeveelheid.</a:t>
+              <a:t>Misvatting: De verticale as geeft al totale bedragen. Lees twee lijnhoogten bij dezelfde hoeveelheid; een oppervlakte is hier geen winst.</a:t>
             </a:r>
           </a:p>
           <a:p xmlns:a="http://schemas.openxmlformats.org/drawingml/2006/main">
@@ -3253,7 +3205,7 @@
           <a:p xmlns:a="http://schemas.openxmlformats.org/drawingml/2006/main">
             <a:r>
               <a:rPr sz="1400"/>
-              <a:t>Overgang: Laat het overzicht staan tijdens zelfstandig werken.</a:t>
+              <a:t>Overgang: Laat nu het overzicht staan. Leerlingen kiezen en gebruiken de methoden zelf bij de toegewezen boekopgaven.</a:t>
             </a:r>
           </a:p>
           <a:p xmlns:a="http://schemas.openxmlformats.org/drawingml/2006/main">
@@ -3265,19 +3217,7 @@
           <a:p xmlns:a="http://schemas.openxmlformats.org/drawingml/2006/main">
             <a:r>
               <a:rPr sz="1400"/>
-              <a:t>Bron: leerlingenboek Boek 2, chatuitgave 2026, revisie 21 september 2026, gedrukte pagina 30. https://github.com/meijer1973/4veco-lessen/blob/08d7fd27830b5c42d1dbebc7fcb73b882b4d67a4/Boek%202%20-%20Kosten%2C%20opbrengsten%2C%20elasticiteit%20en%20surplus/edities/chat-2026/boek/Boek_2_Compleet.pdf</a:t>
-            </a:r>
-          </a:p>
-          <a:p xmlns:a="http://schemas.openxmlformats.org/drawingml/2006/main">
-            <a:r>
-              <a:rPr sz="1400"/>
-              <a:t>Antwoordmodel: https://github.com/meijer1973/4veco-lessen/blob/08d7fd27830b5c42d1dbebc7fcb73b882b4d67a4/Boek%202%20-%20Kosten%2C%20opbrengsten%2C%20elasticiteit%20en%20surplus/edities/chat-2026/bronnen/H1/2.1%20Kosten%20en%20opbrengsten%20%E2%80%93%20antwoorden.md</a:t>
-            </a:r>
-          </a:p>
-          <a:p xmlns:a="http://schemas.openxmlformats.org/drawingml/2006/main">
-            <a:r>
-              <a:rPr sz="1400"/>
-              <a:t>Docentenroute: https://github.com/meijer1973/4veco-lessen/blob/08d7fd27830b5c42d1dbebc7fcb73b882b4d67a4/Boek%202%20-%20Kosten%2C%20opbrengsten%2C%20elasticiteit%20en%20surplus/edities/chat-2026/bronnen/H1/Docenten_en_bouwverantwoording.md</a:t>
+              <a:t>Bron: Zelfgemaakt uitlegvoorbeeld FietsWas, niet uit het boek. Context en getallen zijn voor deze uitleg gekozen en vormen geen boekopgave of huiswerk. De onderliggende methoden sluiten aan bij Boek 2, chatuitgave 2026, §2.1.1–2.1.3: kostenfuncties, totale/gemiddelde bedragen, break-even en marginale veranderingen. https://github.com/meijer1973/4veco-lessen/blob/08d7fd27830b5c42d1dbebc7fcb73b882b4d67a4/Boek%202%20-%20Kosten%2C%20opbrengsten%2C%20elasticiteit%20en%20surplus/edities/chat-2026/boek/Boek_2_Compleet.pdf</a:t>
             </a:r>
           </a:p>
         </p:txBody>
@@ -3607,7 +3547,7 @@
   </p:cSld>
   <p:clrMap bg1="lt1" tx1="dk1" bg2="lt2" tx2="dk2" accent1="accent1" accent2="accent2" accent3="accent3" accent4="accent4" accent5="accent5" accent6="accent6" hlink="hlink" folHlink="folHlink"/>
   <p:sldLayoutIdLst>
-    <p:sldLayoutId xmlns:r="http://schemas.openxmlformats.org/officeDocument/2006/relationships" id="2147483649" r:id="R12dacd225e4c49b6"/>
+    <p:sldLayoutId xmlns:r="http://schemas.openxmlformats.org/officeDocument/2006/relationships" id="2147483649" r:id="R7d45daaccb8243c4"/>
   </p:sldLayoutIdLst>
   <p:txStyles>
     <p:titleStyle>
@@ -4210,7 +4150,7 @@
                   <c:v>0</c:v>
                 </c:pt>
                 <c:pt idx="1">
-                  <c:v>120</c:v>
+                  <c:v>40</c:v>
                 </c:pt>
               </c:numCache>
             </c:numRef>
@@ -4225,7 +4165,7 @@
                   <c:v>0</c:v>
                 </c:pt>
                 <c:pt idx="1">
-                  <c:v>720</c:v>
+                  <c:v>200</c:v>
                 </c:pt>
               </c:numCache>
             </c:numRef>
@@ -4300,7 +4240,7 @@
                   <c:v>0</c:v>
                 </c:pt>
                 <c:pt idx="1">
-                  <c:v>120</c:v>
+                  <c:v>40</c:v>
                 </c:pt>
               </c:numCache>
             </c:numRef>
@@ -4312,10 +4252,10 @@
                 <c:formatCode>#,##0</c:formatCode>
                 <c:ptCount val="2"/>
                 <c:pt idx="0">
-                  <c:v>240</c:v>
+                  <c:v>36</c:v>
                 </c:pt>
                 <c:pt idx="1">
-                  <c:v>480</c:v>
+                  <c:v>116</c:v>
                 </c:pt>
               </c:numCache>
             </c:numRef>
@@ -4324,6 +4264,162 @@
         <c:ser>
           <c:idx val="2"/>
           <c:order val="2"/>
+          <c:tx>
+            <c:v>Break-even</c:v>
+          </c:tx>
+          <c:spPr>
+            <a:ln xmlns:a="http://schemas.openxmlformats.org/drawingml/2006/main" w="0">
+              <a:solidFill>
+                <a:srgbClr val="183247"/>
+              </a:solidFill>
+              <a:prstDash val="solid"/>
+            </a:ln>
+          </c:spPr>
+          <c:marker>
+            <c:symbol val="diamond"/>
+            <c:size val="9"/>
+            <c:spPr>
+              <a:solidFill xmlns:a="http://schemas.openxmlformats.org/drawingml/2006/main">
+                <a:srgbClr val="183247"/>
+              </a:solidFill>
+            </c:spPr>
+          </c:marker>
+          <c:xVal>
+            <c:numRef>
+              <c:f>'Chart Data'!$E$2:$E$2</c:f>
+              <c:numCache>
+                <c:formatCode>General</c:formatCode>
+                <c:ptCount val="1"/>
+                <c:pt idx="0">
+                  <c:v>12</c:v>
+                </c:pt>
+              </c:numCache>
+            </c:numRef>
+          </c:xVal>
+          <c:yVal>
+            <c:numRef>
+              <c:f>'Chart Data'!$F$2:$F$2</c:f>
+              <c:numCache>
+                <c:formatCode>#,##0</c:formatCode>
+                <c:ptCount val="1"/>
+                <c:pt idx="0">
+                  <c:v>60</c:v>
+                </c:pt>
+              </c:numCache>
+            </c:numRef>
+          </c:yVal>
+        </c:ser>
+        <c:ser>
+          <c:idx val="3"/>
+          <c:order val="3"/>
+          <c:tx>
+            <c:v>Hulplijn Q</c:v>
+          </c:tx>
+          <c:spPr>
+            <a:ln xmlns:a="http://schemas.openxmlformats.org/drawingml/2006/main" w="19050">
+              <a:solidFill>
+                <a:srgbClr val="445B6B"/>
+              </a:solidFill>
+              <a:prstDash val="dash"/>
+            </a:ln>
+          </c:spPr>
+          <c:marker>
+            <c:symbol val="none"/>
+            <c:size val="9"/>
+            <c:spPr>
+              <a:solidFill xmlns:a="http://schemas.openxmlformats.org/drawingml/2006/main">
+                <a:srgbClr val="445B6B"/>
+              </a:solidFill>
+            </c:spPr>
+          </c:marker>
+          <c:xVal>
+            <c:numRef>
+              <c:f>'Chart Data'!$G$2:$G$3</c:f>
+              <c:numCache>
+                <c:formatCode>General</c:formatCode>
+                <c:ptCount val="2"/>
+                <c:pt idx="0">
+                  <c:v>12</c:v>
+                </c:pt>
+                <c:pt idx="1">
+                  <c:v>12</c:v>
+                </c:pt>
+              </c:numCache>
+            </c:numRef>
+          </c:xVal>
+          <c:yVal>
+            <c:numRef>
+              <c:f>'Chart Data'!$H$2:$H$3</c:f>
+              <c:numCache>
+                <c:formatCode>#,##0</c:formatCode>
+                <c:ptCount val="2"/>
+                <c:pt idx="0">
+                  <c:v>0</c:v>
+                </c:pt>
+                <c:pt idx="1">
+                  <c:v>60</c:v>
+                </c:pt>
+              </c:numCache>
+            </c:numRef>
+          </c:yVal>
+        </c:ser>
+        <c:ser>
+          <c:idx val="4"/>
+          <c:order val="4"/>
+          <c:tx>
+            <c:v>Hulplijn bedrag</c:v>
+          </c:tx>
+          <c:spPr>
+            <a:ln xmlns:a="http://schemas.openxmlformats.org/drawingml/2006/main" w="19050">
+              <a:solidFill>
+                <a:srgbClr val="445B6B"/>
+              </a:solidFill>
+              <a:prstDash val="dash"/>
+            </a:ln>
+          </c:spPr>
+          <c:marker>
+            <c:symbol val="none"/>
+            <c:size val="9"/>
+            <c:spPr>
+              <a:solidFill xmlns:a="http://schemas.openxmlformats.org/drawingml/2006/main">
+                <a:srgbClr val="445B6B"/>
+              </a:solidFill>
+            </c:spPr>
+          </c:marker>
+          <c:xVal>
+            <c:numRef>
+              <c:f>'Chart Data'!$I$2:$I$3</c:f>
+              <c:numCache>
+                <c:formatCode>General</c:formatCode>
+                <c:ptCount val="2"/>
+                <c:pt idx="0">
+                  <c:v>0</c:v>
+                </c:pt>
+                <c:pt idx="1">
+                  <c:v>12</c:v>
+                </c:pt>
+              </c:numCache>
+            </c:numRef>
+          </c:xVal>
+          <c:yVal>
+            <c:numRef>
+              <c:f>'Chart Data'!$J$2:$J$3</c:f>
+              <c:numCache>
+                <c:formatCode>#,##0</c:formatCode>
+                <c:ptCount val="2"/>
+                <c:pt idx="0">
+                  <c:v>60</c:v>
+                </c:pt>
+                <c:pt idx="1">
+                  <c:v>60</c:v>
+                </c:pt>
+              </c:numCache>
+            </c:numRef>
+          </c:yVal>
+        </c:ser>
+        <c:ser>
+          <c:idx val="5"/>
+          <c:order val="5"/>
           <c:tx>
             <c:v>Winstafstand</c:v>
           </c:tx>
@@ -4346,30 +4442,30 @@
           </c:marker>
           <c:xVal>
             <c:numRef>
-              <c:f>'Chart Data'!$E$2:$E$3</c:f>
+              <c:f>'Chart Data'!$K$2:$K$3</c:f>
               <c:numCache>
                 <c:formatCode>General</c:formatCode>
                 <c:ptCount val="2"/>
                 <c:pt idx="0">
-                  <c:v>90</c:v>
+                  <c:v>20</c:v>
                 </c:pt>
                 <c:pt idx="1">
-                  <c:v>90</c:v>
+                  <c:v>20</c:v>
                 </c:pt>
               </c:numCache>
             </c:numRef>
           </c:xVal>
           <c:yVal>
             <c:numRef>
-              <c:f>'Chart Data'!$F$2:$F$3</c:f>
+              <c:f>'Chart Data'!$L$2:$L$3</c:f>
               <c:numCache>
                 <c:formatCode>#,##0</c:formatCode>
                 <c:ptCount val="2"/>
                 <c:pt idx="0">
-                  <c:v>420</c:v>
+                  <c:v>76</c:v>
                 </c:pt>
                 <c:pt idx="1">
-                  <c:v>540</c:v>
+                  <c:v>100</c:v>
                 </c:pt>
               </c:numCache>
             </c:numRef>
@@ -4404,7 +4500,7 @@
         <c:axId val="48672768"/>
         <c:scaling>
           <c:orientation val="minMax"/>
-          <c:max val="800"/>
+          <c:max val="220"/>
           <c:min val="0"/>
         </c:scaling>
         <c:delete val="0"/>
@@ -4433,7 +4529,7 @@
                     <a:ea typeface="Arial"/>
                     <a:cs typeface="Arial"/>
                   </a:rPr>
-                  <a:t>TO en TK (€ per feest)</a:t>
+                  <a:t>TO en TK (€ per dag)</a:t>
                 </a:r>
               </a:p>
             </c:rich>
@@ -4483,13 +4579,13 @@
           </a:p>
         </c:txPr>
         <c:crossAx val="48650112"/>
-        <c:majorUnit val="200"/>
+        <c:majorUnit val="40"/>
       </c:valAx>
       <c:valAx>
         <c:axId val="48650112"/>
         <c:scaling>
           <c:orientation val="minMax"/>
-          <c:max val="150"/>
+          <c:max val="50"/>
           <c:min val="0"/>
         </c:scaling>
         <c:delete val="0"/>
@@ -4509,7 +4605,7 @@
                     <a:ea typeface="Arial"/>
                     <a:cs typeface="Arial"/>
                   </a:rPr>
-                  <a:t>Q (foto’s per feest)</a:t>
+                  <a:t>Q (fietsen per dag)</a:t>
                 </a:r>
               </a:p>
             </c:rich>
@@ -4559,7 +4655,7 @@
           </a:p>
         </c:txPr>
         <c:crossAx val="48672768"/>
-        <c:majorUnit val="30"/>
+        <c:majorUnit val="10"/>
       </c:valAx>
       <c:spPr>
         <a:solidFill xmlns:a="http://schemas.openxmlformats.org/drawingml/2006/main">
@@ -6476,7 +6572,7 @@
           <p:cNvPr id="29" name="Deze les: §2.1.4 Gemengde opgaven">
             <a:extLst xmlns:a="http://schemas.openxmlformats.org/drawingml/2006/main">
               <a:ext uri="{FF2B5EF4-FFF2-40B4-BE49-F238E27FC236}">
-                <a16:creationId xmlns:a16="http://schemas.microsoft.com/office/drawing/2014/main" id="{4E9982B4-C6C7-49C9-9011-DCCB0175613D}"/>
+                <a16:creationId xmlns:a16="http://schemas.microsoft.com/office/drawing/2014/main" id="{72A1D38C-B3FF-4F64-AAB5-F8CBA0C99A69}"/>
               </a:ext>
             </a:extLst>
           </p:cNvPr>
@@ -6533,7 +6629,7 @@
           <p:cNvPr id="2" name="">
             <a:extLst xmlns:a="http://schemas.openxmlformats.org/drawingml/2006/main">
               <a:ext uri="{FF2B5EF4-FFF2-40B4-BE49-F238E27FC236}">
-                <a16:creationId xmlns:a16="http://schemas.microsoft.com/office/drawing/2014/main" id="{359FAB36-2DE1-4A6E-BE13-88CDDB3532C4}"/>
+                <a16:creationId xmlns:a16="http://schemas.microsoft.com/office/drawing/2014/main" id="{B0EC3F88-F20D-4920-ACBF-422FE0FE532E}"/>
               </a:ext>
             </a:extLst>
           </p:cNvPr>
@@ -6562,7 +6658,7 @@
           <p:cNvPr id="3" name="§2.1.4 Gemengde opgaven">
             <a:extLst xmlns:a="http://schemas.openxmlformats.org/drawingml/2006/main">
               <a:ext uri="{FF2B5EF4-FFF2-40B4-BE49-F238E27FC236}">
-                <a16:creationId xmlns:a16="http://schemas.microsoft.com/office/drawing/2014/main" id="{EC7ABA3C-46E1-4761-ACCD-EB42784DB35E}"/>
+                <a16:creationId xmlns:a16="http://schemas.microsoft.com/office/drawing/2014/main" id="{BC0DB0D8-45A5-481B-8704-3FB29CF9B8A0}"/>
               </a:ext>
             </a:extLst>
           </p:cNvPr>
@@ -6619,7 +6715,7 @@
           <p:cNvPr id="4" name="slide-number">
             <a:extLst xmlns:a="http://schemas.openxmlformats.org/drawingml/2006/main">
               <a:ext uri="{FF2B5EF4-FFF2-40B4-BE49-F238E27FC236}">
-                <a16:creationId xmlns:a16="http://schemas.microsoft.com/office/drawing/2014/main" id="{30392EE1-FB8C-4CC4-883B-27241F21A756}"/>
+                <a16:creationId xmlns:a16="http://schemas.microsoft.com/office/drawing/2014/main" id="{81565F62-B731-4ADF-B3D7-AAFB4C8E2051}"/>
               </a:ext>
             </a:extLst>
           </p:cNvPr>
@@ -6676,7 +6772,7 @@
           <p:cNvPr id="5" name="phase">
             <a:extLst xmlns:a="http://schemas.openxmlformats.org/drawingml/2006/main">
               <a:ext uri="{FF2B5EF4-FFF2-40B4-BE49-F238E27FC236}">
-                <a16:creationId xmlns:a16="http://schemas.microsoft.com/office/drawing/2014/main" id="{ECFD8657-A0CC-45EC-9A37-1D611EE922D1}"/>
+                <a16:creationId xmlns:a16="http://schemas.microsoft.com/office/drawing/2014/main" id="{96FCD981-45D0-463E-B687-4DADDEF41F3C}"/>
               </a:ext>
             </a:extLst>
           </p:cNvPr>
@@ -6733,7 +6829,7 @@
           <p:cNvPr id="6" name="Lesroute">
             <a:extLst xmlns:a="http://schemas.openxmlformats.org/drawingml/2006/main">
               <a:ext uri="{FF2B5EF4-FFF2-40B4-BE49-F238E27FC236}">
-                <a16:creationId xmlns:a16="http://schemas.microsoft.com/office/drawing/2014/main" id="{D39358AE-3652-4C1C-ACC0-E09B2F4B5EB3}"/>
+                <a16:creationId xmlns:a16="http://schemas.microsoft.com/office/drawing/2014/main" id="{013D681A-BDC6-4F05-8B52-C028B14A7F7E}"/>
               </a:ext>
             </a:extLst>
           </p:cNvPr>
@@ -6790,7 +6886,7 @@
           <p:cNvPr id="7" name="route-number-1">
             <a:extLst xmlns:a="http://schemas.openxmlformats.org/drawingml/2006/main">
               <a:ext uri="{FF2B5EF4-FFF2-40B4-BE49-F238E27FC236}">
-                <a16:creationId xmlns:a16="http://schemas.microsoft.com/office/drawing/2014/main" id="{485A78A7-523E-49C9-AB09-36888549235F}"/>
+                <a16:creationId xmlns:a16="http://schemas.microsoft.com/office/drawing/2014/main" id="{7B5BA49E-614C-41AD-B0B2-404725261BBC}"/>
               </a:ext>
             </a:extLst>
           </p:cNvPr>
@@ -6847,7 +6943,7 @@
           <p:cNvPr id="8" name="route-1">
             <a:extLst xmlns:a="http://schemas.openxmlformats.org/drawingml/2006/main">
               <a:ext uri="{FF2B5EF4-FFF2-40B4-BE49-F238E27FC236}">
-                <a16:creationId xmlns:a16="http://schemas.microsoft.com/office/drawing/2014/main" id="{92412A59-8BD7-474F-B74D-15FF3235BD2B}"/>
+                <a16:creationId xmlns:a16="http://schemas.microsoft.com/office/drawing/2014/main" id="{9B22F823-BCF4-493A-9C72-F363790EC78C}"/>
               </a:ext>
             </a:extLst>
           </p:cNvPr>
@@ -6904,7 +7000,7 @@
           <p:cNvPr id="9" name="route-number-2">
             <a:extLst xmlns:a="http://schemas.openxmlformats.org/drawingml/2006/main">
               <a:ext uri="{FF2B5EF4-FFF2-40B4-BE49-F238E27FC236}">
-                <a16:creationId xmlns:a16="http://schemas.microsoft.com/office/drawing/2014/main" id="{DD29F55F-666A-44E7-925B-79649F71AB5E}"/>
+                <a16:creationId xmlns:a16="http://schemas.microsoft.com/office/drawing/2014/main" id="{7C275BE4-C272-4513-8588-6DC01E73BCF1}"/>
               </a:ext>
             </a:extLst>
           </p:cNvPr>
@@ -6961,7 +7057,7 @@
           <p:cNvPr id="10" name="route-2">
             <a:extLst xmlns:a="http://schemas.openxmlformats.org/drawingml/2006/main">
               <a:ext uri="{FF2B5EF4-FFF2-40B4-BE49-F238E27FC236}">
-                <a16:creationId xmlns:a16="http://schemas.microsoft.com/office/drawing/2014/main" id="{BFB2EDC5-9A8D-4BB4-8100-7F424F03343F}"/>
+                <a16:creationId xmlns:a16="http://schemas.microsoft.com/office/drawing/2014/main" id="{FCB4FFAC-DD8E-41A2-BD5C-B2CDFA896775}"/>
               </a:ext>
             </a:extLst>
           </p:cNvPr>
@@ -7018,7 +7114,7 @@
           <p:cNvPr id="11" name="route-number-3">
             <a:extLst xmlns:a="http://schemas.openxmlformats.org/drawingml/2006/main">
               <a:ext uri="{FF2B5EF4-FFF2-40B4-BE49-F238E27FC236}">
-                <a16:creationId xmlns:a16="http://schemas.microsoft.com/office/drawing/2014/main" id="{651FFA1D-075F-4E9A-81EE-7A5B290149EE}"/>
+                <a16:creationId xmlns:a16="http://schemas.microsoft.com/office/drawing/2014/main" id="{E88BA9E1-8263-41C7-9E8B-8512A3CBDD38}"/>
               </a:ext>
             </a:extLst>
           </p:cNvPr>
@@ -7075,7 +7171,7 @@
           <p:cNvPr id="12" name="route-3">
             <a:extLst xmlns:a="http://schemas.openxmlformats.org/drawingml/2006/main">
               <a:ext uri="{FF2B5EF4-FFF2-40B4-BE49-F238E27FC236}">
-                <a16:creationId xmlns:a16="http://schemas.microsoft.com/office/drawing/2014/main" id="{D4031F1B-4351-46AA-9E61-805822637225}"/>
+                <a16:creationId xmlns:a16="http://schemas.microsoft.com/office/drawing/2014/main" id="{578D0313-DEFD-4067-AD3B-DBA4B4CDB731}"/>
               </a:ext>
             </a:extLst>
           </p:cNvPr>
@@ -7132,7 +7228,7 @@
           <p:cNvPr id="13" name="route-number-4">
             <a:extLst xmlns:a="http://schemas.openxmlformats.org/drawingml/2006/main">
               <a:ext uri="{FF2B5EF4-FFF2-40B4-BE49-F238E27FC236}">
-                <a16:creationId xmlns:a16="http://schemas.microsoft.com/office/drawing/2014/main" id="{1DD3E0F8-F08C-4995-9436-711D93FFBFDE}"/>
+                <a16:creationId xmlns:a16="http://schemas.microsoft.com/office/drawing/2014/main" id="{F7924C07-92B2-49E5-9CB2-E5FF714F0DEE}"/>
               </a:ext>
             </a:extLst>
           </p:cNvPr>
@@ -7189,7 +7285,7 @@
           <p:cNvPr id="14" name="route-4">
             <a:extLst xmlns:a="http://schemas.openxmlformats.org/drawingml/2006/main">
               <a:ext uri="{FF2B5EF4-FFF2-40B4-BE49-F238E27FC236}">
-                <a16:creationId xmlns:a16="http://schemas.microsoft.com/office/drawing/2014/main" id="{4EFE5F5B-ED53-446B-A62B-6D3D5B3184D0}"/>
+                <a16:creationId xmlns:a16="http://schemas.microsoft.com/office/drawing/2014/main" id="{8CB1A4C8-BBDD-4CB0-B313-31A88A5E71FD}"/>
               </a:ext>
             </a:extLst>
           </p:cNvPr>
@@ -7246,7 +7342,7 @@
           <p:cNvPr id="15" name="route-number-5">
             <a:extLst xmlns:a="http://schemas.openxmlformats.org/drawingml/2006/main">
               <a:ext uri="{FF2B5EF4-FFF2-40B4-BE49-F238E27FC236}">
-                <a16:creationId xmlns:a16="http://schemas.microsoft.com/office/drawing/2014/main" id="{74C2F8C1-23F3-4D5B-9AE9-A99CF1122188}"/>
+                <a16:creationId xmlns:a16="http://schemas.microsoft.com/office/drawing/2014/main" id="{D7FC547F-66E9-4D01-92BE-71BB04F8AD00}"/>
               </a:ext>
             </a:extLst>
           </p:cNvPr>
@@ -7303,7 +7399,7 @@
           <p:cNvPr id="16" name="route-5">
             <a:extLst xmlns:a="http://schemas.openxmlformats.org/drawingml/2006/main">
               <a:ext uri="{FF2B5EF4-FFF2-40B4-BE49-F238E27FC236}">
-                <a16:creationId xmlns:a16="http://schemas.microsoft.com/office/drawing/2014/main" id="{8E5C68AF-4CCA-46A7-81AF-0C6A2FBBB583}"/>
+                <a16:creationId xmlns:a16="http://schemas.microsoft.com/office/drawing/2014/main" id="{8CC3380F-3294-4BD1-901C-10CBF0D32193}"/>
               </a:ext>
             </a:extLst>
           </p:cNvPr>
@@ -7360,7 +7456,7 @@
           <p:cNvPr id="17" name="route-number-6">
             <a:extLst xmlns:a="http://schemas.openxmlformats.org/drawingml/2006/main">
               <a:ext uri="{FF2B5EF4-FFF2-40B4-BE49-F238E27FC236}">
-                <a16:creationId xmlns:a16="http://schemas.microsoft.com/office/drawing/2014/main" id="{8623B76A-4F0B-4C83-AB12-DD8AFC6FAE5B}"/>
+                <a16:creationId xmlns:a16="http://schemas.microsoft.com/office/drawing/2014/main" id="{1EEC6CBD-D2B6-4A3B-BD3B-2873EC968803}"/>
               </a:ext>
             </a:extLst>
           </p:cNvPr>
@@ -7417,7 +7513,7 @@
           <p:cNvPr id="18" name="route-6">
             <a:extLst xmlns:a="http://schemas.openxmlformats.org/drawingml/2006/main">
               <a:ext uri="{FF2B5EF4-FFF2-40B4-BE49-F238E27FC236}">
-                <a16:creationId xmlns:a16="http://schemas.microsoft.com/office/drawing/2014/main" id="{45834228-CAC9-4D81-B602-A49D4608DAAC}"/>
+                <a16:creationId xmlns:a16="http://schemas.microsoft.com/office/drawing/2014/main" id="{CBAB530A-7704-4BCD-AD21-91A0256ECF76}"/>
               </a:ext>
             </a:extLst>
           </p:cNvPr>
@@ -7474,7 +7570,7 @@
           <p:cNvPr id="19" name="route-number-7">
             <a:extLst xmlns:a="http://schemas.openxmlformats.org/drawingml/2006/main">
               <a:ext uri="{FF2B5EF4-FFF2-40B4-BE49-F238E27FC236}">
-                <a16:creationId xmlns:a16="http://schemas.microsoft.com/office/drawing/2014/main" id="{62EA6A57-B8C6-4A08-AE2A-529C068B95E8}"/>
+                <a16:creationId xmlns:a16="http://schemas.microsoft.com/office/drawing/2014/main" id="{AF6DF4AE-F84E-4292-B4E0-1541B6731C9E}"/>
               </a:ext>
             </a:extLst>
           </p:cNvPr>
@@ -7531,7 +7627,7 @@
           <p:cNvPr id="20" name="route-7">
             <a:extLst xmlns:a="http://schemas.openxmlformats.org/drawingml/2006/main">
               <a:ext uri="{FF2B5EF4-FFF2-40B4-BE49-F238E27FC236}">
-                <a16:creationId xmlns:a16="http://schemas.microsoft.com/office/drawing/2014/main" id="{98F69E05-78E1-4606-8B12-1767377F68CE}"/>
+                <a16:creationId xmlns:a16="http://schemas.microsoft.com/office/drawing/2014/main" id="{3174D751-7219-4FCA-8E92-1AB3F858C61C}"/>
               </a:ext>
             </a:extLst>
           </p:cNvPr>
@@ -7588,7 +7684,7 @@
           <p:cNvPr id="21" name="Lesdoelen">
             <a:extLst xmlns:a="http://schemas.openxmlformats.org/drawingml/2006/main">
               <a:ext uri="{FF2B5EF4-FFF2-40B4-BE49-F238E27FC236}">
-                <a16:creationId xmlns:a16="http://schemas.microsoft.com/office/drawing/2014/main" id="{CF27FB1B-C22D-49B0-A291-EE48D065123D}"/>
+                <a16:creationId xmlns:a16="http://schemas.microsoft.com/office/drawing/2014/main" id="{6C4FC1F6-123E-4678-BCDE-C2D7EAC7B809}"/>
               </a:ext>
             </a:extLst>
           </p:cNvPr>
@@ -7645,7 +7741,7 @@
           <p:cNvPr id="22" name="overview-goals">
             <a:extLst xmlns:a="http://schemas.openxmlformats.org/drawingml/2006/main">
               <a:ext uri="{FF2B5EF4-FFF2-40B4-BE49-F238E27FC236}">
-                <a16:creationId xmlns:a16="http://schemas.microsoft.com/office/drawing/2014/main" id="{7315D047-D869-45FE-A89A-1674630395FC}"/>
+                <a16:creationId xmlns:a16="http://schemas.microsoft.com/office/drawing/2014/main" id="{9FD67723-67D6-40D1-AB29-C8B6B51337DA}"/>
               </a:ext>
             </a:extLst>
           </p:cNvPr>
@@ -7748,7 +7844,7 @@
           <p:cNvPr id="23" name="">
             <a:extLst xmlns:a="http://schemas.openxmlformats.org/drawingml/2006/main">
               <a:ext uri="{FF2B5EF4-FFF2-40B4-BE49-F238E27FC236}">
-                <a16:creationId xmlns:a16="http://schemas.microsoft.com/office/drawing/2014/main" id="{DDA9B3FA-2F2E-45AB-BA04-98FDAF7AB485}"/>
+                <a16:creationId xmlns:a16="http://schemas.microsoft.com/office/drawing/2014/main" id="{E8D553D9-F1D3-4968-A8DE-52C138DA5CC7}"/>
               </a:ext>
             </a:extLst>
           </p:cNvPr>
@@ -7777,7 +7873,7 @@
           <p:cNvPr id="24" name="Startopdracht">
             <a:extLst xmlns:a="http://schemas.openxmlformats.org/drawingml/2006/main">
               <a:ext uri="{FF2B5EF4-FFF2-40B4-BE49-F238E27FC236}">
-                <a16:creationId xmlns:a16="http://schemas.microsoft.com/office/drawing/2014/main" id="{B908EEAE-551F-4ACE-8E97-B48C10B1DFD0}"/>
+                <a16:creationId xmlns:a16="http://schemas.microsoft.com/office/drawing/2014/main" id="{ECFF315E-CB1C-4F53-A3FA-F4E138005A05}"/>
               </a:ext>
             </a:extLst>
           </p:cNvPr>
@@ -7834,7 +7930,7 @@
           <p:cNvPr id="25" name="overview-start">
             <a:extLst xmlns:a="http://schemas.openxmlformats.org/drawingml/2006/main">
               <a:ext uri="{FF2B5EF4-FFF2-40B4-BE49-F238E27FC236}">
-                <a16:creationId xmlns:a16="http://schemas.microsoft.com/office/drawing/2014/main" id="{70880168-E3E9-4D76-A76C-C55427CF16C0}"/>
+                <a16:creationId xmlns:a16="http://schemas.microsoft.com/office/drawing/2014/main" id="{3C553764-B12D-4463-B125-0727F6714C0E}"/>
               </a:ext>
             </a:extLst>
           </p:cNvPr>
@@ -7914,7 +8010,7 @@
           <p:cNvPr id="26" name="">
             <a:extLst xmlns:a="http://schemas.openxmlformats.org/drawingml/2006/main">
               <a:ext uri="{FF2B5EF4-FFF2-40B4-BE49-F238E27FC236}">
-                <a16:creationId xmlns:a16="http://schemas.microsoft.com/office/drawing/2014/main" id="{AFE57552-A7B2-4DA0-9C7E-3E8D72294F0C}"/>
+                <a16:creationId xmlns:a16="http://schemas.microsoft.com/office/drawing/2014/main" id="{47B164D3-FF5F-442A-937C-387C365DFAC8}"/>
               </a:ext>
             </a:extLst>
           </p:cNvPr>
@@ -7943,7 +8039,7 @@
           <p:cNvPr id="27" name="Huiswerk">
             <a:extLst xmlns:a="http://schemas.openxmlformats.org/drawingml/2006/main">
               <a:ext uri="{FF2B5EF4-FFF2-40B4-BE49-F238E27FC236}">
-                <a16:creationId xmlns:a16="http://schemas.microsoft.com/office/drawing/2014/main" id="{D6487D24-2F55-415B-AEF1-F520F126E8A4}"/>
+                <a16:creationId xmlns:a16="http://schemas.microsoft.com/office/drawing/2014/main" id="{DFEA7990-D2E7-4D0F-84F0-8AE6C9EFC878}"/>
               </a:ext>
             </a:extLst>
           </p:cNvPr>
@@ -8000,7 +8096,7 @@
           <p:cNvPr id="28" name="overview-homework">
             <a:extLst xmlns:a="http://schemas.openxmlformats.org/drawingml/2006/main">
               <a:ext uri="{FF2B5EF4-FFF2-40B4-BE49-F238E27FC236}">
-                <a16:creationId xmlns:a16="http://schemas.microsoft.com/office/drawing/2014/main" id="{E0716F66-205A-4832-BD21-BAA03038479A}"/>
+                <a16:creationId xmlns:a16="http://schemas.microsoft.com/office/drawing/2014/main" id="{0C7D6C4C-680F-4C62-904C-E8B3C325E4B0}"/>
               </a:ext>
             </a:extLst>
           </p:cNvPr>
@@ -8147,7 +8243,7 @@
     </p:spTree>
     <p:extLst>
       <p:ext uri="{BB962C8B-B14F-4D97-AF65-F5344CB8AC3E}">
-        <p14:creationId xmlns:p14="http://schemas.microsoft.com/office/powerpoint/2010/main" val="724293105"/>
+        <p14:creationId xmlns:p14="http://schemas.microsoft.com/office/powerpoint/2010/main" val="1862282736"/>
       </p:ext>
     </p:extLst>
   </p:cSld>
@@ -8178,7 +8274,7 @@
           <p:cNvPr id="9" name="Opgave 5 · Bron B: zaterdag">
             <a:extLst xmlns:a="http://schemas.openxmlformats.org/drawingml/2006/main">
               <a:ext uri="{FF2B5EF4-FFF2-40B4-BE49-F238E27FC236}">
-                <a16:creationId xmlns:a16="http://schemas.microsoft.com/office/drawing/2014/main" id="{2609EAAE-57F2-4573-987B-3F7388FA8A99}"/>
+                <a16:creationId xmlns:a16="http://schemas.microsoft.com/office/drawing/2014/main" id="{173F48D0-5C7D-4745-BED1-7037B33B1AFD}"/>
               </a:ext>
             </a:extLst>
           </p:cNvPr>
@@ -8235,7 +8331,7 @@
           <p:cNvPr id="2" name="">
             <a:extLst xmlns:a="http://schemas.openxmlformats.org/drawingml/2006/main">
               <a:ext uri="{FF2B5EF4-FFF2-40B4-BE49-F238E27FC236}">
-                <a16:creationId xmlns:a16="http://schemas.microsoft.com/office/drawing/2014/main" id="{598E4208-3445-450E-80A1-037B9DE17367}"/>
+                <a16:creationId xmlns:a16="http://schemas.microsoft.com/office/drawing/2014/main" id="{272610D8-A996-4206-B8DA-3F65DA09C008}"/>
               </a:ext>
             </a:extLst>
           </p:cNvPr>
@@ -8264,7 +8360,7 @@
           <p:cNvPr id="3" name="§2.1.4 Gemengde opgaven · Opgave 5 · Boekpagina 32–33">
             <a:extLst xmlns:a="http://schemas.openxmlformats.org/drawingml/2006/main">
               <a:ext uri="{FF2B5EF4-FFF2-40B4-BE49-F238E27FC236}">
-                <a16:creationId xmlns:a16="http://schemas.microsoft.com/office/drawing/2014/main" id="{3B043C7F-081F-49B2-BDF6-852F20D8B377}"/>
+                <a16:creationId xmlns:a16="http://schemas.microsoft.com/office/drawing/2014/main" id="{D32A7B48-141D-46F8-AC3E-AB745CC79B8F}"/>
               </a:ext>
             </a:extLst>
           </p:cNvPr>
@@ -8321,7 +8417,7 @@
           <p:cNvPr id="4" name="slide-number">
             <a:extLst xmlns:a="http://schemas.openxmlformats.org/drawingml/2006/main">
               <a:ext uri="{FF2B5EF4-FFF2-40B4-BE49-F238E27FC236}">
-                <a16:creationId xmlns:a16="http://schemas.microsoft.com/office/drawing/2014/main" id="{B245A0C5-B8FE-467A-BF39-F4A88B138F00}"/>
+                <a16:creationId xmlns:a16="http://schemas.microsoft.com/office/drawing/2014/main" id="{1FB81E08-B9E5-447D-B4E1-4C3399D33F09}"/>
               </a:ext>
             </a:extLst>
           </p:cNvPr>
@@ -8378,7 +8474,7 @@
           <p:cNvPr id="5" name="Een ander menu · Constante kosten: € 1.200 per dag">
             <a:extLst xmlns:a="http://schemas.openxmlformats.org/drawingml/2006/main">
               <a:ext uri="{FF2B5EF4-FFF2-40B4-BE49-F238E27FC236}">
-                <a16:creationId xmlns:a16="http://schemas.microsoft.com/office/drawing/2014/main" id="{CD9C098A-86C9-4982-8537-FBD0BB0DC21A}"/>
+                <a16:creationId xmlns:a16="http://schemas.microsoft.com/office/drawing/2014/main" id="{1C490873-FA77-4408-9903-924C852F4146}"/>
               </a:ext>
             </a:extLst>
           </p:cNvPr>
@@ -8435,7 +8531,7 @@
           <p:cNvPr id="6" name="Meer productie vraagt steeds meer betaald werk per extra lun">
             <a:extLst xmlns:a="http://schemas.openxmlformats.org/drawingml/2006/main">
               <a:ext uri="{FF2B5EF4-FFF2-40B4-BE49-F238E27FC236}">
-                <a16:creationId xmlns:a16="http://schemas.microsoft.com/office/drawing/2014/main" id="{A82C85D6-EE82-44D2-ACAF-A9A12BC63359}"/>
+                <a16:creationId xmlns:a16="http://schemas.microsoft.com/office/drawing/2014/main" id="{074C9412-B09C-4782-B3CE-71AAAC46F6CD}"/>
               </a:ext>
             </a:extLst>
           </p:cNvPr>
@@ -8885,7 +8981,7 @@
           <p:cNvPr id="8" name="Gebruik voor zaterdag deze totalen, niet de € 2 uit bron A.">
             <a:extLst xmlns:a="http://schemas.openxmlformats.org/drawingml/2006/main">
               <a:ext uri="{FF2B5EF4-FFF2-40B4-BE49-F238E27FC236}">
-                <a16:creationId xmlns:a16="http://schemas.microsoft.com/office/drawing/2014/main" id="{9A0D3871-B3C9-45B0-8741-DBC90B5C063F}"/>
+                <a16:creationId xmlns:a16="http://schemas.microsoft.com/office/drawing/2014/main" id="{8CEFE1C6-F569-469A-8855-2D3EF1473C8D}"/>
               </a:ext>
             </a:extLst>
           </p:cNvPr>
@@ -8940,7 +9036,7 @@
     </p:spTree>
     <p:extLst>
       <p:ext uri="{BB962C8B-B14F-4D97-AF65-F5344CB8AC3E}">
-        <p14:creationId xmlns:p14="http://schemas.microsoft.com/office/powerpoint/2010/main" val="1601444687"/>
+        <p14:creationId xmlns:p14="http://schemas.microsoft.com/office/powerpoint/2010/main" val="1577463876"/>
       </p:ext>
     </p:extLst>
   </p:cSld>
@@ -8971,7 +9067,7 @@
           <p:cNvPr id="9" name="Opgave 5 · Bron C: basisgrafiek">
             <a:extLst xmlns:a="http://schemas.openxmlformats.org/drawingml/2006/main">
               <a:ext uri="{FF2B5EF4-FFF2-40B4-BE49-F238E27FC236}">
-                <a16:creationId xmlns:a16="http://schemas.microsoft.com/office/drawing/2014/main" id="{3BB87475-865D-48F8-9725-96E9247BC75C}"/>
+                <a16:creationId xmlns:a16="http://schemas.microsoft.com/office/drawing/2014/main" id="{6B2509CA-931A-4F66-8402-63B81BB69B22}"/>
               </a:ext>
             </a:extLst>
           </p:cNvPr>
@@ -9028,7 +9124,7 @@
           <p:cNvPr id="2" name="">
             <a:extLst xmlns:a="http://schemas.openxmlformats.org/drawingml/2006/main">
               <a:ext uri="{FF2B5EF4-FFF2-40B4-BE49-F238E27FC236}">
-                <a16:creationId xmlns:a16="http://schemas.microsoft.com/office/drawing/2014/main" id="{559ED423-EB7E-4DDC-95A2-3FEDEBC03367}"/>
+                <a16:creationId xmlns:a16="http://schemas.microsoft.com/office/drawing/2014/main" id="{BB30C0B5-14D8-42C2-9B9B-4EFAAF0BDB3D}"/>
               </a:ext>
             </a:extLst>
           </p:cNvPr>
@@ -9057,7 +9153,7 @@
           <p:cNvPr id="3" name="§2.1.4 Gemengde opgaven · Opgave 5 · Boekpagina 32–33">
             <a:extLst xmlns:a="http://schemas.openxmlformats.org/drawingml/2006/main">
               <a:ext uri="{FF2B5EF4-FFF2-40B4-BE49-F238E27FC236}">
-                <a16:creationId xmlns:a16="http://schemas.microsoft.com/office/drawing/2014/main" id="{C5EAE263-05EE-441E-BBCD-141CF1B1A415}"/>
+                <a16:creationId xmlns:a16="http://schemas.microsoft.com/office/drawing/2014/main" id="{CA78C48C-66E2-4956-BBC2-828ADF2D3325}"/>
               </a:ext>
             </a:extLst>
           </p:cNvPr>
@@ -9114,7 +9210,7 @@
           <p:cNvPr id="4" name="slide-number">
             <a:extLst xmlns:a="http://schemas.openxmlformats.org/drawingml/2006/main">
               <a:ext uri="{FF2B5EF4-FFF2-40B4-BE49-F238E27FC236}">
-                <a16:creationId xmlns:a16="http://schemas.microsoft.com/office/drawing/2014/main" id="{2A3E5BF2-06E4-4962-AAF5-538C7DBE286E}"/>
+                <a16:creationId xmlns:a16="http://schemas.microsoft.com/office/drawing/2014/main" id="{611EC637-0A86-43D2-AA1C-0B8E9869CBB3}"/>
               </a:ext>
             </a:extLst>
           </p:cNvPr>
@@ -9178,7 +9274,7 @@
         </p:xfrm>
         <a:graphic xmlns:a="http://schemas.openxmlformats.org/drawingml/2006/main">
           <a:graphicData uri="http://schemas.openxmlformats.org/drawingml/2006/chart">
-            <c:chart xmlns:r="http://schemas.openxmlformats.org/officeDocument/2006/relationships" xmlns:c="http://schemas.openxmlformats.org/drawingml/2006/chart" r:id="Re22a9b13520e4985"/>
+            <c:chart xmlns:r="http://schemas.openxmlformats.org/officeDocument/2006/relationships" xmlns:c="http://schemas.openxmlformats.org/drawingml/2006/chart" r:id="R27a35bc128c44032"/>
           </a:graphicData>
         </a:graphic>
       </p:graphicFrame>
@@ -9187,7 +9283,7 @@
           <p:cNvPr id="6" name="Beide dagen">
             <a:extLst xmlns:a="http://schemas.openxmlformats.org/drawingml/2006/main">
               <a:ext uri="{FF2B5EF4-FFF2-40B4-BE49-F238E27FC236}">
-                <a16:creationId xmlns:a16="http://schemas.microsoft.com/office/drawing/2014/main" id="{6CDEE7CB-77EC-4848-B3B1-7731828ABCB9}"/>
+                <a16:creationId xmlns:a16="http://schemas.microsoft.com/office/drawing/2014/main" id="{57F8CE55-34CA-467B-A201-4F56A7E3C753}"/>
               </a:ext>
             </a:extLst>
           </p:cNvPr>
@@ -9244,7 +9340,7 @@
           <p:cNvPr id="7" name="Capaciteit:&#10;1.000 lunchboxen&#10;per dag">
             <a:extLst xmlns:a="http://schemas.openxmlformats.org/drawingml/2006/main">
               <a:ext uri="{FF2B5EF4-FFF2-40B4-BE49-F238E27FC236}">
-                <a16:creationId xmlns:a16="http://schemas.microsoft.com/office/drawing/2014/main" id="{502132D6-3578-4F6E-8813-F8AD718E8A34}"/>
+                <a16:creationId xmlns:a16="http://schemas.microsoft.com/office/drawing/2014/main" id="{FFE1DE2C-0692-47C2-88E1-D9D4F0BCC869}"/>
               </a:ext>
             </a:extLst>
           </p:cNvPr>
@@ -9347,7 +9443,7 @@
           <p:cNvPr id="8" name="Zaterdag:&#10;alleen de vier&#10;tabelpunten">
             <a:extLst xmlns:a="http://schemas.openxmlformats.org/drawingml/2006/main">
               <a:ext uri="{FF2B5EF4-FFF2-40B4-BE49-F238E27FC236}">
-                <a16:creationId xmlns:a16="http://schemas.microsoft.com/office/drawing/2014/main" id="{C8B9C319-7097-4976-A84E-26B0023357BF}"/>
+                <a16:creationId xmlns:a16="http://schemas.microsoft.com/office/drawing/2014/main" id="{853477C1-BE07-44FD-8D3D-0B73759767CD}"/>
               </a:ext>
             </a:extLst>
           </p:cNvPr>
@@ -9448,7 +9544,7 @@
     </p:spTree>
     <p:extLst>
       <p:ext uri="{BB962C8B-B14F-4D97-AF65-F5344CB8AC3E}">
-        <p14:creationId xmlns:p14="http://schemas.microsoft.com/office/powerpoint/2010/main" val="1374418824"/>
+        <p14:creationId xmlns:p14="http://schemas.microsoft.com/office/powerpoint/2010/main" val="1417542597"/>
       </p:ext>
     </p:extLst>
   </p:cSld>
@@ -9479,7 +9575,7 @@
           <p:cNvPr id="11" name="Opgave 5 · Vragen a, b en c">
             <a:extLst xmlns:a="http://schemas.openxmlformats.org/drawingml/2006/main">
               <a:ext uri="{FF2B5EF4-FFF2-40B4-BE49-F238E27FC236}">
-                <a16:creationId xmlns:a16="http://schemas.microsoft.com/office/drawing/2014/main" id="{D483E299-5800-440E-BFE4-75BF07F79F1F}"/>
+                <a16:creationId xmlns:a16="http://schemas.microsoft.com/office/drawing/2014/main" id="{805E8B0A-7F71-4A05-A8B3-51B3164AF154}"/>
               </a:ext>
             </a:extLst>
           </p:cNvPr>
@@ -9536,7 +9632,7 @@
           <p:cNvPr id="2" name="">
             <a:extLst xmlns:a="http://schemas.openxmlformats.org/drawingml/2006/main">
               <a:ext uri="{FF2B5EF4-FFF2-40B4-BE49-F238E27FC236}">
-                <a16:creationId xmlns:a16="http://schemas.microsoft.com/office/drawing/2014/main" id="{26AE1547-8F51-48FA-AB25-D2956E13835D}"/>
+                <a16:creationId xmlns:a16="http://schemas.microsoft.com/office/drawing/2014/main" id="{268DA750-CCC0-43FD-9BAA-A0C9C97F4048}"/>
               </a:ext>
             </a:extLst>
           </p:cNvPr>
@@ -9565,7 +9661,7 @@
           <p:cNvPr id="3" name="§2.1.4 Gemengde opgaven · Opgave 5 · Boekpagina 32–33">
             <a:extLst xmlns:a="http://schemas.openxmlformats.org/drawingml/2006/main">
               <a:ext uri="{FF2B5EF4-FFF2-40B4-BE49-F238E27FC236}">
-                <a16:creationId xmlns:a16="http://schemas.microsoft.com/office/drawing/2014/main" id="{B2A873F9-B3EA-4DAF-BDBE-A9BF9BF13905}"/>
+                <a16:creationId xmlns:a16="http://schemas.microsoft.com/office/drawing/2014/main" id="{51A86287-163E-4AC4-96F6-C55EB9A0C683}"/>
               </a:ext>
             </a:extLst>
           </p:cNvPr>
@@ -9622,7 +9718,7 @@
           <p:cNvPr id="4" name="slide-number">
             <a:extLst xmlns:a="http://schemas.openxmlformats.org/drawingml/2006/main">
               <a:ext uri="{FF2B5EF4-FFF2-40B4-BE49-F238E27FC236}">
-                <a16:creationId xmlns:a16="http://schemas.microsoft.com/office/drawing/2014/main" id="{F43083BD-2B16-474E-9F3B-F89829936FB7}"/>
+                <a16:creationId xmlns:a16="http://schemas.microsoft.com/office/drawing/2014/main" id="{F75C0E3E-3226-4B93-9A9D-E5C2080E86FB}"/>
               </a:ext>
             </a:extLst>
           </p:cNvPr>
@@ -9679,7 +9775,7 @@
           <p:cNvPr id="5" name="a)">
             <a:extLst xmlns:a="http://schemas.openxmlformats.org/drawingml/2006/main">
               <a:ext uri="{FF2B5EF4-FFF2-40B4-BE49-F238E27FC236}">
-                <a16:creationId xmlns:a16="http://schemas.microsoft.com/office/drawing/2014/main" id="{9C4F7B86-84BA-430B-89D9-123601BECCA5}"/>
+                <a16:creationId xmlns:a16="http://schemas.microsoft.com/office/drawing/2014/main" id="{B6F6DCB4-C806-48CE-B9D1-178A31524295}"/>
               </a:ext>
             </a:extLst>
           </p:cNvPr>
@@ -9736,7 +9832,7 @@
           <p:cNvPr id="6" name="Selecteer uit bron A de constante kosten, de variabele koste">
             <a:extLst xmlns:a="http://schemas.openxmlformats.org/drawingml/2006/main">
               <a:ext uri="{FF2B5EF4-FFF2-40B4-BE49-F238E27FC236}">
-                <a16:creationId xmlns:a16="http://schemas.microsoft.com/office/drawing/2014/main" id="{AC43C1DE-8638-454A-9D43-D22A34B42FE5}"/>
+                <a16:creationId xmlns:a16="http://schemas.microsoft.com/office/drawing/2014/main" id="{FCA6F89F-0696-4CE1-9194-75237E3ECD0E}"/>
               </a:ext>
             </a:extLst>
           </p:cNvPr>
@@ -9793,7 +9889,7 @@
           <p:cNvPr id="7" name="b)">
             <a:extLst xmlns:a="http://schemas.openxmlformats.org/drawingml/2006/main">
               <a:ext uri="{FF2B5EF4-FFF2-40B4-BE49-F238E27FC236}">
-                <a16:creationId xmlns:a16="http://schemas.microsoft.com/office/drawing/2014/main" id="{F7A06448-DEDA-4F8F-985D-B9D3A763CCD6}"/>
+                <a16:creationId xmlns:a16="http://schemas.microsoft.com/office/drawing/2014/main" id="{BA016F1F-374A-49D3-A0DB-2607E0C28E2B}"/>
               </a:ext>
             </a:extLst>
           </p:cNvPr>
@@ -9850,7 +9946,7 @@
           <p:cNvPr id="8" name="Stel voor vrijdag de functies voor TK en TO op. Bereken de b">
             <a:extLst xmlns:a="http://schemas.openxmlformats.org/drawingml/2006/main">
               <a:ext uri="{FF2B5EF4-FFF2-40B4-BE49-F238E27FC236}">
-                <a16:creationId xmlns:a16="http://schemas.microsoft.com/office/drawing/2014/main" id="{DFF59FDA-36A7-4D7A-ACFB-610250D71530}"/>
+                <a16:creationId xmlns:a16="http://schemas.microsoft.com/office/drawing/2014/main" id="{1F510DA6-AFBC-4E6F-9D2B-7753B726B9AD}"/>
               </a:ext>
             </a:extLst>
           </p:cNvPr>
@@ -9907,7 +10003,7 @@
           <p:cNvPr id="9" name="c)">
             <a:extLst xmlns:a="http://schemas.openxmlformats.org/drawingml/2006/main">
               <a:ext uri="{FF2B5EF4-FFF2-40B4-BE49-F238E27FC236}">
-                <a16:creationId xmlns:a16="http://schemas.microsoft.com/office/drawing/2014/main" id="{AE0BEBDB-6D6B-42D7-BA69-C98455F5986B}"/>
+                <a16:creationId xmlns:a16="http://schemas.microsoft.com/office/drawing/2014/main" id="{DAF4836B-A8FD-4E20-894D-69FAB484FC68}"/>
               </a:ext>
             </a:extLst>
           </p:cNvPr>
@@ -9964,7 +10060,7 @@
           <p:cNvPr id="10" name="Bereken voor vrijdag bij Q = 700 de winst en GTK. Noteer de ">
             <a:extLst xmlns:a="http://schemas.openxmlformats.org/drawingml/2006/main">
               <a:ext uri="{FF2B5EF4-FFF2-40B4-BE49-F238E27FC236}">
-                <a16:creationId xmlns:a16="http://schemas.microsoft.com/office/drawing/2014/main" id="{C8FC4698-72CB-4681-8C10-DD4D7F2054F5}"/>
+                <a16:creationId xmlns:a16="http://schemas.microsoft.com/office/drawing/2014/main" id="{889CDAF5-08EE-4CCB-9BF3-465F79E46540}"/>
               </a:ext>
             </a:extLst>
           </p:cNvPr>
@@ -10019,7 +10115,7 @@
     </p:spTree>
     <p:extLst>
       <p:ext uri="{BB962C8B-B14F-4D97-AF65-F5344CB8AC3E}">
-        <p14:creationId xmlns:p14="http://schemas.microsoft.com/office/powerpoint/2010/main" val="51609883"/>
+        <p14:creationId xmlns:p14="http://schemas.microsoft.com/office/powerpoint/2010/main" val="454170914"/>
       </p:ext>
     </p:extLst>
   </p:cSld>
@@ -10050,7 +10146,7 @@
           <p:cNvPr id="7" name="Opgave 5 · Vraag d">
             <a:extLst xmlns:a="http://schemas.openxmlformats.org/drawingml/2006/main">
               <a:ext uri="{FF2B5EF4-FFF2-40B4-BE49-F238E27FC236}">
-                <a16:creationId xmlns:a16="http://schemas.microsoft.com/office/drawing/2014/main" id="{493C69F0-BF93-4605-BDEA-E862AF34D066}"/>
+                <a16:creationId xmlns:a16="http://schemas.microsoft.com/office/drawing/2014/main" id="{75468EDB-3D0D-4201-BDAD-D34E0022BF1B}"/>
               </a:ext>
             </a:extLst>
           </p:cNvPr>
@@ -10107,7 +10203,7 @@
           <p:cNvPr id="2" name="">
             <a:extLst xmlns:a="http://schemas.openxmlformats.org/drawingml/2006/main">
               <a:ext uri="{FF2B5EF4-FFF2-40B4-BE49-F238E27FC236}">
-                <a16:creationId xmlns:a16="http://schemas.microsoft.com/office/drawing/2014/main" id="{CA69669E-B8C7-449A-A45B-499F20447D1E}"/>
+                <a16:creationId xmlns:a16="http://schemas.microsoft.com/office/drawing/2014/main" id="{8754E394-EC5B-4774-8CE3-EC58808156AE}"/>
               </a:ext>
             </a:extLst>
           </p:cNvPr>
@@ -10136,7 +10232,7 @@
           <p:cNvPr id="3" name="§2.1.4 Gemengde opgaven · Opgave 5 · Boekpagina 32–33">
             <a:extLst xmlns:a="http://schemas.openxmlformats.org/drawingml/2006/main">
               <a:ext uri="{FF2B5EF4-FFF2-40B4-BE49-F238E27FC236}">
-                <a16:creationId xmlns:a16="http://schemas.microsoft.com/office/drawing/2014/main" id="{A1DE052D-6D2C-4CD8-85E9-3BBC211D83A2}"/>
+                <a16:creationId xmlns:a16="http://schemas.microsoft.com/office/drawing/2014/main" id="{1BE8A749-27B9-46D1-A53A-1F64B73BF559}"/>
               </a:ext>
             </a:extLst>
           </p:cNvPr>
@@ -10193,7 +10289,7 @@
           <p:cNvPr id="4" name="slide-number">
             <a:extLst xmlns:a="http://schemas.openxmlformats.org/drawingml/2006/main">
               <a:ext uri="{FF2B5EF4-FFF2-40B4-BE49-F238E27FC236}">
-                <a16:creationId xmlns:a16="http://schemas.microsoft.com/office/drawing/2014/main" id="{FCF743B7-9A9D-4AAD-A3C6-D26C571EBC4A}"/>
+                <a16:creationId xmlns:a16="http://schemas.microsoft.com/office/drawing/2014/main" id="{5D50C6C3-BDF5-4B35-9D7A-CDA92D6997D9}"/>
               </a:ext>
             </a:extLst>
           </p:cNvPr>
@@ -10250,7 +10346,7 @@
           <p:cNvPr id="5" name="d) Bereken met bron B voor elk van de drie stappen op zaterd">
             <a:extLst xmlns:a="http://schemas.openxmlformats.org/drawingml/2006/main">
               <a:ext uri="{FF2B5EF4-FFF2-40B4-BE49-F238E27FC236}">
-                <a16:creationId xmlns:a16="http://schemas.microsoft.com/office/drawing/2014/main" id="{E686ABAE-FA9A-4D9E-909D-2018FEA3FD74}"/>
+                <a16:creationId xmlns:a16="http://schemas.microsoft.com/office/drawing/2014/main" id="{58A3265E-0297-4FD3-80CD-DB7A14557107}"/>
               </a:ext>
             </a:extLst>
           </p:cNvPr>
@@ -10624,7 +10720,7 @@
     </p:spTree>
     <p:extLst>
       <p:ext uri="{BB962C8B-B14F-4D97-AF65-F5344CB8AC3E}">
-        <p14:creationId xmlns:p14="http://schemas.microsoft.com/office/powerpoint/2010/main" val="82686124"/>
+        <p14:creationId xmlns:p14="http://schemas.microsoft.com/office/powerpoint/2010/main" val="896658163"/>
       </p:ext>
     </p:extLst>
   </p:cSld>
@@ -10655,7 +10751,7 @@
           <p:cNvPr id="10" name="Opgave 5 · Vragen e en f">
             <a:extLst xmlns:a="http://schemas.openxmlformats.org/drawingml/2006/main">
               <a:ext uri="{FF2B5EF4-FFF2-40B4-BE49-F238E27FC236}">
-                <a16:creationId xmlns:a16="http://schemas.microsoft.com/office/drawing/2014/main" id="{3616B021-D650-4CDC-B2D8-FE29CE3B9B9E}"/>
+                <a16:creationId xmlns:a16="http://schemas.microsoft.com/office/drawing/2014/main" id="{39637C6E-AF76-41F6-8EC5-DC604F639B2B}"/>
               </a:ext>
             </a:extLst>
           </p:cNvPr>
@@ -10712,7 +10808,7 @@
           <p:cNvPr id="2" name="">
             <a:extLst xmlns:a="http://schemas.openxmlformats.org/drawingml/2006/main">
               <a:ext uri="{FF2B5EF4-FFF2-40B4-BE49-F238E27FC236}">
-                <a16:creationId xmlns:a16="http://schemas.microsoft.com/office/drawing/2014/main" id="{C7A16EF3-EF41-4933-BC89-DC8EBDA69D1B}"/>
+                <a16:creationId xmlns:a16="http://schemas.microsoft.com/office/drawing/2014/main" id="{C125F85F-4DAB-475C-B961-68F7B8F46073}"/>
               </a:ext>
             </a:extLst>
           </p:cNvPr>
@@ -10741,7 +10837,7 @@
           <p:cNvPr id="3" name="§2.1.4 Gemengde opgaven · Opgave 5 · Boekpagina 32–33">
             <a:extLst xmlns:a="http://schemas.openxmlformats.org/drawingml/2006/main">
               <a:ext uri="{FF2B5EF4-FFF2-40B4-BE49-F238E27FC236}">
-                <a16:creationId xmlns:a16="http://schemas.microsoft.com/office/drawing/2014/main" id="{08891B32-1013-4E02-B1DA-475C94802DA1}"/>
+                <a16:creationId xmlns:a16="http://schemas.microsoft.com/office/drawing/2014/main" id="{060F9526-9628-4A0C-BA8E-2046722A70FD}"/>
               </a:ext>
             </a:extLst>
           </p:cNvPr>
@@ -10798,7 +10894,7 @@
           <p:cNvPr id="4" name="slide-number">
             <a:extLst xmlns:a="http://schemas.openxmlformats.org/drawingml/2006/main">
               <a:ext uri="{FF2B5EF4-FFF2-40B4-BE49-F238E27FC236}">
-                <a16:creationId xmlns:a16="http://schemas.microsoft.com/office/drawing/2014/main" id="{1647DEB7-1AF5-4D99-8760-456349E1FAC8}"/>
+                <a16:creationId xmlns:a16="http://schemas.microsoft.com/office/drawing/2014/main" id="{9D1E5325-52DD-4059-B204-914A8B79701D}"/>
               </a:ext>
             </a:extLst>
           </p:cNvPr>
@@ -10855,7 +10951,7 @@
           <p:cNvPr id="5" name="e)">
             <a:extLst xmlns:a="http://schemas.openxmlformats.org/drawingml/2006/main">
               <a:ext uri="{FF2B5EF4-FFF2-40B4-BE49-F238E27FC236}">
-                <a16:creationId xmlns:a16="http://schemas.microsoft.com/office/drawing/2014/main" id="{7CF5902B-8ABD-47E6-8FC4-AA5716698278}"/>
+                <a16:creationId xmlns:a16="http://schemas.microsoft.com/office/drawing/2014/main" id="{D97E692D-73C4-408A-93EA-D27E2E10DFDE}"/>
               </a:ext>
             </a:extLst>
           </p:cNvPr>
@@ -10912,7 +11008,7 @@
           <p:cNvPr id="6" name="Markeer in bron C het break-evenpunt van vrijdag. Geef ook a">
             <a:extLst xmlns:a="http://schemas.openxmlformats.org/drawingml/2006/main">
               <a:ext uri="{FF2B5EF4-FFF2-40B4-BE49-F238E27FC236}">
-                <a16:creationId xmlns:a16="http://schemas.microsoft.com/office/drawing/2014/main" id="{08484AF2-6C88-42EC-9269-2E58EA464446}"/>
+                <a16:creationId xmlns:a16="http://schemas.microsoft.com/office/drawing/2014/main" id="{C01A23E7-A04F-43AB-8F35-5FDFAB1BC481}"/>
               </a:ext>
             </a:extLst>
           </p:cNvPr>
@@ -10969,7 +11065,7 @@
           <p:cNvPr id="7" name="">
             <a:extLst xmlns:a="http://schemas.openxmlformats.org/drawingml/2006/main">
               <a:ext uri="{FF2B5EF4-FFF2-40B4-BE49-F238E27FC236}">
-                <a16:creationId xmlns:a16="http://schemas.microsoft.com/office/drawing/2014/main" id="{A972C562-7874-4A1F-A422-C1F9E446E532}"/>
+                <a16:creationId xmlns:a16="http://schemas.microsoft.com/office/drawing/2014/main" id="{96FDEF77-044D-4104-AF2B-88801D0F65B2}"/>
               </a:ext>
             </a:extLst>
           </p:cNvPr>
@@ -10998,7 +11094,7 @@
           <p:cNvPr id="8" name="f)">
             <a:extLst xmlns:a="http://schemas.openxmlformats.org/drawingml/2006/main">
               <a:ext uri="{FF2B5EF4-FFF2-40B4-BE49-F238E27FC236}">
-                <a16:creationId xmlns:a16="http://schemas.microsoft.com/office/drawing/2014/main" id="{623BC712-42C5-4312-8258-1F29ECA6F808}"/>
+                <a16:creationId xmlns:a16="http://schemas.microsoft.com/office/drawing/2014/main" id="{F61F98CB-81D4-4D92-8E7F-E690A56F80DB}"/>
               </a:ext>
             </a:extLst>
           </p:cNvPr>
@@ -11055,7 +11151,7 @@
           <p:cNvPr id="9" name="Een leerling zegt: “Door de vaste verkoopprijs leveren alle ">
             <a:extLst xmlns:a="http://schemas.openxmlformats.org/drawingml/2006/main">
               <a:ext uri="{FF2B5EF4-FFF2-40B4-BE49-F238E27FC236}">
-                <a16:creationId xmlns:a16="http://schemas.microsoft.com/office/drawing/2014/main" id="{C26AAF01-005C-444E-93FE-3825E6EF082D}"/>
+                <a16:creationId xmlns:a16="http://schemas.microsoft.com/office/drawing/2014/main" id="{BDE0D898-7B0C-44D9-A092-0B3526E803CF}"/>
               </a:ext>
             </a:extLst>
           </p:cNvPr>
@@ -11110,7 +11206,7 @@
     </p:spTree>
     <p:extLst>
       <p:ext uri="{BB962C8B-B14F-4D97-AF65-F5344CB8AC3E}">
-        <p14:creationId xmlns:p14="http://schemas.microsoft.com/office/powerpoint/2010/main" val="1775522779"/>
+        <p14:creationId xmlns:p14="http://schemas.microsoft.com/office/powerpoint/2010/main" val="676821772"/>
       </p:ext>
     </p:extLst>
   </p:cSld>
@@ -11141,7 +11237,7 @@
           <p:cNvPr id="10" name="Opgave 5a–b · Vrijdag: gegevens en functies">
             <a:extLst xmlns:a="http://schemas.openxmlformats.org/drawingml/2006/main">
               <a:ext uri="{FF2B5EF4-FFF2-40B4-BE49-F238E27FC236}">
-                <a16:creationId xmlns:a16="http://schemas.microsoft.com/office/drawing/2014/main" id="{63875403-1AD1-4404-9C36-B1A9ECFD30F5}"/>
+                <a16:creationId xmlns:a16="http://schemas.microsoft.com/office/drawing/2014/main" id="{A3E6A448-B5FE-4B0E-975D-6950DBE94F06}"/>
               </a:ext>
             </a:extLst>
           </p:cNvPr>
@@ -11198,7 +11294,7 @@
           <p:cNvPr id="2" name="">
             <a:extLst xmlns:a="http://schemas.openxmlformats.org/drawingml/2006/main">
               <a:ext uri="{FF2B5EF4-FFF2-40B4-BE49-F238E27FC236}">
-                <a16:creationId xmlns:a16="http://schemas.microsoft.com/office/drawing/2014/main" id="{EA099AB8-4909-474E-B44C-E3E19A1E990C}"/>
+                <a16:creationId xmlns:a16="http://schemas.microsoft.com/office/drawing/2014/main" id="{D9B9A085-3467-4671-8490-37F06BC10C22}"/>
               </a:ext>
             </a:extLst>
           </p:cNvPr>
@@ -11227,7 +11323,7 @@
           <p:cNvPr id="3" name="§2.1.4 Gemengde opgaven · Opgave 5 · Boekpagina 32–33">
             <a:extLst xmlns:a="http://schemas.openxmlformats.org/drawingml/2006/main">
               <a:ext uri="{FF2B5EF4-FFF2-40B4-BE49-F238E27FC236}">
-                <a16:creationId xmlns:a16="http://schemas.microsoft.com/office/drawing/2014/main" id="{71FCF5EB-8182-4F35-83E5-7B2B506F4075}"/>
+                <a16:creationId xmlns:a16="http://schemas.microsoft.com/office/drawing/2014/main" id="{FA72038A-D5D9-40E8-BC66-9CE212091588}"/>
               </a:ext>
             </a:extLst>
           </p:cNvPr>
@@ -11284,7 +11380,7 @@
           <p:cNvPr id="4" name="slide-number">
             <a:extLst xmlns:a="http://schemas.openxmlformats.org/drawingml/2006/main">
               <a:ext uri="{FF2B5EF4-FFF2-40B4-BE49-F238E27FC236}">
-                <a16:creationId xmlns:a16="http://schemas.microsoft.com/office/drawing/2014/main" id="{03DF2F50-0EC3-4711-B1D0-AD90F990062B}"/>
+                <a16:creationId xmlns:a16="http://schemas.microsoft.com/office/drawing/2014/main" id="{5BCD1CF1-077B-44B9-8825-C79B884AB852}"/>
               </a:ext>
             </a:extLst>
           </p:cNvPr>
@@ -11660,7 +11756,7 @@
           <p:cNvPr id="6" name="TK = 1.200 + 2Q">
             <a:extLst xmlns:a="http://schemas.openxmlformats.org/drawingml/2006/main">
               <a:ext uri="{FF2B5EF4-FFF2-40B4-BE49-F238E27FC236}">
-                <a16:creationId xmlns:a16="http://schemas.microsoft.com/office/drawing/2014/main" id="{C847C023-D46A-47DA-8C91-3D00AA154326}"/>
+                <a16:creationId xmlns:a16="http://schemas.microsoft.com/office/drawing/2014/main" id="{6D857565-BFF6-44EA-ACE0-A5624E0594D2}"/>
               </a:ext>
             </a:extLst>
           </p:cNvPr>
@@ -11717,7 +11813,7 @@
           <p:cNvPr id="7" name="TO = 5Q">
             <a:extLst xmlns:a="http://schemas.openxmlformats.org/drawingml/2006/main">
               <a:ext uri="{FF2B5EF4-FFF2-40B4-BE49-F238E27FC236}">
-                <a16:creationId xmlns:a16="http://schemas.microsoft.com/office/drawing/2014/main" id="{AC7068BF-C9D7-4A89-AA41-116E779D75EF}"/>
+                <a16:creationId xmlns:a16="http://schemas.microsoft.com/office/drawing/2014/main" id="{708A850A-12B4-41C7-9A76-52FDCDB59694}"/>
               </a:ext>
             </a:extLst>
           </p:cNvPr>
@@ -11774,7 +11870,7 @@
           <p:cNvPr id="8" name="Totalen in € per dag · 0 ≤ Q ≤ 1.000 lunchboxen per dag">
             <a:extLst xmlns:a="http://schemas.openxmlformats.org/drawingml/2006/main">
               <a:ext uri="{FF2B5EF4-FFF2-40B4-BE49-F238E27FC236}">
-                <a16:creationId xmlns:a16="http://schemas.microsoft.com/office/drawing/2014/main" id="{60622874-F68A-4DCC-AE92-B56E67520614}"/>
+                <a16:creationId xmlns:a16="http://schemas.microsoft.com/office/drawing/2014/main" id="{F950D34B-941C-4D93-9351-B7089D5A23FA}"/>
               </a:ext>
             </a:extLst>
           </p:cNvPr>
@@ -11831,7 +11927,7 @@
           <p:cNvPr id="9" name="4.000 bezoekers is niet nodig voor TK en TO.">
             <a:extLst xmlns:a="http://schemas.openxmlformats.org/drawingml/2006/main">
               <a:ext uri="{FF2B5EF4-FFF2-40B4-BE49-F238E27FC236}">
-                <a16:creationId xmlns:a16="http://schemas.microsoft.com/office/drawing/2014/main" id="{64743B06-6A37-4C80-9947-7D9C0C957011}"/>
+                <a16:creationId xmlns:a16="http://schemas.microsoft.com/office/drawing/2014/main" id="{034134B5-D415-45D6-8F6F-25B8160485D5}"/>
               </a:ext>
             </a:extLst>
           </p:cNvPr>
@@ -11886,7 +11982,7 @@
     </p:spTree>
     <p:extLst>
       <p:ext uri="{BB962C8B-B14F-4D97-AF65-F5344CB8AC3E}">
-        <p14:creationId xmlns:p14="http://schemas.microsoft.com/office/powerpoint/2010/main" val="477818082"/>
+        <p14:creationId xmlns:p14="http://schemas.microsoft.com/office/powerpoint/2010/main" val="526727172"/>
       </p:ext>
     </p:extLst>
   </p:cSld>
@@ -11917,7 +12013,7 @@
           <p:cNvPr id="15" name="Opgave 5b · De break-even-afzet">
             <a:extLst xmlns:a="http://schemas.openxmlformats.org/drawingml/2006/main">
               <a:ext uri="{FF2B5EF4-FFF2-40B4-BE49-F238E27FC236}">
-                <a16:creationId xmlns:a16="http://schemas.microsoft.com/office/drawing/2014/main" id="{37B29224-5259-4005-AF2C-4891A707FE34}"/>
+                <a16:creationId xmlns:a16="http://schemas.microsoft.com/office/drawing/2014/main" id="{A142731B-0C6E-4AB8-A6AA-40FF44C6FB2B}"/>
               </a:ext>
             </a:extLst>
           </p:cNvPr>
@@ -11974,7 +12070,7 @@
           <p:cNvPr id="2" name="">
             <a:extLst xmlns:a="http://schemas.openxmlformats.org/drawingml/2006/main">
               <a:ext uri="{FF2B5EF4-FFF2-40B4-BE49-F238E27FC236}">
-                <a16:creationId xmlns:a16="http://schemas.microsoft.com/office/drawing/2014/main" id="{7CB14226-A2E6-4B77-BC0E-152BCC547FDE}"/>
+                <a16:creationId xmlns:a16="http://schemas.microsoft.com/office/drawing/2014/main" id="{78FE59CF-AE55-42CF-93BD-BBC1B9DCE6BB}"/>
               </a:ext>
             </a:extLst>
           </p:cNvPr>
@@ -12003,7 +12099,7 @@
           <p:cNvPr id="3" name="§2.1.4 Gemengde opgaven · Opgave 5 · Boekpagina 32–33">
             <a:extLst xmlns:a="http://schemas.openxmlformats.org/drawingml/2006/main">
               <a:ext uri="{FF2B5EF4-FFF2-40B4-BE49-F238E27FC236}">
-                <a16:creationId xmlns:a16="http://schemas.microsoft.com/office/drawing/2014/main" id="{8D0C26D5-86A3-4770-A786-5CF551E65BBB}"/>
+                <a16:creationId xmlns:a16="http://schemas.microsoft.com/office/drawing/2014/main" id="{04F0608F-2E1E-4E32-AEB6-48440264A803}"/>
               </a:ext>
             </a:extLst>
           </p:cNvPr>
@@ -12060,7 +12156,7 @@
           <p:cNvPr id="4" name="slide-number">
             <a:extLst xmlns:a="http://schemas.openxmlformats.org/drawingml/2006/main">
               <a:ext uri="{FF2B5EF4-FFF2-40B4-BE49-F238E27FC236}">
-                <a16:creationId xmlns:a16="http://schemas.microsoft.com/office/drawing/2014/main" id="{CFB8AB24-85C0-4CA9-8090-DD0981C8AB1B}"/>
+                <a16:creationId xmlns:a16="http://schemas.microsoft.com/office/drawing/2014/main" id="{2214BB2F-21C0-4042-B43E-D0F2AD5F6A84}"/>
               </a:ext>
             </a:extLst>
           </p:cNvPr>
@@ -12117,7 +12213,7 @@
           <p:cNvPr id="5" name="TO = TK">
             <a:extLst xmlns:a="http://schemas.openxmlformats.org/drawingml/2006/main">
               <a:ext uri="{FF2B5EF4-FFF2-40B4-BE49-F238E27FC236}">
-                <a16:creationId xmlns:a16="http://schemas.microsoft.com/office/drawing/2014/main" id="{ABB46614-CB8F-4961-B8E0-A332DA592EFD}"/>
+                <a16:creationId xmlns:a16="http://schemas.microsoft.com/office/drawing/2014/main" id="{3B1E123D-386E-4414-8634-CBCE1C60D952}"/>
               </a:ext>
             </a:extLst>
           </p:cNvPr>
@@ -12174,7 +12270,7 @@
           <p:cNvPr id="6" name="Opbrengst dekt alle kosten">
             <a:extLst xmlns:a="http://schemas.openxmlformats.org/drawingml/2006/main">
               <a:ext uri="{FF2B5EF4-FFF2-40B4-BE49-F238E27FC236}">
-                <a16:creationId xmlns:a16="http://schemas.microsoft.com/office/drawing/2014/main" id="{E21AF8D3-4D98-42E1-BE33-850A66306AAE}"/>
+                <a16:creationId xmlns:a16="http://schemas.microsoft.com/office/drawing/2014/main" id="{33D0240E-4EF2-4378-A743-D74EDE391655}"/>
               </a:ext>
             </a:extLst>
           </p:cNvPr>
@@ -12231,7 +12327,7 @@
           <p:cNvPr id="7" name="5Q = 1.200 + 2Q">
             <a:extLst xmlns:a="http://schemas.openxmlformats.org/drawingml/2006/main">
               <a:ext uri="{FF2B5EF4-FFF2-40B4-BE49-F238E27FC236}">
-                <a16:creationId xmlns:a16="http://schemas.microsoft.com/office/drawing/2014/main" id="{5109DF82-6D98-4820-A3E1-1BE3F66982A5}"/>
+                <a16:creationId xmlns:a16="http://schemas.microsoft.com/office/drawing/2014/main" id="{5FFF7466-62FA-433A-83B3-7659749A298C}"/>
               </a:ext>
             </a:extLst>
           </p:cNvPr>
@@ -12288,7 +12384,7 @@
           <p:cNvPr id="8" name="Functies invullen">
             <a:extLst xmlns:a="http://schemas.openxmlformats.org/drawingml/2006/main">
               <a:ext uri="{FF2B5EF4-FFF2-40B4-BE49-F238E27FC236}">
-                <a16:creationId xmlns:a16="http://schemas.microsoft.com/office/drawing/2014/main" id="{E355D26E-0EBE-4160-9E7A-B3844039E25D}"/>
+                <a16:creationId xmlns:a16="http://schemas.microsoft.com/office/drawing/2014/main" id="{8F0BEBF2-0586-4BDD-B111-81250C5DA57D}"/>
               </a:ext>
             </a:extLst>
           </p:cNvPr>
@@ -12345,7 +12441,7 @@
           <p:cNvPr id="9" name="3Q = 1.200">
             <a:extLst xmlns:a="http://schemas.openxmlformats.org/drawingml/2006/main">
               <a:ext uri="{FF2B5EF4-FFF2-40B4-BE49-F238E27FC236}">
-                <a16:creationId xmlns:a16="http://schemas.microsoft.com/office/drawing/2014/main" id="{2D3FD35F-DD0F-474A-85E8-151D3C43F467}"/>
+                <a16:creationId xmlns:a16="http://schemas.microsoft.com/office/drawing/2014/main" id="{E4F76C9D-B991-4449-BE5F-723A2E4DC0B8}"/>
               </a:ext>
             </a:extLst>
           </p:cNvPr>
@@ -12402,7 +12498,7 @@
           <p:cNvPr id="10" name="Aan beide kanten 2Q aftrekken">
             <a:extLst xmlns:a="http://schemas.openxmlformats.org/drawingml/2006/main">
               <a:ext uri="{FF2B5EF4-FFF2-40B4-BE49-F238E27FC236}">
-                <a16:creationId xmlns:a16="http://schemas.microsoft.com/office/drawing/2014/main" id="{BB43F602-64D4-4B1A-B052-278D19839DDD}"/>
+                <a16:creationId xmlns:a16="http://schemas.microsoft.com/office/drawing/2014/main" id="{A5CAD3AA-F53E-4E1A-B320-38CDBD45C71F}"/>
               </a:ext>
             </a:extLst>
           </p:cNvPr>
@@ -12459,7 +12555,7 @@
           <p:cNvPr id="11" name="Q = 1.200 / 3 = 400">
             <a:extLst xmlns:a="http://schemas.openxmlformats.org/drawingml/2006/main">
               <a:ext uri="{FF2B5EF4-FFF2-40B4-BE49-F238E27FC236}">
-                <a16:creationId xmlns:a16="http://schemas.microsoft.com/office/drawing/2014/main" id="{9F702C60-9018-455C-A4CD-772681602542}"/>
+                <a16:creationId xmlns:a16="http://schemas.microsoft.com/office/drawing/2014/main" id="{851EDB28-EAEB-485D-B0E9-524067662F2A}"/>
               </a:ext>
             </a:extLst>
           </p:cNvPr>
@@ -12516,7 +12612,7 @@
           <p:cNvPr id="12" name="Lunchboxen per dag">
             <a:extLst xmlns:a="http://schemas.openxmlformats.org/drawingml/2006/main">
               <a:ext uri="{FF2B5EF4-FFF2-40B4-BE49-F238E27FC236}">
-                <a16:creationId xmlns:a16="http://schemas.microsoft.com/office/drawing/2014/main" id="{19A332F5-BF56-45D7-92DC-5B8B7099C379}"/>
+                <a16:creationId xmlns:a16="http://schemas.microsoft.com/office/drawing/2014/main" id="{0E08E1AF-9D88-495E-910B-9A539015A3F0}"/>
               </a:ext>
             </a:extLst>
           </p:cNvPr>
@@ -12573,7 +12669,7 @@
           <p:cNvPr id="13" name="Controle: TO = 5 × 400 = € 2.000 per dag">
             <a:extLst xmlns:a="http://schemas.openxmlformats.org/drawingml/2006/main">
               <a:ext uri="{FF2B5EF4-FFF2-40B4-BE49-F238E27FC236}">
-                <a16:creationId xmlns:a16="http://schemas.microsoft.com/office/drawing/2014/main" id="{8E50A144-A7AD-46B9-97A8-2DDDFCE00553}"/>
+                <a16:creationId xmlns:a16="http://schemas.microsoft.com/office/drawing/2014/main" id="{178502E4-B291-45C1-AFCD-840D0713BDF9}"/>
               </a:ext>
             </a:extLst>
           </p:cNvPr>
@@ -12630,7 +12726,7 @@
           <p:cNvPr id="14" name="TK = 1.200 + 2 × 400 = € 2.000 per dag. Winst = € 0.">
             <a:extLst xmlns:a="http://schemas.openxmlformats.org/drawingml/2006/main">
               <a:ext uri="{FF2B5EF4-FFF2-40B4-BE49-F238E27FC236}">
-                <a16:creationId xmlns:a16="http://schemas.microsoft.com/office/drawing/2014/main" id="{4C760BD6-5A7B-436F-98D7-4FD5DAB87C27}"/>
+                <a16:creationId xmlns:a16="http://schemas.microsoft.com/office/drawing/2014/main" id="{BF1F71CD-B22E-415E-994E-56FBAB065D29}"/>
               </a:ext>
             </a:extLst>
           </p:cNvPr>
@@ -12685,7 +12781,7 @@
     </p:spTree>
     <p:extLst>
       <p:ext uri="{BB962C8B-B14F-4D97-AF65-F5344CB8AC3E}">
-        <p14:creationId xmlns:p14="http://schemas.microsoft.com/office/powerpoint/2010/main" val="793295441"/>
+        <p14:creationId xmlns:p14="http://schemas.microsoft.com/office/powerpoint/2010/main" val="1044969476"/>
       </p:ext>
     </p:extLst>
   </p:cSld>
@@ -12716,7 +12812,7 @@
           <p:cNvPr id="11" name="Opgave 5c · Vrijdag bij 700 lunchboxen">
             <a:extLst xmlns:a="http://schemas.openxmlformats.org/drawingml/2006/main">
               <a:ext uri="{FF2B5EF4-FFF2-40B4-BE49-F238E27FC236}">
-                <a16:creationId xmlns:a16="http://schemas.microsoft.com/office/drawing/2014/main" id="{F036399F-A8EA-4C49-8D5D-54CBCFA4C1A2}"/>
+                <a16:creationId xmlns:a16="http://schemas.microsoft.com/office/drawing/2014/main" id="{115E5094-5135-48A1-B321-46C52E4EE843}"/>
               </a:ext>
             </a:extLst>
           </p:cNvPr>
@@ -12773,7 +12869,7 @@
           <p:cNvPr id="2" name="">
             <a:extLst xmlns:a="http://schemas.openxmlformats.org/drawingml/2006/main">
               <a:ext uri="{FF2B5EF4-FFF2-40B4-BE49-F238E27FC236}">
-                <a16:creationId xmlns:a16="http://schemas.microsoft.com/office/drawing/2014/main" id="{8D380D32-F9BE-4C3F-ABAF-4914FF9B606F}"/>
+                <a16:creationId xmlns:a16="http://schemas.microsoft.com/office/drawing/2014/main" id="{8D716639-F3AC-4D56-A02D-FAD9FD372AF7}"/>
               </a:ext>
             </a:extLst>
           </p:cNvPr>
@@ -12802,7 +12898,7 @@
           <p:cNvPr id="3" name="§2.1.4 Gemengde opgaven · Opgave 5 · Boekpagina 32–33">
             <a:extLst xmlns:a="http://schemas.openxmlformats.org/drawingml/2006/main">
               <a:ext uri="{FF2B5EF4-FFF2-40B4-BE49-F238E27FC236}">
-                <a16:creationId xmlns:a16="http://schemas.microsoft.com/office/drawing/2014/main" id="{73F6B6EF-159E-4EDB-819D-3575BFB8207F}"/>
+                <a16:creationId xmlns:a16="http://schemas.microsoft.com/office/drawing/2014/main" id="{019185CC-93E8-4F9B-BF5B-FBC2F101C21A}"/>
               </a:ext>
             </a:extLst>
           </p:cNvPr>
@@ -12859,7 +12955,7 @@
           <p:cNvPr id="4" name="slide-number">
             <a:extLst xmlns:a="http://schemas.openxmlformats.org/drawingml/2006/main">
               <a:ext uri="{FF2B5EF4-FFF2-40B4-BE49-F238E27FC236}">
-                <a16:creationId xmlns:a16="http://schemas.microsoft.com/office/drawing/2014/main" id="{102EFAE2-A35E-4880-B2D5-4779B611363C}"/>
+                <a16:creationId xmlns:a16="http://schemas.microsoft.com/office/drawing/2014/main" id="{FAD7507A-9A86-456D-BDB8-55EA9B19A65E}"/>
               </a:ext>
             </a:extLst>
           </p:cNvPr>
@@ -12916,7 +13012,7 @@
           <p:cNvPr id="5" name="TK = 1.200 + 2 × 700 = € 2.600 per dag">
             <a:extLst xmlns:a="http://schemas.openxmlformats.org/drawingml/2006/main">
               <a:ext uri="{FF2B5EF4-FFF2-40B4-BE49-F238E27FC236}">
-                <a16:creationId xmlns:a16="http://schemas.microsoft.com/office/drawing/2014/main" id="{0B8DED40-2B0C-4C50-A80C-4117A1F68C82}"/>
+                <a16:creationId xmlns:a16="http://schemas.microsoft.com/office/drawing/2014/main" id="{26CA2967-6B65-4C02-BD1B-7188F57FF5B9}"/>
               </a:ext>
             </a:extLst>
           </p:cNvPr>
@@ -12973,7 +13069,7 @@
           <p:cNvPr id="6" name="TO = 5 × 700 = € 3.500 per dag">
             <a:extLst xmlns:a="http://schemas.openxmlformats.org/drawingml/2006/main">
               <a:ext uri="{FF2B5EF4-FFF2-40B4-BE49-F238E27FC236}">
-                <a16:creationId xmlns:a16="http://schemas.microsoft.com/office/drawing/2014/main" id="{AA9D52EF-9E20-4AF9-BA3A-FF8EA2C1282B}"/>
+                <a16:creationId xmlns:a16="http://schemas.microsoft.com/office/drawing/2014/main" id="{E632BAFF-48CB-4F23-A465-5F2B02B72735}"/>
               </a:ext>
             </a:extLst>
           </p:cNvPr>
@@ -13030,7 +13126,7 @@
           <p:cNvPr id="7" name="">
             <a:extLst xmlns:a="http://schemas.openxmlformats.org/drawingml/2006/main">
               <a:ext uri="{FF2B5EF4-FFF2-40B4-BE49-F238E27FC236}">
-                <a16:creationId xmlns:a16="http://schemas.microsoft.com/office/drawing/2014/main" id="{E7F594A9-97A3-4979-ADEE-32AF4AC3E89C}"/>
+                <a16:creationId xmlns:a16="http://schemas.microsoft.com/office/drawing/2014/main" id="{6A97BB48-FCC7-4029-A771-89F6C1CEDEBB}"/>
               </a:ext>
             </a:extLst>
           </p:cNvPr>
@@ -13059,7 +13155,7 @@
           <p:cNvPr id="8" name="Winst = TO − TK = 3.500 − 2.600">
             <a:extLst xmlns:a="http://schemas.openxmlformats.org/drawingml/2006/main">
               <a:ext uri="{FF2B5EF4-FFF2-40B4-BE49-F238E27FC236}">
-                <a16:creationId xmlns:a16="http://schemas.microsoft.com/office/drawing/2014/main" id="{2B537BC6-444E-4E5C-BBFA-3ED86D2BB710}"/>
+                <a16:creationId xmlns:a16="http://schemas.microsoft.com/office/drawing/2014/main" id="{EA313D9E-D504-4CDA-82D2-0928B395930F}"/>
               </a:ext>
             </a:extLst>
           </p:cNvPr>
@@ -13116,7 +13212,7 @@
           <p:cNvPr id="9" name="= € 900 per dag">
             <a:extLst xmlns:a="http://schemas.openxmlformats.org/drawingml/2006/main">
               <a:ext uri="{FF2B5EF4-FFF2-40B4-BE49-F238E27FC236}">
-                <a16:creationId xmlns:a16="http://schemas.microsoft.com/office/drawing/2014/main" id="{F56EBB7A-648E-41EE-93F0-3FDDB19B2E36}"/>
+                <a16:creationId xmlns:a16="http://schemas.microsoft.com/office/drawing/2014/main" id="{C39DCD71-EA38-4D8F-BAE7-8831B73055CA}"/>
               </a:ext>
             </a:extLst>
           </p:cNvPr>
@@ -13173,7 +13269,7 @@
           <p:cNvPr id="10" name="GTK = TK / Q = 2.600 / 700 ≈ € 3,71 per lunchbox">
             <a:extLst xmlns:a="http://schemas.openxmlformats.org/drawingml/2006/main">
               <a:ext uri="{FF2B5EF4-FFF2-40B4-BE49-F238E27FC236}">
-                <a16:creationId xmlns:a16="http://schemas.microsoft.com/office/drawing/2014/main" id="{BE20410B-4D23-4F9B-AAA6-58C93272180F}"/>
+                <a16:creationId xmlns:a16="http://schemas.microsoft.com/office/drawing/2014/main" id="{323AAF3C-79E0-4250-A23A-363EE8AEFC18}"/>
               </a:ext>
             </a:extLst>
           </p:cNvPr>
@@ -13228,7 +13324,7 @@
     </p:spTree>
     <p:extLst>
       <p:ext uri="{BB962C8B-B14F-4D97-AF65-F5344CB8AC3E}">
-        <p14:creationId xmlns:p14="http://schemas.microsoft.com/office/powerpoint/2010/main" val="1708808147"/>
+        <p14:creationId xmlns:p14="http://schemas.microsoft.com/office/powerpoint/2010/main" val="1449104457"/>
       </p:ext>
     </p:extLst>
   </p:cSld>
@@ -13259,7 +13355,7 @@
           <p:cNvPr id="8" name="Opgave 5d · MK en MO op zaterdag">
             <a:extLst xmlns:a="http://schemas.openxmlformats.org/drawingml/2006/main">
               <a:ext uri="{FF2B5EF4-FFF2-40B4-BE49-F238E27FC236}">
-                <a16:creationId xmlns:a16="http://schemas.microsoft.com/office/drawing/2014/main" id="{4C743F35-035C-452B-A432-BEF9D94D5609}"/>
+                <a16:creationId xmlns:a16="http://schemas.microsoft.com/office/drawing/2014/main" id="{05D3AED9-B2A6-405B-943C-F1CFEC492A19}"/>
               </a:ext>
             </a:extLst>
           </p:cNvPr>
@@ -13316,7 +13412,7 @@
           <p:cNvPr id="2" name="">
             <a:extLst xmlns:a="http://schemas.openxmlformats.org/drawingml/2006/main">
               <a:ext uri="{FF2B5EF4-FFF2-40B4-BE49-F238E27FC236}">
-                <a16:creationId xmlns:a16="http://schemas.microsoft.com/office/drawing/2014/main" id="{D905B639-E43D-42A2-82ED-CBF726DC8203}"/>
+                <a16:creationId xmlns:a16="http://schemas.microsoft.com/office/drawing/2014/main" id="{3804EE23-B99F-44E9-B498-F6C105A9927D}"/>
               </a:ext>
             </a:extLst>
           </p:cNvPr>
@@ -13345,7 +13441,7 @@
           <p:cNvPr id="3" name="§2.1.4 Gemengde opgaven · Opgave 5 · Boekpagina 32–33">
             <a:extLst xmlns:a="http://schemas.openxmlformats.org/drawingml/2006/main">
               <a:ext uri="{FF2B5EF4-FFF2-40B4-BE49-F238E27FC236}">
-                <a16:creationId xmlns:a16="http://schemas.microsoft.com/office/drawing/2014/main" id="{FF12082C-5204-4CD0-A99F-383E7410CC3F}"/>
+                <a16:creationId xmlns:a16="http://schemas.microsoft.com/office/drawing/2014/main" id="{9524D79E-8639-4031-BFC8-D89BABF49978}"/>
               </a:ext>
             </a:extLst>
           </p:cNvPr>
@@ -13402,7 +13498,7 @@
           <p:cNvPr id="4" name="slide-number">
             <a:extLst xmlns:a="http://schemas.openxmlformats.org/drawingml/2006/main">
               <a:ext uri="{FF2B5EF4-FFF2-40B4-BE49-F238E27FC236}">
-                <a16:creationId xmlns:a16="http://schemas.microsoft.com/office/drawing/2014/main" id="{FF1B1669-B278-4406-95E8-F967ACA730A4}"/>
+                <a16:creationId xmlns:a16="http://schemas.microsoft.com/office/drawing/2014/main" id="{AD971604-AF26-4948-AE23-439F65DB3078}"/>
               </a:ext>
             </a:extLst>
           </p:cNvPr>
@@ -13459,7 +13555,7 @@
           <p:cNvPr id="5" name="MK = ΔTK / ΔQ     MO = ΔTO / ΔQ">
             <a:extLst xmlns:a="http://schemas.openxmlformats.org/drawingml/2006/main">
               <a:ext uri="{FF2B5EF4-FFF2-40B4-BE49-F238E27FC236}">
-                <a16:creationId xmlns:a16="http://schemas.microsoft.com/office/drawing/2014/main" id="{0DFE9CD0-0599-4AAC-A0BD-8CC5A61E2037}"/>
+                <a16:creationId xmlns:a16="http://schemas.microsoft.com/office/drawing/2014/main" id="{BCECA4A9-9F9D-49DC-9F68-891AD949A3D1}"/>
               </a:ext>
             </a:extLst>
           </p:cNvPr>
@@ -13913,7 +14009,7 @@
           <p:cNvPr id="7" name="De extra kosten per lunchbox stijgen.&#10;De extra opbrengst bli">
             <a:extLst xmlns:a="http://schemas.openxmlformats.org/drawingml/2006/main">
               <a:ext uri="{FF2B5EF4-FFF2-40B4-BE49-F238E27FC236}">
-                <a16:creationId xmlns:a16="http://schemas.microsoft.com/office/drawing/2014/main" id="{B88A368F-006E-48D2-9920-CEB8C05D059D}"/>
+                <a16:creationId xmlns:a16="http://schemas.microsoft.com/office/drawing/2014/main" id="{168684C9-43B1-40B4-91CB-07E37D7E9891}"/>
               </a:ext>
             </a:extLst>
           </p:cNvPr>
@@ -13991,7 +14087,7 @@
     </p:spTree>
     <p:extLst>
       <p:ext uri="{BB962C8B-B14F-4D97-AF65-F5344CB8AC3E}">
-        <p14:creationId xmlns:p14="http://schemas.microsoft.com/office/powerpoint/2010/main" val="508061609"/>
+        <p14:creationId xmlns:p14="http://schemas.microsoft.com/office/powerpoint/2010/main" val="1818003207"/>
       </p:ext>
     </p:extLst>
   </p:cSld>
@@ -14022,7 +14118,7 @@
           <p:cNvPr id="9" name="Opgave 5e · Break-even en positieve winst">
             <a:extLst xmlns:a="http://schemas.openxmlformats.org/drawingml/2006/main">
               <a:ext uri="{FF2B5EF4-FFF2-40B4-BE49-F238E27FC236}">
-                <a16:creationId xmlns:a16="http://schemas.microsoft.com/office/drawing/2014/main" id="{33A8942C-1DAA-4A85-9E7A-EC6A89B05D42}"/>
+                <a16:creationId xmlns:a16="http://schemas.microsoft.com/office/drawing/2014/main" id="{6BA8C003-A872-4B9B-A1F0-E787EDA1EF20}"/>
               </a:ext>
             </a:extLst>
           </p:cNvPr>
@@ -14079,7 +14175,7 @@
           <p:cNvPr id="2" name="">
             <a:extLst xmlns:a="http://schemas.openxmlformats.org/drawingml/2006/main">
               <a:ext uri="{FF2B5EF4-FFF2-40B4-BE49-F238E27FC236}">
-                <a16:creationId xmlns:a16="http://schemas.microsoft.com/office/drawing/2014/main" id="{126A52A7-5757-4BC6-A0B7-DD43CB05D371}"/>
+                <a16:creationId xmlns:a16="http://schemas.microsoft.com/office/drawing/2014/main" id="{28089100-808A-4FF9-B288-814BB67BBC60}"/>
               </a:ext>
             </a:extLst>
           </p:cNvPr>
@@ -14108,7 +14204,7 @@
           <p:cNvPr id="3" name="§2.1.4 Gemengde opgaven · Opgave 5 · Boekpagina 32–33">
             <a:extLst xmlns:a="http://schemas.openxmlformats.org/drawingml/2006/main">
               <a:ext uri="{FF2B5EF4-FFF2-40B4-BE49-F238E27FC236}">
-                <a16:creationId xmlns:a16="http://schemas.microsoft.com/office/drawing/2014/main" id="{6DF265A4-714E-4269-BEE5-32D7F325B1FC}"/>
+                <a16:creationId xmlns:a16="http://schemas.microsoft.com/office/drawing/2014/main" id="{EB238C9A-9887-4C0A-BFBA-CDBEEF56F1C7}"/>
               </a:ext>
             </a:extLst>
           </p:cNvPr>
@@ -14165,7 +14261,7 @@
           <p:cNvPr id="4" name="slide-number">
             <a:extLst xmlns:a="http://schemas.openxmlformats.org/drawingml/2006/main">
               <a:ext uri="{FF2B5EF4-FFF2-40B4-BE49-F238E27FC236}">
-                <a16:creationId xmlns:a16="http://schemas.microsoft.com/office/drawing/2014/main" id="{2F2F7763-FB52-4BDD-BEC6-D791713D2E41}"/>
+                <a16:creationId xmlns:a16="http://schemas.microsoft.com/office/drawing/2014/main" id="{F5B7D3A7-C976-4B11-8B3B-DACF5D8B9765}"/>
               </a:ext>
             </a:extLst>
           </p:cNvPr>
@@ -14229,7 +14325,7 @@
         </p:xfrm>
         <a:graphic xmlns:a="http://schemas.openxmlformats.org/drawingml/2006/main">
           <a:graphicData uri="http://schemas.openxmlformats.org/drawingml/2006/chart">
-            <c:chart xmlns:r="http://schemas.openxmlformats.org/officeDocument/2006/relationships" xmlns:c="http://schemas.openxmlformats.org/drawingml/2006/chart" r:id="R87bc9cc240f94bdc"/>
+            <c:chart xmlns:r="http://schemas.openxmlformats.org/officeDocument/2006/relationships" xmlns:c="http://schemas.openxmlformats.org/drawingml/2006/chart" r:id="Rc624bbc4718d43dd"/>
           </a:graphicData>
         </a:graphic>
       </p:graphicFrame>
@@ -14238,7 +14334,7 @@
           <p:cNvPr id="6" name="Vrijdag">
             <a:extLst xmlns:a="http://schemas.openxmlformats.org/drawingml/2006/main">
               <a:ext uri="{FF2B5EF4-FFF2-40B4-BE49-F238E27FC236}">
-                <a16:creationId xmlns:a16="http://schemas.microsoft.com/office/drawing/2014/main" id="{4A1C4A58-665B-42DD-990D-43EBE058429D}"/>
+                <a16:creationId xmlns:a16="http://schemas.microsoft.com/office/drawing/2014/main" id="{DEC81F26-8319-45F3-88CE-1A76EB1326B4}"/>
               </a:ext>
             </a:extLst>
           </p:cNvPr>
@@ -14295,7 +14391,7 @@
           <p:cNvPr id="7" name="Break-even:&#10;(400; 2.000)">
             <a:extLst xmlns:a="http://schemas.openxmlformats.org/drawingml/2006/main">
               <a:ext uri="{FF2B5EF4-FFF2-40B4-BE49-F238E27FC236}">
-                <a16:creationId xmlns:a16="http://schemas.microsoft.com/office/drawing/2014/main" id="{8D9FBDC6-A79C-4FEF-ABB1-F39E6AC944CE}"/>
+                <a16:creationId xmlns:a16="http://schemas.microsoft.com/office/drawing/2014/main" id="{38675BF7-4F60-4B6C-9851-6FF2C17F0671}"/>
               </a:ext>
             </a:extLst>
           </p:cNvPr>
@@ -14375,7 +14471,7 @@
           <p:cNvPr id="8" name="Positieve winst:&#10;400 &lt; Q ≤ 1.000&#10;&#10;Gehele aantallen:&#10;401 t/m ">
             <a:extLst xmlns:a="http://schemas.openxmlformats.org/drawingml/2006/main">
               <a:ext uri="{FF2B5EF4-FFF2-40B4-BE49-F238E27FC236}">
-                <a16:creationId xmlns:a16="http://schemas.microsoft.com/office/drawing/2014/main" id="{F2E701CF-6A6C-480B-A7D4-54DE80064756}"/>
+                <a16:creationId xmlns:a16="http://schemas.microsoft.com/office/drawing/2014/main" id="{1482AAD6-C07F-458D-B995-C9F03232B156}"/>
               </a:ext>
             </a:extLst>
           </p:cNvPr>
@@ -14504,7 +14600,7 @@
     </p:spTree>
     <p:extLst>
       <p:ext uri="{BB962C8B-B14F-4D97-AF65-F5344CB8AC3E}">
-        <p14:creationId xmlns:p14="http://schemas.microsoft.com/office/powerpoint/2010/main" val="1470743127"/>
+        <p14:creationId xmlns:p14="http://schemas.microsoft.com/office/powerpoint/2010/main" val="1125718001"/>
       </p:ext>
     </p:extLst>
   </p:cSld>
@@ -14535,7 +14631,7 @@
           <p:cNvPr id="16" name="De aanpak bij gemengde opgaven">
             <a:extLst xmlns:a="http://schemas.openxmlformats.org/drawingml/2006/main">
               <a:ext uri="{FF2B5EF4-FFF2-40B4-BE49-F238E27FC236}">
-                <a16:creationId xmlns:a16="http://schemas.microsoft.com/office/drawing/2014/main" id="{BA92E401-704C-4384-B120-817F9D51EC96}"/>
+                <a16:creationId xmlns:a16="http://schemas.microsoft.com/office/drawing/2014/main" id="{CC8E654A-FA58-431B-98B2-AF9C31FF96DD}"/>
               </a:ext>
             </a:extLst>
           </p:cNvPr>
@@ -14592,7 +14688,7 @@
           <p:cNvPr id="2" name="">
             <a:extLst xmlns:a="http://schemas.openxmlformats.org/drawingml/2006/main">
               <a:ext uri="{FF2B5EF4-FFF2-40B4-BE49-F238E27FC236}">
-                <a16:creationId xmlns:a16="http://schemas.microsoft.com/office/drawing/2014/main" id="{9EF13353-3CD6-4C88-A981-8AF6760F6312}"/>
+                <a16:creationId xmlns:a16="http://schemas.microsoft.com/office/drawing/2014/main" id="{90D9AA64-3FB0-4C25-A412-7446E6067DC6}"/>
               </a:ext>
             </a:extLst>
           </p:cNvPr>
@@ -14621,7 +14717,7 @@
           <p:cNvPr id="3" name="§2.1.4 Gemengde opgaven">
             <a:extLst xmlns:a="http://schemas.openxmlformats.org/drawingml/2006/main">
               <a:ext uri="{FF2B5EF4-FFF2-40B4-BE49-F238E27FC236}">
-                <a16:creationId xmlns:a16="http://schemas.microsoft.com/office/drawing/2014/main" id="{9D7EE9AC-73C5-42F6-B3E7-33E4C4FE0E0D}"/>
+                <a16:creationId xmlns:a16="http://schemas.microsoft.com/office/drawing/2014/main" id="{ADC53D17-6DA2-42B4-BC64-691587B0CBD1}"/>
               </a:ext>
             </a:extLst>
           </p:cNvPr>
@@ -14678,7 +14774,7 @@
           <p:cNvPr id="4" name="slide-number">
             <a:extLst xmlns:a="http://schemas.openxmlformats.org/drawingml/2006/main">
               <a:ext uri="{FF2B5EF4-FFF2-40B4-BE49-F238E27FC236}">
-                <a16:creationId xmlns:a16="http://schemas.microsoft.com/office/drawing/2014/main" id="{9B014601-A0F7-4767-82D4-D3A82DC40D7F}"/>
+                <a16:creationId xmlns:a16="http://schemas.microsoft.com/office/drawing/2014/main" id="{66309D4D-CEF2-4DD6-A55F-8E296C347CC2}"/>
               </a:ext>
             </a:extLst>
           </p:cNvPr>
@@ -14735,7 +14831,7 @@
           <p:cNvPr id="5" name="Gegevens kiezen">
             <a:extLst xmlns:a="http://schemas.openxmlformats.org/drawingml/2006/main">
               <a:ext uri="{FF2B5EF4-FFF2-40B4-BE49-F238E27FC236}">
-                <a16:creationId xmlns:a16="http://schemas.microsoft.com/office/drawing/2014/main" id="{ECA5CBB8-5B6E-4BA4-A501-7FFC7DDB88D2}"/>
+                <a16:creationId xmlns:a16="http://schemas.microsoft.com/office/drawing/2014/main" id="{4A630CAA-583C-4B48-8C6A-FA7E0E58AA3D}"/>
               </a:ext>
             </a:extLst>
           </p:cNvPr>
@@ -14792,7 +14888,7 @@
           <p:cNvPr id="6" name="Welke dag, hoeveelheid, periode en eenheid?">
             <a:extLst xmlns:a="http://schemas.openxmlformats.org/drawingml/2006/main">
               <a:ext uri="{FF2B5EF4-FFF2-40B4-BE49-F238E27FC236}">
-                <a16:creationId xmlns:a16="http://schemas.microsoft.com/office/drawing/2014/main" id="{0395DFEC-FCAD-41A9-9F86-76B29C5EA549}"/>
+                <a16:creationId xmlns:a16="http://schemas.microsoft.com/office/drawing/2014/main" id="{A6A6CEBE-2BA3-485C-A74B-257734DE4C62}"/>
               </a:ext>
             </a:extLst>
           </p:cNvPr>
@@ -14849,7 +14945,7 @@
           <p:cNvPr id="7" name="">
             <a:extLst xmlns:a="http://schemas.openxmlformats.org/drawingml/2006/main">
               <a:ext uri="{FF2B5EF4-FFF2-40B4-BE49-F238E27FC236}">
-                <a16:creationId xmlns:a16="http://schemas.microsoft.com/office/drawing/2014/main" id="{55A68440-2E08-4180-AA97-819006E37B8D}"/>
+                <a16:creationId xmlns:a16="http://schemas.microsoft.com/office/drawing/2014/main" id="{BFE2319E-1E10-4A6F-B29D-88FE52D2C309}"/>
               </a:ext>
             </a:extLst>
           </p:cNvPr>
@@ -14878,7 +14974,7 @@
           <p:cNvPr id="8" name="Bewerking kiezen">
             <a:extLst xmlns:a="http://schemas.openxmlformats.org/drawingml/2006/main">
               <a:ext uri="{FF2B5EF4-FFF2-40B4-BE49-F238E27FC236}">
-                <a16:creationId xmlns:a16="http://schemas.microsoft.com/office/drawing/2014/main" id="{BAED19B4-0E69-4CB1-B024-764A2A0780FB}"/>
+                <a16:creationId xmlns:a16="http://schemas.microsoft.com/office/drawing/2014/main" id="{296E44D4-4225-42D5-8A55-04DA6E47E981}"/>
               </a:ext>
             </a:extLst>
           </p:cNvPr>
@@ -14935,7 +15031,7 @@
           <p:cNvPr id="9" name="Totaal, per product of per extra product?">
             <a:extLst xmlns:a="http://schemas.openxmlformats.org/drawingml/2006/main">
               <a:ext uri="{FF2B5EF4-FFF2-40B4-BE49-F238E27FC236}">
-                <a16:creationId xmlns:a16="http://schemas.microsoft.com/office/drawing/2014/main" id="{61D0CE58-E277-4B98-8223-462BB16B7C70}"/>
+                <a16:creationId xmlns:a16="http://schemas.microsoft.com/office/drawing/2014/main" id="{98066C95-9F55-43C7-844A-B16BAE357F0E}"/>
               </a:ext>
             </a:extLst>
           </p:cNvPr>
@@ -14992,7 +15088,7 @@
           <p:cNvPr id="10" name="">
             <a:extLst xmlns:a="http://schemas.openxmlformats.org/drawingml/2006/main">
               <a:ext uri="{FF2B5EF4-FFF2-40B4-BE49-F238E27FC236}">
-                <a16:creationId xmlns:a16="http://schemas.microsoft.com/office/drawing/2014/main" id="{52638F73-2239-4A70-B39F-AE0AD4BE28CA}"/>
+                <a16:creationId xmlns:a16="http://schemas.microsoft.com/office/drawing/2014/main" id="{98FFABAD-FFBF-409F-B8F4-DC6974245688}"/>
               </a:ext>
             </a:extLst>
           </p:cNvPr>
@@ -15021,7 +15117,7 @@
           <p:cNvPr id="11" name="Tabel en grafiek">
             <a:extLst xmlns:a="http://schemas.openxmlformats.org/drawingml/2006/main">
               <a:ext uri="{FF2B5EF4-FFF2-40B4-BE49-F238E27FC236}">
-                <a16:creationId xmlns:a16="http://schemas.microsoft.com/office/drawing/2014/main" id="{C4B8AD70-4819-46BB-AC6B-DAC95CFF25C6}"/>
+                <a16:creationId xmlns:a16="http://schemas.microsoft.com/office/drawing/2014/main" id="{8A194129-0E80-416B-A75E-FA81CBDD13EF}"/>
               </a:ext>
             </a:extLst>
           </p:cNvPr>
@@ -15078,7 +15174,7 @@
           <p:cNvPr id="12" name="Tabelwaarden en lijnhoogten beschrijven dezelfde bedragen.">
             <a:extLst xmlns:a="http://schemas.openxmlformats.org/drawingml/2006/main">
               <a:ext uri="{FF2B5EF4-FFF2-40B4-BE49-F238E27FC236}">
-                <a16:creationId xmlns:a16="http://schemas.microsoft.com/office/drawing/2014/main" id="{17D39DFC-3BE0-423E-BE21-B64425D7D6AA}"/>
+                <a16:creationId xmlns:a16="http://schemas.microsoft.com/office/drawing/2014/main" id="{4E7C4DF9-5CBA-42B0-87B3-E25843CA46BE}"/>
               </a:ext>
             </a:extLst>
           </p:cNvPr>
@@ -15135,7 +15231,7 @@
           <p:cNvPr id="13" name="">
             <a:extLst xmlns:a="http://schemas.openxmlformats.org/drawingml/2006/main">
               <a:ext uri="{FF2B5EF4-FFF2-40B4-BE49-F238E27FC236}">
-                <a16:creationId xmlns:a16="http://schemas.microsoft.com/office/drawing/2014/main" id="{33A6DBAD-6DE1-4C8F-9612-B3CFD9C5C9B1}"/>
+                <a16:creationId xmlns:a16="http://schemas.microsoft.com/office/drawing/2014/main" id="{18306B27-9AA9-45C3-9EA7-50523DBA440B}"/>
               </a:ext>
             </a:extLst>
           </p:cNvPr>
@@ -15164,7 +15260,7 @@
           <p:cNvPr id="14" name="Uitspraak beoordelen">
             <a:extLst xmlns:a="http://schemas.openxmlformats.org/drawingml/2006/main">
               <a:ext uri="{FF2B5EF4-FFF2-40B4-BE49-F238E27FC236}">
-                <a16:creationId xmlns:a16="http://schemas.microsoft.com/office/drawing/2014/main" id="{22852191-CE79-4564-AB87-5261D286EF7C}"/>
+                <a16:creationId xmlns:a16="http://schemas.microsoft.com/office/drawing/2014/main" id="{82F4CA18-C8C0-4965-94E3-7D102744404A}"/>
               </a:ext>
             </a:extLst>
           </p:cNvPr>
@@ -15221,7 +15317,7 @@
           <p:cNvPr id="15" name="Berekening, economische betekenis en conclusie.">
             <a:extLst xmlns:a="http://schemas.openxmlformats.org/drawingml/2006/main">
               <a:ext uri="{FF2B5EF4-FFF2-40B4-BE49-F238E27FC236}">
-                <a16:creationId xmlns:a16="http://schemas.microsoft.com/office/drawing/2014/main" id="{146CD573-0B1B-4D3A-AAF0-44545265E7AE}"/>
+                <a16:creationId xmlns:a16="http://schemas.microsoft.com/office/drawing/2014/main" id="{7CC78BFF-F754-4DF1-AD00-BDD8F788E723}"/>
               </a:ext>
             </a:extLst>
           </p:cNvPr>
@@ -15276,7 +15372,7 @@
     </p:spTree>
     <p:extLst>
       <p:ext uri="{BB962C8B-B14F-4D97-AF65-F5344CB8AC3E}">
-        <p14:creationId xmlns:p14="http://schemas.microsoft.com/office/powerpoint/2010/main" val="64376959"/>
+        <p14:creationId xmlns:p14="http://schemas.microsoft.com/office/powerpoint/2010/main" val="701626276"/>
       </p:ext>
     </p:extLst>
   </p:cSld>
@@ -15307,7 +15403,7 @@
           <p:cNvPr id="9" name="Opgave 5e · De winstafstand bij 700">
             <a:extLst xmlns:a="http://schemas.openxmlformats.org/drawingml/2006/main">
               <a:ext uri="{FF2B5EF4-FFF2-40B4-BE49-F238E27FC236}">
-                <a16:creationId xmlns:a16="http://schemas.microsoft.com/office/drawing/2014/main" id="{3C087D02-4647-4635-8C24-A841F06F05DC}"/>
+                <a16:creationId xmlns:a16="http://schemas.microsoft.com/office/drawing/2014/main" id="{266EDC12-08BD-484D-B78D-C6D1B1CE816D}"/>
               </a:ext>
             </a:extLst>
           </p:cNvPr>
@@ -15364,7 +15460,7 @@
           <p:cNvPr id="2" name="">
             <a:extLst xmlns:a="http://schemas.openxmlformats.org/drawingml/2006/main">
               <a:ext uri="{FF2B5EF4-FFF2-40B4-BE49-F238E27FC236}">
-                <a16:creationId xmlns:a16="http://schemas.microsoft.com/office/drawing/2014/main" id="{9F385BD1-93B0-4113-83AE-BE212843CFB0}"/>
+                <a16:creationId xmlns:a16="http://schemas.microsoft.com/office/drawing/2014/main" id="{8C53B5D8-92FE-4CC1-B77A-618C5CDD2D4A}"/>
               </a:ext>
             </a:extLst>
           </p:cNvPr>
@@ -15393,7 +15489,7 @@
           <p:cNvPr id="3" name="§2.1.4 Gemengde opgaven · Opgave 5 · Boekpagina 32–33">
             <a:extLst xmlns:a="http://schemas.openxmlformats.org/drawingml/2006/main">
               <a:ext uri="{FF2B5EF4-FFF2-40B4-BE49-F238E27FC236}">
-                <a16:creationId xmlns:a16="http://schemas.microsoft.com/office/drawing/2014/main" id="{90D6434F-4555-40D9-A3FA-0807F931C86A}"/>
+                <a16:creationId xmlns:a16="http://schemas.microsoft.com/office/drawing/2014/main" id="{6B8D2B0B-4396-4A98-9854-241A686E5ADE}"/>
               </a:ext>
             </a:extLst>
           </p:cNvPr>
@@ -15450,7 +15546,7 @@
           <p:cNvPr id="4" name="slide-number">
             <a:extLst xmlns:a="http://schemas.openxmlformats.org/drawingml/2006/main">
               <a:ext uri="{FF2B5EF4-FFF2-40B4-BE49-F238E27FC236}">
-                <a16:creationId xmlns:a16="http://schemas.microsoft.com/office/drawing/2014/main" id="{4762A74E-D881-4401-BCC7-E6F98309A5BC}"/>
+                <a16:creationId xmlns:a16="http://schemas.microsoft.com/office/drawing/2014/main" id="{C2350D1C-B51C-46E0-BCED-B4F6FB1A50DD}"/>
               </a:ext>
             </a:extLst>
           </p:cNvPr>
@@ -15514,7 +15610,7 @@
         </p:xfrm>
         <a:graphic xmlns:a="http://schemas.openxmlformats.org/drawingml/2006/main">
           <a:graphicData uri="http://schemas.openxmlformats.org/drawingml/2006/chart">
-            <c:chart xmlns:r="http://schemas.openxmlformats.org/officeDocument/2006/relationships" xmlns:c="http://schemas.openxmlformats.org/drawingml/2006/chart" r:id="R0707b678350c4a8e"/>
+            <c:chart xmlns:r="http://schemas.openxmlformats.org/officeDocument/2006/relationships" xmlns:c="http://schemas.openxmlformats.org/drawingml/2006/chart" r:id="R25cb0ff2c4c94feb"/>
           </a:graphicData>
         </a:graphic>
       </p:graphicFrame>
@@ -15523,7 +15619,7 @@
           <p:cNvPr id="6" name="Bij Q = 700">
             <a:extLst xmlns:a="http://schemas.openxmlformats.org/drawingml/2006/main">
               <a:ext uri="{FF2B5EF4-FFF2-40B4-BE49-F238E27FC236}">
-                <a16:creationId xmlns:a16="http://schemas.microsoft.com/office/drawing/2014/main" id="{622D200B-C6F2-4478-87FF-48651182953D}"/>
+                <a16:creationId xmlns:a16="http://schemas.microsoft.com/office/drawing/2014/main" id="{8F600145-8F8C-4F33-9F2C-4D2490934A10}"/>
               </a:ext>
             </a:extLst>
           </p:cNvPr>
@@ -15580,7 +15676,7 @@
           <p:cNvPr id="7" name="TO = € 3.500&#10;TK = € 2.600">
             <a:extLst xmlns:a="http://schemas.openxmlformats.org/drawingml/2006/main">
               <a:ext uri="{FF2B5EF4-FFF2-40B4-BE49-F238E27FC236}">
-                <a16:creationId xmlns:a16="http://schemas.microsoft.com/office/drawing/2014/main" id="{A6272D42-5DA4-4878-809A-20995C0653C4}"/>
+                <a16:creationId xmlns:a16="http://schemas.microsoft.com/office/drawing/2014/main" id="{EAB5A674-8FCC-469D-95CA-E763986D133B}"/>
               </a:ext>
             </a:extLst>
           </p:cNvPr>
@@ -15660,7 +15756,7 @@
           <p:cNvPr id="8" name="Verticale afstand:&#10;€ 900 per dag&#10;&#10;Op beide dagen&#10;bij deze Q.">
             <a:extLst xmlns:a="http://schemas.openxmlformats.org/drawingml/2006/main">
               <a:ext uri="{FF2B5EF4-FFF2-40B4-BE49-F238E27FC236}">
-                <a16:creationId xmlns:a16="http://schemas.microsoft.com/office/drawing/2014/main" id="{F0F7E97B-AED0-432D-92B9-02C4A1EA6039}"/>
+                <a16:creationId xmlns:a16="http://schemas.microsoft.com/office/drawing/2014/main" id="{84326130-B6E2-4DD6-8ED5-EAF631F6B2D9}"/>
               </a:ext>
             </a:extLst>
           </p:cNvPr>
@@ -15789,7 +15885,7 @@
     </p:spTree>
     <p:extLst>
       <p:ext uri="{BB962C8B-B14F-4D97-AF65-F5344CB8AC3E}">
-        <p14:creationId xmlns:p14="http://schemas.microsoft.com/office/powerpoint/2010/main" val="829586672"/>
+        <p14:creationId xmlns:p14="http://schemas.microsoft.com/office/powerpoint/2010/main" val="422293868"/>
       </p:ext>
     </p:extLst>
   </p:cSld>
@@ -15820,7 +15916,7 @@
           <p:cNvPr id="8" name="Opgave 5e · Waar groeit de winst sneller?">
             <a:extLst xmlns:a="http://schemas.openxmlformats.org/drawingml/2006/main">
               <a:ext uri="{FF2B5EF4-FFF2-40B4-BE49-F238E27FC236}">
-                <a16:creationId xmlns:a16="http://schemas.microsoft.com/office/drawing/2014/main" id="{85FAFD0D-3915-4421-B908-0734C869FC07}"/>
+                <a16:creationId xmlns:a16="http://schemas.microsoft.com/office/drawing/2014/main" id="{6F87E968-CA1E-4E54-954E-D6AB2661A1B2}"/>
               </a:ext>
             </a:extLst>
           </p:cNvPr>
@@ -15877,7 +15973,7 @@
           <p:cNvPr id="2" name="">
             <a:extLst xmlns:a="http://schemas.openxmlformats.org/drawingml/2006/main">
               <a:ext uri="{FF2B5EF4-FFF2-40B4-BE49-F238E27FC236}">
-                <a16:creationId xmlns:a16="http://schemas.microsoft.com/office/drawing/2014/main" id="{14579825-FFC2-42AE-86B1-84C55BB2C13F}"/>
+                <a16:creationId xmlns:a16="http://schemas.microsoft.com/office/drawing/2014/main" id="{F0039BBA-F9E2-4944-879D-474087B07D38}"/>
               </a:ext>
             </a:extLst>
           </p:cNvPr>
@@ -15906,7 +16002,7 @@
           <p:cNvPr id="3" name="§2.1.4 Gemengde opgaven · Opgave 5 · Boekpagina 32–33">
             <a:extLst xmlns:a="http://schemas.openxmlformats.org/drawingml/2006/main">
               <a:ext uri="{FF2B5EF4-FFF2-40B4-BE49-F238E27FC236}">
-                <a16:creationId xmlns:a16="http://schemas.microsoft.com/office/drawing/2014/main" id="{491D544E-85CC-4C96-8325-2BCE942838B5}"/>
+                <a16:creationId xmlns:a16="http://schemas.microsoft.com/office/drawing/2014/main" id="{0F22DF52-16E2-4152-9AD8-3F72C22D7774}"/>
               </a:ext>
             </a:extLst>
           </p:cNvPr>
@@ -15963,7 +16059,7 @@
           <p:cNvPr id="4" name="slide-number">
             <a:extLst xmlns:a="http://schemas.openxmlformats.org/drawingml/2006/main">
               <a:ext uri="{FF2B5EF4-FFF2-40B4-BE49-F238E27FC236}">
-                <a16:creationId xmlns:a16="http://schemas.microsoft.com/office/drawing/2014/main" id="{DA17DFF1-CD73-4EC6-850E-BF1CB5B70B76}"/>
+                <a16:creationId xmlns:a16="http://schemas.microsoft.com/office/drawing/2014/main" id="{F88CAD0F-6003-42E0-8A1B-6F8C9CD5AC0E}"/>
               </a:ext>
             </a:extLst>
           </p:cNvPr>
@@ -16020,7 +16116,7 @@
           <p:cNvPr id="5" name="Groei van de winst per extra lunchbox = MO − MK">
             <a:extLst xmlns:a="http://schemas.openxmlformats.org/drawingml/2006/main">
               <a:ext uri="{FF2B5EF4-FFF2-40B4-BE49-F238E27FC236}">
-                <a16:creationId xmlns:a16="http://schemas.microsoft.com/office/drawing/2014/main" id="{2B699841-EDC3-42C9-915C-BD3F3DAEEF59}"/>
+                <a16:creationId xmlns:a16="http://schemas.microsoft.com/office/drawing/2014/main" id="{4072592B-B463-40DC-8353-F6AF6FFFE663}"/>
               </a:ext>
             </a:extLst>
           </p:cNvPr>
@@ -16470,7 +16566,7 @@
           <p:cNvPr id="7" name="Vrijdag groeit de positieve winstafstand het snelst:&#10;meer da">
             <a:extLst xmlns:a="http://schemas.openxmlformats.org/drawingml/2006/main">
               <a:ext uri="{FF2B5EF4-FFF2-40B4-BE49-F238E27FC236}">
-                <a16:creationId xmlns:a16="http://schemas.microsoft.com/office/drawing/2014/main" id="{C2516D4D-5740-4290-8900-F9D2A687B8A5}"/>
+                <a16:creationId xmlns:a16="http://schemas.microsoft.com/office/drawing/2014/main" id="{F56EBDD8-0F40-424F-805A-E4502E1ABFFE}"/>
               </a:ext>
             </a:extLst>
           </p:cNvPr>
@@ -16548,7 +16644,7 @@
     </p:spTree>
     <p:extLst>
       <p:ext uri="{BB962C8B-B14F-4D97-AF65-F5344CB8AC3E}">
-        <p14:creationId xmlns:p14="http://schemas.microsoft.com/office/powerpoint/2010/main" val="1409090153"/>
+        <p14:creationId xmlns:p14="http://schemas.microsoft.com/office/powerpoint/2010/main" val="2013155930"/>
       </p:ext>
     </p:extLst>
   </p:cSld>
@@ -16579,7 +16675,7 @@
           <p:cNvPr id="9" name="Opgave 5f · Gelijke extra omzet, andere winst">
             <a:extLst xmlns:a="http://schemas.openxmlformats.org/drawingml/2006/main">
               <a:ext uri="{FF2B5EF4-FFF2-40B4-BE49-F238E27FC236}">
-                <a16:creationId xmlns:a16="http://schemas.microsoft.com/office/drawing/2014/main" id="{124B6DBF-4152-42E7-82F2-7FA9854FA3B8}"/>
+                <a16:creationId xmlns:a16="http://schemas.microsoft.com/office/drawing/2014/main" id="{B2FFBF3B-E4D3-412D-9DC9-804592102BC9}"/>
               </a:ext>
             </a:extLst>
           </p:cNvPr>
@@ -16636,7 +16732,7 @@
           <p:cNvPr id="2" name="">
             <a:extLst xmlns:a="http://schemas.openxmlformats.org/drawingml/2006/main">
               <a:ext uri="{FF2B5EF4-FFF2-40B4-BE49-F238E27FC236}">
-                <a16:creationId xmlns:a16="http://schemas.microsoft.com/office/drawing/2014/main" id="{90ACE923-B3B0-45B1-A0F0-88CBEC580445}"/>
+                <a16:creationId xmlns:a16="http://schemas.microsoft.com/office/drawing/2014/main" id="{0762C89E-70AE-4714-9B68-C92AF471572D}"/>
               </a:ext>
             </a:extLst>
           </p:cNvPr>
@@ -16665,7 +16761,7 @@
           <p:cNvPr id="3" name="§2.1.4 Gemengde opgaven · Opgave 5 · Boekpagina 32–33">
             <a:extLst xmlns:a="http://schemas.openxmlformats.org/drawingml/2006/main">
               <a:ext uri="{FF2B5EF4-FFF2-40B4-BE49-F238E27FC236}">
-                <a16:creationId xmlns:a16="http://schemas.microsoft.com/office/drawing/2014/main" id="{5F4B5961-B586-4295-8863-7634AC7B2A73}"/>
+                <a16:creationId xmlns:a16="http://schemas.microsoft.com/office/drawing/2014/main" id="{B25040FE-1A56-4537-940A-BFC5FFFEF3B3}"/>
               </a:ext>
             </a:extLst>
           </p:cNvPr>
@@ -16722,7 +16818,7 @@
           <p:cNvPr id="4" name="slide-number">
             <a:extLst xmlns:a="http://schemas.openxmlformats.org/drawingml/2006/main">
               <a:ext uri="{FF2B5EF4-FFF2-40B4-BE49-F238E27FC236}">
-                <a16:creationId xmlns:a16="http://schemas.microsoft.com/office/drawing/2014/main" id="{CF6E3913-E69C-459D-8DA2-9C312F320F5B}"/>
+                <a16:creationId xmlns:a16="http://schemas.microsoft.com/office/drawing/2014/main" id="{C4B85904-1589-4EF6-92DB-4A83A5F2EBFD}"/>
               </a:ext>
             </a:extLst>
           </p:cNvPr>
@@ -16779,7 +16875,7 @@
           <p:cNvPr id="5" name="Extra winst = ΔTO − ΔTK = (MO − MK) × ΔQ">
             <a:extLst xmlns:a="http://schemas.openxmlformats.org/drawingml/2006/main">
               <a:ext uri="{FF2B5EF4-FFF2-40B4-BE49-F238E27FC236}">
-                <a16:creationId xmlns:a16="http://schemas.microsoft.com/office/drawing/2014/main" id="{2DE130A0-D338-46ED-9837-A87785172A79}"/>
+                <a16:creationId xmlns:a16="http://schemas.microsoft.com/office/drawing/2014/main" id="{BA2B8FF8-B82C-4066-B5DA-C503D62ED1D6}"/>
               </a:ext>
             </a:extLst>
           </p:cNvPr>
@@ -17155,7 +17251,7 @@
           <p:cNvPr id="7" name="De uitspraak is onjuist.">
             <a:extLst xmlns:a="http://schemas.openxmlformats.org/drawingml/2006/main">
               <a:ext uri="{FF2B5EF4-FFF2-40B4-BE49-F238E27FC236}">
-                <a16:creationId xmlns:a16="http://schemas.microsoft.com/office/drawing/2014/main" id="{26C3F684-996E-40E2-BD0E-9C1B8CE71E83}"/>
+                <a16:creationId xmlns:a16="http://schemas.microsoft.com/office/drawing/2014/main" id="{D8036ACD-10B1-40DD-946C-D62C5C249600}"/>
               </a:ext>
             </a:extLst>
           </p:cNvPr>
@@ -17212,7 +17308,7 @@
           <p:cNvPr id="8" name="Elke groep levert € 500 extra omzet, maar vraagt meer extra ">
             <a:extLst xmlns:a="http://schemas.openxmlformats.org/drawingml/2006/main">
               <a:ext uri="{FF2B5EF4-FFF2-40B4-BE49-F238E27FC236}">
-                <a16:creationId xmlns:a16="http://schemas.microsoft.com/office/drawing/2014/main" id="{C352BF85-E64E-416C-9406-6750A604650C}"/>
+                <a16:creationId xmlns:a16="http://schemas.microsoft.com/office/drawing/2014/main" id="{1BFD89FE-09A6-43F7-99D8-A4F73728D772}"/>
               </a:ext>
             </a:extLst>
           </p:cNvPr>
@@ -17267,7 +17363,7 @@
     </p:spTree>
     <p:extLst>
       <p:ext uri="{BB962C8B-B14F-4D97-AF65-F5344CB8AC3E}">
-        <p14:creationId xmlns:p14="http://schemas.microsoft.com/office/powerpoint/2010/main" val="98488270"/>
+        <p14:creationId xmlns:p14="http://schemas.microsoft.com/office/powerpoint/2010/main" val="508256737"/>
       </p:ext>
     </p:extLst>
   </p:cSld>
@@ -17298,7 +17394,7 @@
           <p:cNvPr id="14" name="Antwoordcontrole bij SmoothBox">
             <a:extLst xmlns:a="http://schemas.openxmlformats.org/drawingml/2006/main">
               <a:ext uri="{FF2B5EF4-FFF2-40B4-BE49-F238E27FC236}">
-                <a16:creationId xmlns:a16="http://schemas.microsoft.com/office/drawing/2014/main" id="{64DB0DB5-E9FE-47F4-8FBE-CEE26CE919C9}"/>
+                <a16:creationId xmlns:a16="http://schemas.microsoft.com/office/drawing/2014/main" id="{91E716E5-C38E-4484-8ADE-99EFA42725AB}"/>
               </a:ext>
             </a:extLst>
           </p:cNvPr>
@@ -17355,7 +17451,7 @@
           <p:cNvPr id="2" name="">
             <a:extLst xmlns:a="http://schemas.openxmlformats.org/drawingml/2006/main">
               <a:ext uri="{FF2B5EF4-FFF2-40B4-BE49-F238E27FC236}">
-                <a16:creationId xmlns:a16="http://schemas.microsoft.com/office/drawing/2014/main" id="{8F36BC34-55C9-41FB-8B74-1E630024B0F7}"/>
+                <a16:creationId xmlns:a16="http://schemas.microsoft.com/office/drawing/2014/main" id="{009CF18B-8F0A-477F-B0D2-2BBDEA101611}"/>
               </a:ext>
             </a:extLst>
           </p:cNvPr>
@@ -17384,7 +17480,7 @@
           <p:cNvPr id="3" name="§2.1.4 Gemengde opgaven">
             <a:extLst xmlns:a="http://schemas.openxmlformats.org/drawingml/2006/main">
               <a:ext uri="{FF2B5EF4-FFF2-40B4-BE49-F238E27FC236}">
-                <a16:creationId xmlns:a16="http://schemas.microsoft.com/office/drawing/2014/main" id="{7135A40F-C335-45EB-8FBA-B1A2ADB773B8}"/>
+                <a16:creationId xmlns:a16="http://schemas.microsoft.com/office/drawing/2014/main" id="{2311E7CB-8F91-4972-B9B5-EB54EA704584}"/>
               </a:ext>
             </a:extLst>
           </p:cNvPr>
@@ -17441,7 +17537,7 @@
           <p:cNvPr id="4" name="slide-number">
             <a:extLst xmlns:a="http://schemas.openxmlformats.org/drawingml/2006/main">
               <a:ext uri="{FF2B5EF4-FFF2-40B4-BE49-F238E27FC236}">
-                <a16:creationId xmlns:a16="http://schemas.microsoft.com/office/drawing/2014/main" id="{A551405A-4C72-4A86-9FF6-7B0470C4981E}"/>
+                <a16:creationId xmlns:a16="http://schemas.microsoft.com/office/drawing/2014/main" id="{8383B30A-3697-498C-8160-854D4C6A3C8C}"/>
               </a:ext>
             </a:extLst>
           </p:cNvPr>
@@ -17498,7 +17594,7 @@
           <p:cNvPr id="5" name="Bron en eenheid">
             <a:extLst xmlns:a="http://schemas.openxmlformats.org/drawingml/2006/main">
               <a:ext uri="{FF2B5EF4-FFF2-40B4-BE49-F238E27FC236}">
-                <a16:creationId xmlns:a16="http://schemas.microsoft.com/office/drawing/2014/main" id="{15D99EDB-E936-490C-8C92-D71550A53390}"/>
+                <a16:creationId xmlns:a16="http://schemas.microsoft.com/office/drawing/2014/main" id="{35B59E8E-AF3E-47FE-8E0A-494A62FB290A}"/>
               </a:ext>
             </a:extLst>
           </p:cNvPr>
@@ -17555,7 +17651,7 @@
           <p:cNvPr id="6" name="Vrijdag bij a–c, zaterdag bij d en f, beide dagen bij e.">
             <a:extLst xmlns:a="http://schemas.openxmlformats.org/drawingml/2006/main">
               <a:ext uri="{FF2B5EF4-FFF2-40B4-BE49-F238E27FC236}">
-                <a16:creationId xmlns:a16="http://schemas.microsoft.com/office/drawing/2014/main" id="{311CC2F1-B9AD-4F2D-A336-6D1DB0477CCA}"/>
+                <a16:creationId xmlns:a16="http://schemas.microsoft.com/office/drawing/2014/main" id="{C9DD9427-05D7-4BC6-A92C-80B378E2F2F2}"/>
               </a:ext>
             </a:extLst>
           </p:cNvPr>
@@ -17612,7 +17708,7 @@
           <p:cNvPr id="7" name="Berekeningen">
             <a:extLst xmlns:a="http://schemas.openxmlformats.org/drawingml/2006/main">
               <a:ext uri="{FF2B5EF4-FFF2-40B4-BE49-F238E27FC236}">
-                <a16:creationId xmlns:a16="http://schemas.microsoft.com/office/drawing/2014/main" id="{6C1E83B8-96E1-4B48-8921-54E6A2DA2FB0}"/>
+                <a16:creationId xmlns:a16="http://schemas.microsoft.com/office/drawing/2014/main" id="{7C075E41-4BC9-47BD-8AEA-ED6DA30845C1}"/>
               </a:ext>
             </a:extLst>
           </p:cNvPr>
@@ -17669,7 +17765,7 @@
           <p:cNvPr id="8" name="Formule, ingevulde getallen en volledige eenheid.">
             <a:extLst xmlns:a="http://schemas.openxmlformats.org/drawingml/2006/main">
               <a:ext uri="{FF2B5EF4-FFF2-40B4-BE49-F238E27FC236}">
-                <a16:creationId xmlns:a16="http://schemas.microsoft.com/office/drawing/2014/main" id="{ED20679E-1F8A-46AB-A66A-AE636FE9AAD5}"/>
+                <a16:creationId xmlns:a16="http://schemas.microsoft.com/office/drawing/2014/main" id="{9EFB0F42-677B-4398-98C6-DB6A84A01F31}"/>
               </a:ext>
             </a:extLst>
           </p:cNvPr>
@@ -17726,7 +17822,7 @@
           <p:cNvPr id="9" name="Grafiek">
             <a:extLst xmlns:a="http://schemas.openxmlformats.org/drawingml/2006/main">
               <a:ext uri="{FF2B5EF4-FFF2-40B4-BE49-F238E27FC236}">
-                <a16:creationId xmlns:a16="http://schemas.microsoft.com/office/drawing/2014/main" id="{D2319455-1CD3-4310-BB21-96D34C6D2171}"/>
+                <a16:creationId xmlns:a16="http://schemas.microsoft.com/office/drawing/2014/main" id="{4E04F38E-CC58-42EE-8720-35625A952754}"/>
               </a:ext>
             </a:extLst>
           </p:cNvPr>
@@ -17783,7 +17879,7 @@
           <p:cNvPr id="10" name="(400; 2.000), positieve winst en de groei per extra lunchbox">
             <a:extLst xmlns:a="http://schemas.openxmlformats.org/drawingml/2006/main">
               <a:ext uri="{FF2B5EF4-FFF2-40B4-BE49-F238E27FC236}">
-                <a16:creationId xmlns:a16="http://schemas.microsoft.com/office/drawing/2014/main" id="{7659E108-9610-4C16-BD20-20D825569CB3}"/>
+                <a16:creationId xmlns:a16="http://schemas.microsoft.com/office/drawing/2014/main" id="{B9DF8572-8368-44FF-8C46-C91C1B293EBA}"/>
               </a:ext>
             </a:extLst>
           </p:cNvPr>
@@ -17840,7 +17936,7 @@
           <p:cNvPr id="11" name="Redenering">
             <a:extLst xmlns:a="http://schemas.openxmlformats.org/drawingml/2006/main">
               <a:ext uri="{FF2B5EF4-FFF2-40B4-BE49-F238E27FC236}">
-                <a16:creationId xmlns:a16="http://schemas.microsoft.com/office/drawing/2014/main" id="{A6FD9DA5-9C91-4B8C-BE0C-3FC09D0E3B22}"/>
+                <a16:creationId xmlns:a16="http://schemas.microsoft.com/office/drawing/2014/main" id="{CF66546D-3438-4037-9291-41C655EAF91F}"/>
               </a:ext>
             </a:extLst>
           </p:cNvPr>
@@ -17897,7 +17993,7 @@
           <p:cNvPr id="12" name="Gelijke extra omzet geeft bij stijgende MK minder extra wins">
             <a:extLst xmlns:a="http://schemas.openxmlformats.org/drawingml/2006/main">
               <a:ext uri="{FF2B5EF4-FFF2-40B4-BE49-F238E27FC236}">
-                <a16:creationId xmlns:a16="http://schemas.microsoft.com/office/drawing/2014/main" id="{0470B660-073D-417B-B289-1FA69775AB37}"/>
+                <a16:creationId xmlns:a16="http://schemas.microsoft.com/office/drawing/2014/main" id="{AAA857A5-5B55-4EEC-AEED-A144DC117771}"/>
               </a:ext>
             </a:extLst>
           </p:cNvPr>
@@ -17954,7 +18050,7 @@
           <p:cNvPr id="13" name="Verbeter één ontbrekende stap of uitleg in je eigen antwoord">
             <a:extLst xmlns:a="http://schemas.openxmlformats.org/drawingml/2006/main">
               <a:ext uri="{FF2B5EF4-FFF2-40B4-BE49-F238E27FC236}">
-                <a16:creationId xmlns:a16="http://schemas.microsoft.com/office/drawing/2014/main" id="{F97AE78A-9138-4255-86B1-581B7D384DB9}"/>
+                <a16:creationId xmlns:a16="http://schemas.microsoft.com/office/drawing/2014/main" id="{362D0F70-4CAF-4FAC-8906-8989C154C60B}"/>
               </a:ext>
             </a:extLst>
           </p:cNvPr>
@@ -18009,7 +18105,7 @@
     </p:spTree>
     <p:extLst>
       <p:ext uri="{BB962C8B-B14F-4D97-AF65-F5344CB8AC3E}">
-        <p14:creationId xmlns:p14="http://schemas.microsoft.com/office/powerpoint/2010/main" val="799628786"/>
+        <p14:creationId xmlns:p14="http://schemas.microsoft.com/office/powerpoint/2010/main" val="256089805"/>
       </p:ext>
     </p:extLst>
   </p:cSld>
@@ -18040,7 +18136,7 @@
           <p:cNvPr id="29" name="Deze les: §2.1.4 Gemengde opgaven">
             <a:extLst xmlns:a="http://schemas.openxmlformats.org/drawingml/2006/main">
               <a:ext uri="{FF2B5EF4-FFF2-40B4-BE49-F238E27FC236}">
-                <a16:creationId xmlns:a16="http://schemas.microsoft.com/office/drawing/2014/main" id="{0F53A0DA-5D80-4748-A11D-3518A2E17143}"/>
+                <a16:creationId xmlns:a16="http://schemas.microsoft.com/office/drawing/2014/main" id="{67814A60-1E0B-4CFA-80C1-020D9EF7E076}"/>
               </a:ext>
             </a:extLst>
           </p:cNvPr>
@@ -18097,7 +18193,7 @@
           <p:cNvPr id="2" name="">
             <a:extLst xmlns:a="http://schemas.openxmlformats.org/drawingml/2006/main">
               <a:ext uri="{FF2B5EF4-FFF2-40B4-BE49-F238E27FC236}">
-                <a16:creationId xmlns:a16="http://schemas.microsoft.com/office/drawing/2014/main" id="{F3389199-D5E9-4099-B75A-236B5D10B058}"/>
+                <a16:creationId xmlns:a16="http://schemas.microsoft.com/office/drawing/2014/main" id="{81F8F05C-9C57-4029-A827-BC6577FA8A3B}"/>
               </a:ext>
             </a:extLst>
           </p:cNvPr>
@@ -18126,7 +18222,7 @@
           <p:cNvPr id="3" name="§2.1.4 Gemengde opgaven">
             <a:extLst xmlns:a="http://schemas.openxmlformats.org/drawingml/2006/main">
               <a:ext uri="{FF2B5EF4-FFF2-40B4-BE49-F238E27FC236}">
-                <a16:creationId xmlns:a16="http://schemas.microsoft.com/office/drawing/2014/main" id="{711C4A59-C1E9-455E-B23B-0E936E4987AA}"/>
+                <a16:creationId xmlns:a16="http://schemas.microsoft.com/office/drawing/2014/main" id="{576B899C-EFA4-4C4D-B281-981F8B3954EC}"/>
               </a:ext>
             </a:extLst>
           </p:cNvPr>
@@ -18183,7 +18279,7 @@
           <p:cNvPr id="4" name="slide-number">
             <a:extLst xmlns:a="http://schemas.openxmlformats.org/drawingml/2006/main">
               <a:ext uri="{FF2B5EF4-FFF2-40B4-BE49-F238E27FC236}">
-                <a16:creationId xmlns:a16="http://schemas.microsoft.com/office/drawing/2014/main" id="{0ECE9E12-C3EF-4028-B978-CC244942BBA7}"/>
+                <a16:creationId xmlns:a16="http://schemas.microsoft.com/office/drawing/2014/main" id="{75543036-1EB1-4D37-9FC3-B715BF5E9E18}"/>
               </a:ext>
             </a:extLst>
           </p:cNvPr>
@@ -18240,7 +18336,7 @@
           <p:cNvPr id="5" name="phase">
             <a:extLst xmlns:a="http://schemas.openxmlformats.org/drawingml/2006/main">
               <a:ext uri="{FF2B5EF4-FFF2-40B4-BE49-F238E27FC236}">
-                <a16:creationId xmlns:a16="http://schemas.microsoft.com/office/drawing/2014/main" id="{2A3046B4-26D4-47C7-A764-A3B5D130FAB8}"/>
+                <a16:creationId xmlns:a16="http://schemas.microsoft.com/office/drawing/2014/main" id="{5987B3C5-43C7-4630-A340-36BB971E9A3D}"/>
               </a:ext>
             </a:extLst>
           </p:cNvPr>
@@ -18297,7 +18393,7 @@
           <p:cNvPr id="6" name="Lesroute">
             <a:extLst xmlns:a="http://schemas.openxmlformats.org/drawingml/2006/main">
               <a:ext uri="{FF2B5EF4-FFF2-40B4-BE49-F238E27FC236}">
-                <a16:creationId xmlns:a16="http://schemas.microsoft.com/office/drawing/2014/main" id="{6B2EA2C7-73AF-474D-96EF-ABD4E26B4E1A}"/>
+                <a16:creationId xmlns:a16="http://schemas.microsoft.com/office/drawing/2014/main" id="{8B9DC60F-ED53-4CC9-86CB-0D0E1827CB2C}"/>
               </a:ext>
             </a:extLst>
           </p:cNvPr>
@@ -18354,7 +18450,7 @@
           <p:cNvPr id="7" name="route-number-1">
             <a:extLst xmlns:a="http://schemas.openxmlformats.org/drawingml/2006/main">
               <a:ext uri="{FF2B5EF4-FFF2-40B4-BE49-F238E27FC236}">
-                <a16:creationId xmlns:a16="http://schemas.microsoft.com/office/drawing/2014/main" id="{5F502E17-BC32-4928-9FA4-EDEF0DC67948}"/>
+                <a16:creationId xmlns:a16="http://schemas.microsoft.com/office/drawing/2014/main" id="{D052B550-0A9F-4668-B3AF-53037F31BA41}"/>
               </a:ext>
             </a:extLst>
           </p:cNvPr>
@@ -18411,7 +18507,7 @@
           <p:cNvPr id="8" name="route-1">
             <a:extLst xmlns:a="http://schemas.openxmlformats.org/drawingml/2006/main">
               <a:ext uri="{FF2B5EF4-FFF2-40B4-BE49-F238E27FC236}">
-                <a16:creationId xmlns:a16="http://schemas.microsoft.com/office/drawing/2014/main" id="{8CD1B814-8373-4BF6-9714-6DFCAA779379}"/>
+                <a16:creationId xmlns:a16="http://schemas.microsoft.com/office/drawing/2014/main" id="{09E7B10F-82A1-43E5-BEF3-62E21A740EFE}"/>
               </a:ext>
             </a:extLst>
           </p:cNvPr>
@@ -18468,7 +18564,7 @@
           <p:cNvPr id="9" name="route-number-2">
             <a:extLst xmlns:a="http://schemas.openxmlformats.org/drawingml/2006/main">
               <a:ext uri="{FF2B5EF4-FFF2-40B4-BE49-F238E27FC236}">
-                <a16:creationId xmlns:a16="http://schemas.microsoft.com/office/drawing/2014/main" id="{906852B6-AF8A-4083-A68B-CFAE8990BF16}"/>
+                <a16:creationId xmlns:a16="http://schemas.microsoft.com/office/drawing/2014/main" id="{74233559-0FCB-4A0D-8171-25AA6329115E}"/>
               </a:ext>
             </a:extLst>
           </p:cNvPr>
@@ -18525,7 +18621,7 @@
           <p:cNvPr id="10" name="route-2">
             <a:extLst xmlns:a="http://schemas.openxmlformats.org/drawingml/2006/main">
               <a:ext uri="{FF2B5EF4-FFF2-40B4-BE49-F238E27FC236}">
-                <a16:creationId xmlns:a16="http://schemas.microsoft.com/office/drawing/2014/main" id="{8AD27CE1-90F1-4D04-9F33-11794771BE0D}"/>
+                <a16:creationId xmlns:a16="http://schemas.microsoft.com/office/drawing/2014/main" id="{DC0A3E14-40DD-48FD-937A-D50174BA92D4}"/>
               </a:ext>
             </a:extLst>
           </p:cNvPr>
@@ -18582,7 +18678,7 @@
           <p:cNvPr id="11" name="route-number-3">
             <a:extLst xmlns:a="http://schemas.openxmlformats.org/drawingml/2006/main">
               <a:ext uri="{FF2B5EF4-FFF2-40B4-BE49-F238E27FC236}">
-                <a16:creationId xmlns:a16="http://schemas.microsoft.com/office/drawing/2014/main" id="{59017B74-7752-407A-9447-5231B4B1DA88}"/>
+                <a16:creationId xmlns:a16="http://schemas.microsoft.com/office/drawing/2014/main" id="{27FCDBBB-0A0E-4106-9049-5A164220D218}"/>
               </a:ext>
             </a:extLst>
           </p:cNvPr>
@@ -18639,7 +18735,7 @@
           <p:cNvPr id="12" name="route-3">
             <a:extLst xmlns:a="http://schemas.openxmlformats.org/drawingml/2006/main">
               <a:ext uri="{FF2B5EF4-FFF2-40B4-BE49-F238E27FC236}">
-                <a16:creationId xmlns:a16="http://schemas.microsoft.com/office/drawing/2014/main" id="{82D947AF-1A85-4ECB-BD9F-22DCF3731809}"/>
+                <a16:creationId xmlns:a16="http://schemas.microsoft.com/office/drawing/2014/main" id="{528548D2-0010-4251-889F-57566B9E0BE7}"/>
               </a:ext>
             </a:extLst>
           </p:cNvPr>
@@ -18696,7 +18792,7 @@
           <p:cNvPr id="13" name="route-number-4">
             <a:extLst xmlns:a="http://schemas.openxmlformats.org/drawingml/2006/main">
               <a:ext uri="{FF2B5EF4-FFF2-40B4-BE49-F238E27FC236}">
-                <a16:creationId xmlns:a16="http://schemas.microsoft.com/office/drawing/2014/main" id="{FF15AE3C-F471-43DF-8CA7-82CDD0544E65}"/>
+                <a16:creationId xmlns:a16="http://schemas.microsoft.com/office/drawing/2014/main" id="{25DF8009-FA72-4619-B7F8-E1AB0529C931}"/>
               </a:ext>
             </a:extLst>
           </p:cNvPr>
@@ -18753,7 +18849,7 @@
           <p:cNvPr id="14" name="route-4">
             <a:extLst xmlns:a="http://schemas.openxmlformats.org/drawingml/2006/main">
               <a:ext uri="{FF2B5EF4-FFF2-40B4-BE49-F238E27FC236}">
-                <a16:creationId xmlns:a16="http://schemas.microsoft.com/office/drawing/2014/main" id="{BAA1D938-F83F-4F6B-ADBC-6CBE382D695F}"/>
+                <a16:creationId xmlns:a16="http://schemas.microsoft.com/office/drawing/2014/main" id="{4D8FE108-411B-4405-8B01-B64591832320}"/>
               </a:ext>
             </a:extLst>
           </p:cNvPr>
@@ -18810,7 +18906,7 @@
           <p:cNvPr id="15" name="route-number-5">
             <a:extLst xmlns:a="http://schemas.openxmlformats.org/drawingml/2006/main">
               <a:ext uri="{FF2B5EF4-FFF2-40B4-BE49-F238E27FC236}">
-                <a16:creationId xmlns:a16="http://schemas.microsoft.com/office/drawing/2014/main" id="{598D401C-BB5D-40E4-B3D0-7CF3373C4782}"/>
+                <a16:creationId xmlns:a16="http://schemas.microsoft.com/office/drawing/2014/main" id="{985F5FFE-6FCC-427A-825E-59D1DCB3AC63}"/>
               </a:ext>
             </a:extLst>
           </p:cNvPr>
@@ -18867,7 +18963,7 @@
           <p:cNvPr id="16" name="route-5">
             <a:extLst xmlns:a="http://schemas.openxmlformats.org/drawingml/2006/main">
               <a:ext uri="{FF2B5EF4-FFF2-40B4-BE49-F238E27FC236}">
-                <a16:creationId xmlns:a16="http://schemas.microsoft.com/office/drawing/2014/main" id="{8163719D-C3B4-4D73-B350-4E6B9C37D5AF}"/>
+                <a16:creationId xmlns:a16="http://schemas.microsoft.com/office/drawing/2014/main" id="{DF330B68-CA87-4D08-BB1E-CF338F76ED0B}"/>
               </a:ext>
             </a:extLst>
           </p:cNvPr>
@@ -18924,7 +19020,7 @@
           <p:cNvPr id="17" name="route-number-6">
             <a:extLst xmlns:a="http://schemas.openxmlformats.org/drawingml/2006/main">
               <a:ext uri="{FF2B5EF4-FFF2-40B4-BE49-F238E27FC236}">
-                <a16:creationId xmlns:a16="http://schemas.microsoft.com/office/drawing/2014/main" id="{935A788B-2DA3-415B-B745-14D75AE2D3F9}"/>
+                <a16:creationId xmlns:a16="http://schemas.microsoft.com/office/drawing/2014/main" id="{37635C45-62FD-402A-8E71-5248E2FF4835}"/>
               </a:ext>
             </a:extLst>
           </p:cNvPr>
@@ -18981,7 +19077,7 @@
           <p:cNvPr id="18" name="route-6">
             <a:extLst xmlns:a="http://schemas.openxmlformats.org/drawingml/2006/main">
               <a:ext uri="{FF2B5EF4-FFF2-40B4-BE49-F238E27FC236}">
-                <a16:creationId xmlns:a16="http://schemas.microsoft.com/office/drawing/2014/main" id="{ACF931CB-8B17-4E49-8A81-D8C9528A14C5}"/>
+                <a16:creationId xmlns:a16="http://schemas.microsoft.com/office/drawing/2014/main" id="{6B74C009-ED0C-4A82-BF98-AB1B3E8EA5D4}"/>
               </a:ext>
             </a:extLst>
           </p:cNvPr>
@@ -19038,7 +19134,7 @@
           <p:cNvPr id="19" name="route-number-7">
             <a:extLst xmlns:a="http://schemas.openxmlformats.org/drawingml/2006/main">
               <a:ext uri="{FF2B5EF4-FFF2-40B4-BE49-F238E27FC236}">
-                <a16:creationId xmlns:a16="http://schemas.microsoft.com/office/drawing/2014/main" id="{F9B71F73-CF43-4943-864D-D06188B348D9}"/>
+                <a16:creationId xmlns:a16="http://schemas.microsoft.com/office/drawing/2014/main" id="{7D8862DB-9265-4004-BC27-37CC7C58F4D5}"/>
               </a:ext>
             </a:extLst>
           </p:cNvPr>
@@ -19095,7 +19191,7 @@
           <p:cNvPr id="20" name="route-7">
             <a:extLst xmlns:a="http://schemas.openxmlformats.org/drawingml/2006/main">
               <a:ext uri="{FF2B5EF4-FFF2-40B4-BE49-F238E27FC236}">
-                <a16:creationId xmlns:a16="http://schemas.microsoft.com/office/drawing/2014/main" id="{DB77EFEF-F152-4DE8-85CA-C6F1011EBE39}"/>
+                <a16:creationId xmlns:a16="http://schemas.microsoft.com/office/drawing/2014/main" id="{019BB245-D4C6-4856-84E9-6B75BCCB577C}"/>
               </a:ext>
             </a:extLst>
           </p:cNvPr>
@@ -19152,7 +19248,7 @@
           <p:cNvPr id="21" name="Lesdoelen">
             <a:extLst xmlns:a="http://schemas.openxmlformats.org/drawingml/2006/main">
               <a:ext uri="{FF2B5EF4-FFF2-40B4-BE49-F238E27FC236}">
-                <a16:creationId xmlns:a16="http://schemas.microsoft.com/office/drawing/2014/main" id="{5CA97971-C0D7-40F2-A811-44D874D1FCE9}"/>
+                <a16:creationId xmlns:a16="http://schemas.microsoft.com/office/drawing/2014/main" id="{2A662EE7-AE16-4D20-976A-750591C74BB3}"/>
               </a:ext>
             </a:extLst>
           </p:cNvPr>
@@ -19209,7 +19305,7 @@
           <p:cNvPr id="22" name="overview-goals">
             <a:extLst xmlns:a="http://schemas.openxmlformats.org/drawingml/2006/main">
               <a:ext uri="{FF2B5EF4-FFF2-40B4-BE49-F238E27FC236}">
-                <a16:creationId xmlns:a16="http://schemas.microsoft.com/office/drawing/2014/main" id="{FC2B9EC2-0696-442F-A759-F005FCD54819}"/>
+                <a16:creationId xmlns:a16="http://schemas.microsoft.com/office/drawing/2014/main" id="{AC7610A2-9B11-4F38-81A9-58DAA8F7CE5B}"/>
               </a:ext>
             </a:extLst>
           </p:cNvPr>
@@ -19312,7 +19408,7 @@
           <p:cNvPr id="23" name="">
             <a:extLst xmlns:a="http://schemas.openxmlformats.org/drawingml/2006/main">
               <a:ext uri="{FF2B5EF4-FFF2-40B4-BE49-F238E27FC236}">
-                <a16:creationId xmlns:a16="http://schemas.microsoft.com/office/drawing/2014/main" id="{B53D3D4A-DE34-4A33-8A29-F9CC1E1CEBE7}"/>
+                <a16:creationId xmlns:a16="http://schemas.microsoft.com/office/drawing/2014/main" id="{5F8DA40E-0C20-4F10-B3F6-329586156CC6}"/>
               </a:ext>
             </a:extLst>
           </p:cNvPr>
@@ -19341,7 +19437,7 @@
           <p:cNvPr id="24" name="Startopdracht">
             <a:extLst xmlns:a="http://schemas.openxmlformats.org/drawingml/2006/main">
               <a:ext uri="{FF2B5EF4-FFF2-40B4-BE49-F238E27FC236}">
-                <a16:creationId xmlns:a16="http://schemas.microsoft.com/office/drawing/2014/main" id="{2EC88739-F2AA-4B96-94C2-A4CA4E4CD296}"/>
+                <a16:creationId xmlns:a16="http://schemas.microsoft.com/office/drawing/2014/main" id="{9F122483-D4AA-4D77-A3C9-61F79A6E715F}"/>
               </a:ext>
             </a:extLst>
           </p:cNvPr>
@@ -19398,7 +19494,7 @@
           <p:cNvPr id="25" name="overview-start">
             <a:extLst xmlns:a="http://schemas.openxmlformats.org/drawingml/2006/main">
               <a:ext uri="{FF2B5EF4-FFF2-40B4-BE49-F238E27FC236}">
-                <a16:creationId xmlns:a16="http://schemas.microsoft.com/office/drawing/2014/main" id="{021D8468-8B33-437B-92FE-2A9FE785BFBC}"/>
+                <a16:creationId xmlns:a16="http://schemas.microsoft.com/office/drawing/2014/main" id="{AFE3E056-E370-4EA5-91EF-0786D6AD6906}"/>
               </a:ext>
             </a:extLst>
           </p:cNvPr>
@@ -19478,7 +19574,7 @@
           <p:cNvPr id="26" name="">
             <a:extLst xmlns:a="http://schemas.openxmlformats.org/drawingml/2006/main">
               <a:ext uri="{FF2B5EF4-FFF2-40B4-BE49-F238E27FC236}">
-                <a16:creationId xmlns:a16="http://schemas.microsoft.com/office/drawing/2014/main" id="{D78A9C7A-3271-4721-8658-10F5252E55C0}"/>
+                <a16:creationId xmlns:a16="http://schemas.microsoft.com/office/drawing/2014/main" id="{CBB02504-C67D-49E0-B527-E927CF952E84}"/>
               </a:ext>
             </a:extLst>
           </p:cNvPr>
@@ -19507,7 +19603,7 @@
           <p:cNvPr id="27" name="Huiswerk">
             <a:extLst xmlns:a="http://schemas.openxmlformats.org/drawingml/2006/main">
               <a:ext uri="{FF2B5EF4-FFF2-40B4-BE49-F238E27FC236}">
-                <a16:creationId xmlns:a16="http://schemas.microsoft.com/office/drawing/2014/main" id="{6508EEA0-0040-4BA2-9508-27D756662759}"/>
+                <a16:creationId xmlns:a16="http://schemas.microsoft.com/office/drawing/2014/main" id="{C6D68496-A8AA-42A1-B312-F6933D9CA9A3}"/>
               </a:ext>
             </a:extLst>
           </p:cNvPr>
@@ -19564,7 +19660,7 @@
           <p:cNvPr id="28" name="overview-homework">
             <a:extLst xmlns:a="http://schemas.openxmlformats.org/drawingml/2006/main">
               <a:ext uri="{FF2B5EF4-FFF2-40B4-BE49-F238E27FC236}">
-                <a16:creationId xmlns:a16="http://schemas.microsoft.com/office/drawing/2014/main" id="{FB17B022-0872-4A27-9125-DF54F281E2A1}"/>
+                <a16:creationId xmlns:a16="http://schemas.microsoft.com/office/drawing/2014/main" id="{F6398E10-C6A9-4D95-860F-AF533B69D51D}"/>
               </a:ext>
             </a:extLst>
           </p:cNvPr>
@@ -19711,7 +19807,7 @@
     </p:spTree>
     <p:extLst>
       <p:ext uri="{BB962C8B-B14F-4D97-AF65-F5344CB8AC3E}">
-        <p14:creationId xmlns:p14="http://schemas.microsoft.com/office/powerpoint/2010/main" val="1619694741"/>
+        <p14:creationId xmlns:p14="http://schemas.microsoft.com/office/powerpoint/2010/main" val="1117520550"/>
       </p:ext>
     </p:extLst>
   </p:cSld>
@@ -19739,10 +19835,10 @@
       </p:grpSpPr>
       <p:sp>
         <p:nvSpPr>
-          <p:cNvPr id="10" name="ShirtSprint: gegevens en functies">
-            <a:extLst xmlns:a="http://schemas.openxmlformats.org/drawingml/2006/main">
-              <a:ext uri="{FF2B5EF4-FFF2-40B4-BE49-F238E27FC236}">
-                <a16:creationId xmlns:a16="http://schemas.microsoft.com/office/drawing/2014/main" id="{E243EFC9-FE11-422B-A1B2-59D9FDD6DC3D}"/>
+          <p:cNvPr id="10" name="FietsWas: gegevens en functies">
+            <a:extLst xmlns:a="http://schemas.openxmlformats.org/drawingml/2006/main">
+              <a:ext uri="{FF2B5EF4-FFF2-40B4-BE49-F238E27FC236}">
+                <a16:creationId xmlns:a16="http://schemas.microsoft.com/office/drawing/2014/main" id="{C3BC5820-585F-447A-9D05-AB613F31F22E}"/>
               </a:ext>
             </a:extLst>
           </p:cNvPr>
@@ -19789,7 +19885,7 @@
                 <a:ea typeface="Arial"/>
                 <a:cs typeface="Arial"/>
               </a:rPr>
-              <a:t>ShirtSprint: gegevens en functies</a:t>
+              <a:t>FietsWas: gegevens en functies</a:t>
             </a:r>
           </a:p>
         </p:txBody>
@@ -19799,7 +19895,7 @@
           <p:cNvPr id="2" name="">
             <a:extLst xmlns:a="http://schemas.openxmlformats.org/drawingml/2006/main">
               <a:ext uri="{FF2B5EF4-FFF2-40B4-BE49-F238E27FC236}">
-                <a16:creationId xmlns:a16="http://schemas.microsoft.com/office/drawing/2014/main" id="{CE23A31D-3D99-43C3-AFF5-B8CA3DFDDD33}"/>
+                <a16:creationId xmlns:a16="http://schemas.microsoft.com/office/drawing/2014/main" id="{260C6F50-FA1E-4E65-BE42-37A01CB87DFB}"/>
               </a:ext>
             </a:extLst>
           </p:cNvPr>
@@ -19825,10 +19921,10 @@
       </p:sp>
       <p:sp>
         <p:nvSpPr>
-          <p:cNvPr id="3" name="§2.1.4 Gemengde opgaven">
-            <a:extLst xmlns:a="http://schemas.openxmlformats.org/drawingml/2006/main">
-              <a:ext uri="{FF2B5EF4-FFF2-40B4-BE49-F238E27FC236}">
-                <a16:creationId xmlns:a16="http://schemas.microsoft.com/office/drawing/2014/main" id="{868CD5DA-3FFD-451E-8AFF-91AED275263A}"/>
+          <p:cNvPr id="3" name="§2.1.4 Gemengde opgaven · Uitlegvoorbeeld — niet uit het boe">
+            <a:extLst xmlns:a="http://schemas.openxmlformats.org/drawingml/2006/main">
+              <a:ext uri="{FF2B5EF4-FFF2-40B4-BE49-F238E27FC236}">
+                <a16:creationId xmlns:a16="http://schemas.microsoft.com/office/drawing/2014/main" id="{7020F351-4166-4706-AA41-8A5FC85E2E42}"/>
               </a:ext>
             </a:extLst>
           </p:cNvPr>
@@ -19875,7 +19971,7 @@
                 <a:ea typeface="Arial"/>
                 <a:cs typeface="Arial"/>
               </a:rPr>
-              <a:t>§2.1.4 Gemengde opgaven</a:t>
+              <a:t>§2.1.4 Gemengde opgaven · Uitlegvoorbeeld — niet uit het boek</a:t>
             </a:r>
           </a:p>
         </p:txBody>
@@ -19885,7 +19981,7 @@
           <p:cNvPr id="4" name="slide-number">
             <a:extLst xmlns:a="http://schemas.openxmlformats.org/drawingml/2006/main">
               <a:ext uri="{FF2B5EF4-FFF2-40B4-BE49-F238E27FC236}">
-                <a16:creationId xmlns:a16="http://schemas.microsoft.com/office/drawing/2014/main" id="{B2CC08A1-A0CF-4647-BBDB-9B369FADE9AA}"/>
+                <a16:creationId xmlns:a16="http://schemas.microsoft.com/office/drawing/2014/main" id="{38D2559F-7FD6-45AC-985E-1AA65EBA38EF}"/>
               </a:ext>
             </a:extLst>
           </p:cNvPr>
@@ -19939,10 +20035,10 @@
       </p:sp>
       <p:sp>
         <p:nvSpPr>
-          <p:cNvPr id="5" name="Opgave 1 · Eén schoolfeest, maximaal 300 shirts">
-            <a:extLst xmlns:a="http://schemas.openxmlformats.org/drawingml/2006/main">
-              <a:ext uri="{FF2B5EF4-FFF2-40B4-BE49-F238E27FC236}">
-                <a16:creationId xmlns:a16="http://schemas.microsoft.com/office/drawing/2014/main" id="{B9257580-E147-4C9F-ACF4-EC75DBAE81F8}"/>
+          <p:cNvPr id="5" name="Fietsen wassen · Maximaal 40 fietsen per dag">
+            <a:extLst xmlns:a="http://schemas.openxmlformats.org/drawingml/2006/main">
+              <a:ext uri="{FF2B5EF4-FFF2-40B4-BE49-F238E27FC236}">
+                <a16:creationId xmlns:a16="http://schemas.microsoft.com/office/drawing/2014/main" id="{FB3E0E84-147F-45BF-90A6-0436AC97DF82}"/>
               </a:ext>
             </a:extLst>
           </p:cNvPr>
@@ -19989,7 +20085,7 @@
                 <a:ea typeface="Arial"/>
                 <a:cs typeface="Arial"/>
               </a:rPr>
-              <a:t>Opgave 1 · Eén schoolfeest, maximaal 300 shirts</a:t>
+              <a:t>Fietsen wassen · Maximaal 40 fietsen per dag</a:t>
             </a:r>
           </a:p>
         </p:txBody>
@@ -20027,7 +20123,7 @@
                           <a:ea typeface="Arial"/>
                           <a:cs typeface="Arial"/>
                         </a:rPr>
-                        <a:t>Gegeven uit de bron</a:t>
+                        <a:t>Gegeven in dit uitlegvoorbeeld</a:t>
                       </a:r>
                     </a:p>
                   </a:txBody>
@@ -20051,7 +20147,7 @@
                           <a:ea typeface="Arial"/>
                           <a:cs typeface="Arial"/>
                         </a:rPr>
-                        <a:t>Bewerking</a:t>
+                        <a:t>Betekenis</a:t>
                       </a:r>
                     </a:p>
                   </a:txBody>
@@ -20077,7 +20173,7 @@
                           <a:ea typeface="Arial"/>
                           <a:cs typeface="Arial"/>
                         </a:rPr>
-                        <a:t>Kraam € 480 + vergunning € 120</a:t>
+                        <a:t>Vaste kosten: € 36 per dag</a:t>
                       </a:r>
                     </a:p>
                   </a:txBody>
@@ -20101,7 +20197,7 @@
                           <a:ea typeface="Arial"/>
                           <a:cs typeface="Arial"/>
                         </a:rPr>
-                        <a:t>TCK = € 600 voor het schoolfeest</a:t>
+                        <a:t>TCK blijft € 36 per dag</a:t>
                       </a:r>
                     </a:p>
                   </a:txBody>
@@ -20127,7 +20223,7 @@
                           <a:ea typeface="Arial"/>
                           <a:cs typeface="Arial"/>
                         </a:rPr>
-                        <a:t>Shirt € 4 + bedrukking/verpakking € 1</a:t>
+                        <a:t>Variabele kosten: € 2 per fiets</a:t>
                       </a:r>
                     </a:p>
                   </a:txBody>
@@ -20151,7 +20247,7 @@
                           <a:ea typeface="Arial"/>
                           <a:cs typeface="Arial"/>
                         </a:rPr>
-                        <a:t>€ 5 per shirt</a:t>
+                        <a:t>TVK = 2Q per dag</a:t>
                       </a:r>
                     </a:p>
                   </a:txBody>
@@ -20177,7 +20273,7 @@
                           <a:ea typeface="Arial"/>
                           <a:cs typeface="Arial"/>
                         </a:rPr>
-                        <a:t>Verkoopprijs € 11 per shirt</a:t>
+                        <a:t>Prijs: € 5 per fiets</a:t>
                       </a:r>
                     </a:p>
                   </a:txBody>
@@ -20201,7 +20297,7 @@
                           <a:ea typeface="Arial"/>
                           <a:cs typeface="Arial"/>
                         </a:rPr>
-                        <a:t>TO = 11Q</a:t>
+                        <a:t>Elke gewassen fiets wordt betaald</a:t>
                       </a:r>
                     </a:p>
                   </a:txBody>
@@ -20218,10 +20314,10 @@
       </p:graphicFrame>
       <p:sp>
         <p:nvSpPr>
-          <p:cNvPr id="7" name="TK = 600 + 5Q">
-            <a:extLst xmlns:a="http://schemas.openxmlformats.org/drawingml/2006/main">
-              <a:ext uri="{FF2B5EF4-FFF2-40B4-BE49-F238E27FC236}">
-                <a16:creationId xmlns:a16="http://schemas.microsoft.com/office/drawing/2014/main" id="{8463AD9E-E455-4E12-9C3F-C0A204E0C57E}"/>
+          <p:cNvPr id="7" name="TK = 36 + 2Q">
+            <a:extLst xmlns:a="http://schemas.openxmlformats.org/drawingml/2006/main">
+              <a:ext uri="{FF2B5EF4-FFF2-40B4-BE49-F238E27FC236}">
+                <a16:creationId xmlns:a16="http://schemas.microsoft.com/office/drawing/2014/main" id="{C0E51C36-62D3-4EE5-AF02-DEBC8AA2461E}"/>
               </a:ext>
             </a:extLst>
           </p:cNvPr>
@@ -20268,17 +20364,17 @@
                 <a:ea typeface="Arial"/>
                 <a:cs typeface="Arial"/>
               </a:rPr>
-              <a:t>TK = 600 + 5Q</a:t>
-            </a:r>
-          </a:p>
-        </p:txBody>
-      </p:sp>
-      <p:sp>
-        <p:nvSpPr>
-          <p:cNvPr id="8" name="TO = 11Q">
-            <a:extLst xmlns:a="http://schemas.openxmlformats.org/drawingml/2006/main">
-              <a:ext uri="{FF2B5EF4-FFF2-40B4-BE49-F238E27FC236}">
-                <a16:creationId xmlns:a16="http://schemas.microsoft.com/office/drawing/2014/main" id="{441A1AB8-32D1-4C81-A004-ECFCF9D904E3}"/>
+              <a:t>TK = 36 + 2Q</a:t>
+            </a:r>
+          </a:p>
+        </p:txBody>
+      </p:sp>
+      <p:sp>
+        <p:nvSpPr>
+          <p:cNvPr id="8" name="TO = 5Q">
+            <a:extLst xmlns:a="http://schemas.openxmlformats.org/drawingml/2006/main">
+              <a:ext uri="{FF2B5EF4-FFF2-40B4-BE49-F238E27FC236}">
+                <a16:creationId xmlns:a16="http://schemas.microsoft.com/office/drawing/2014/main" id="{66D81B3A-EC6F-4DF8-859F-7DB1972210C1}"/>
               </a:ext>
             </a:extLst>
           </p:cNvPr>
@@ -20325,17 +20421,17 @@
                 <a:ea typeface="Arial"/>
                 <a:cs typeface="Arial"/>
               </a:rPr>
-              <a:t>TO = 11Q</a:t>
-            </a:r>
-          </a:p>
-        </p:txBody>
-      </p:sp>
-      <p:sp>
-        <p:nvSpPr>
-          <p:cNvPr id="9" name="600 bezoekers is geen gegarandeerde afzet.">
-            <a:extLst xmlns:a="http://schemas.openxmlformats.org/drawingml/2006/main">
-              <a:ext uri="{FF2B5EF4-FFF2-40B4-BE49-F238E27FC236}">
-                <a16:creationId xmlns:a16="http://schemas.microsoft.com/office/drawing/2014/main" id="{E2ACBEC4-1027-4D44-9876-5DB84605B498}"/>
+              <a:t>TO = 5Q</a:t>
+            </a:r>
+          </a:p>
+        </p:txBody>
+      </p:sp>
+      <p:sp>
+        <p:nvSpPr>
+          <p:cNvPr id="9" name="Q: fietsen per dag · 0 ≤ Q ≤ 40 · Totalen: € per dag">
+            <a:extLst xmlns:a="http://schemas.openxmlformats.org/drawingml/2006/main">
+              <a:ext uri="{FF2B5EF4-FFF2-40B4-BE49-F238E27FC236}">
+                <a16:creationId xmlns:a16="http://schemas.microsoft.com/office/drawing/2014/main" id="{109A435A-FBC7-42AB-87C0-0246625D2E51}"/>
               </a:ext>
             </a:extLst>
           </p:cNvPr>
@@ -20382,7 +20478,7 @@
                 <a:ea typeface="Arial"/>
                 <a:cs typeface="Arial"/>
               </a:rPr>
-              <a:t>600 bezoekers is geen gegarandeerde afzet.</a:t>
+              <a:t>Q: fietsen per dag · 0 ≤ Q ≤ 40 · Totalen: € per dag</a:t>
             </a:r>
           </a:p>
         </p:txBody>
@@ -20390,7 +20486,7 @@
     </p:spTree>
     <p:extLst>
       <p:ext uri="{BB962C8B-B14F-4D97-AF65-F5344CB8AC3E}">
-        <p14:creationId xmlns:p14="http://schemas.microsoft.com/office/powerpoint/2010/main" val="1521471715"/>
+        <p14:creationId xmlns:p14="http://schemas.microsoft.com/office/powerpoint/2010/main" val="1009623029"/>
       </p:ext>
     </p:extLst>
   </p:cSld>
@@ -20418,10 +20514,10 @@
       </p:grpSpPr>
       <p:sp>
         <p:nvSpPr>
-          <p:cNvPr id="8" name="ShirtSprint: totaal en per shirt">
-            <a:extLst xmlns:a="http://schemas.openxmlformats.org/drawingml/2006/main">
-              <a:ext uri="{FF2B5EF4-FFF2-40B4-BE49-F238E27FC236}">
-                <a16:creationId xmlns:a16="http://schemas.microsoft.com/office/drawing/2014/main" id="{B854ACA1-37A6-45B6-A3BD-C862EB53CBE2}"/>
+          <p:cNvPr id="8" name="FietsWas: totaal en per fiets">
+            <a:extLst xmlns:a="http://schemas.openxmlformats.org/drawingml/2006/main">
+              <a:ext uri="{FF2B5EF4-FFF2-40B4-BE49-F238E27FC236}">
+                <a16:creationId xmlns:a16="http://schemas.microsoft.com/office/drawing/2014/main" id="{803963D9-32AD-4B12-B0F1-4C08B3C04C1A}"/>
               </a:ext>
             </a:extLst>
           </p:cNvPr>
@@ -20468,7 +20564,7 @@
                 <a:ea typeface="Arial"/>
                 <a:cs typeface="Arial"/>
               </a:rPr>
-              <a:t>ShirtSprint: totaal en per shirt</a:t>
+              <a:t>FietsWas: totaal en per fiets</a:t>
             </a:r>
           </a:p>
         </p:txBody>
@@ -20478,7 +20574,7 @@
           <p:cNvPr id="2" name="">
             <a:extLst xmlns:a="http://schemas.openxmlformats.org/drawingml/2006/main">
               <a:ext uri="{FF2B5EF4-FFF2-40B4-BE49-F238E27FC236}">
-                <a16:creationId xmlns:a16="http://schemas.microsoft.com/office/drawing/2014/main" id="{E2A394F9-DE9D-4E79-86EF-BCAA73830DB0}"/>
+                <a16:creationId xmlns:a16="http://schemas.microsoft.com/office/drawing/2014/main" id="{02C603F4-4ADC-40CD-936A-F0B2E15506F2}"/>
               </a:ext>
             </a:extLst>
           </p:cNvPr>
@@ -20504,10 +20600,10 @@
       </p:sp>
       <p:sp>
         <p:nvSpPr>
-          <p:cNvPr id="3" name="§2.1.4 Gemengde opgaven">
-            <a:extLst xmlns:a="http://schemas.openxmlformats.org/drawingml/2006/main">
-              <a:ext uri="{FF2B5EF4-FFF2-40B4-BE49-F238E27FC236}">
-                <a16:creationId xmlns:a16="http://schemas.microsoft.com/office/drawing/2014/main" id="{7355EA8E-D221-4D76-AA69-7F4311C44B77}"/>
+          <p:cNvPr id="3" name="§2.1.4 Gemengde opgaven · Uitlegvoorbeeld — niet uit het boe">
+            <a:extLst xmlns:a="http://schemas.openxmlformats.org/drawingml/2006/main">
+              <a:ext uri="{FF2B5EF4-FFF2-40B4-BE49-F238E27FC236}">
+                <a16:creationId xmlns:a16="http://schemas.microsoft.com/office/drawing/2014/main" id="{8F8A0C9E-C347-449A-8F8B-DF3CDD814880}"/>
               </a:ext>
             </a:extLst>
           </p:cNvPr>
@@ -20554,7 +20650,7 @@
                 <a:ea typeface="Arial"/>
                 <a:cs typeface="Arial"/>
               </a:rPr>
-              <a:t>§2.1.4 Gemengde opgaven</a:t>
+              <a:t>§2.1.4 Gemengde opgaven · Uitlegvoorbeeld — niet uit het boek</a:t>
             </a:r>
           </a:p>
         </p:txBody>
@@ -20564,7 +20660,7 @@
           <p:cNvPr id="4" name="slide-number">
             <a:extLst xmlns:a="http://schemas.openxmlformats.org/drawingml/2006/main">
               <a:ext uri="{FF2B5EF4-FFF2-40B4-BE49-F238E27FC236}">
-                <a16:creationId xmlns:a16="http://schemas.microsoft.com/office/drawing/2014/main" id="{20E55686-6A9E-467D-99F5-46DD7205492B}"/>
+                <a16:creationId xmlns:a16="http://schemas.microsoft.com/office/drawing/2014/main" id="{9F195DC0-753B-4BB0-88FF-1F698200D858}"/>
               </a:ext>
             </a:extLst>
           </p:cNvPr>
@@ -20618,10 +20714,10 @@
       </p:sp>
       <p:sp>
         <p:nvSpPr>
-          <p:cNvPr id="5" name="Bij Q = 150 shirts">
-            <a:extLst xmlns:a="http://schemas.openxmlformats.org/drawingml/2006/main">
-              <a:ext uri="{FF2B5EF4-FFF2-40B4-BE49-F238E27FC236}">
-                <a16:creationId xmlns:a16="http://schemas.microsoft.com/office/drawing/2014/main" id="{4B27E18C-A120-4173-9E6D-CA5BEB1E2DA0}"/>
+          <p:cNvPr id="5" name="Bij Q = 20 fietsen per dag">
+            <a:extLst xmlns:a="http://schemas.openxmlformats.org/drawingml/2006/main">
+              <a:ext uri="{FF2B5EF4-FFF2-40B4-BE49-F238E27FC236}">
+                <a16:creationId xmlns:a16="http://schemas.microsoft.com/office/drawing/2014/main" id="{C63AEC49-7443-4364-B223-9AF5F0D17AB2}"/>
               </a:ext>
             </a:extLst>
           </p:cNvPr>
@@ -20668,7 +20764,7 @@
                 <a:ea typeface="Arial"/>
                 <a:cs typeface="Arial"/>
               </a:rPr>
-              <a:t>Bij Q = 150 shirts</a:t>
+              <a:t>Bij Q = 20 fietsen per dag</a:t>
             </a:r>
           </a:p>
         </p:txBody>
@@ -20805,7 +20901,7 @@
                           <a:ea typeface="Arial"/>
                           <a:cs typeface="Arial"/>
                         </a:rPr>
-                        <a:t>600 + 5 × 150</a:t>
+                        <a:t>36 + 2 × 20</a:t>
                       </a:r>
                     </a:p>
                   </a:txBody>
@@ -20829,7 +20925,7 @@
                           <a:ea typeface="Arial"/>
                           <a:cs typeface="Arial"/>
                         </a:rPr>
-                        <a:t>€ 1.350 voor het feest</a:t>
+                        <a:t>€ 76 per dag</a:t>
                       </a:r>
                     </a:p>
                   </a:txBody>
@@ -20879,7 +20975,7 @@
                           <a:ea typeface="Arial"/>
                           <a:cs typeface="Arial"/>
                         </a:rPr>
-                        <a:t>11 × 150</a:t>
+                        <a:t>5 × 20</a:t>
                       </a:r>
                     </a:p>
                   </a:txBody>
@@ -20903,7 +20999,7 @@
                           <a:ea typeface="Arial"/>
                           <a:cs typeface="Arial"/>
                         </a:rPr>
-                        <a:t>€ 1.650 voor het feest</a:t>
+                        <a:t>€ 100 per dag</a:t>
                       </a:r>
                     </a:p>
                   </a:txBody>
@@ -20953,7 +21049,7 @@
                           <a:ea typeface="Arial"/>
                           <a:cs typeface="Arial"/>
                         </a:rPr>
-                        <a:t>1.650 − 1.350</a:t>
+                        <a:t>100 − 76</a:t>
                       </a:r>
                     </a:p>
                   </a:txBody>
@@ -20977,7 +21073,7 @@
                           <a:ea typeface="Arial"/>
                           <a:cs typeface="Arial"/>
                         </a:rPr>
-                        <a:t>€ 300 voor het feest</a:t>
+                        <a:t>€ 24 per dag</a:t>
                       </a:r>
                     </a:p>
                   </a:txBody>
@@ -21027,7 +21123,7 @@
                           <a:ea typeface="Arial"/>
                           <a:cs typeface="Arial"/>
                         </a:rPr>
-                        <a:t>1.350 / 150</a:t>
+                        <a:t>76 / 20</a:t>
                       </a:r>
                     </a:p>
                   </a:txBody>
@@ -21051,7 +21147,7 @@
                           <a:ea typeface="Arial"/>
                           <a:cs typeface="Arial"/>
                         </a:rPr>
-                        <a:t>€ 9 per shirt</a:t>
+                        <a:t>€ 3,80 per fiets</a:t>
                       </a:r>
                     </a:p>
                   </a:txBody>
@@ -21068,10 +21164,10 @@
       </p:graphicFrame>
       <p:sp>
         <p:nvSpPr>
-          <p:cNvPr id="7" name="Winst is een totaalverschil. GTK is een bedrag per shirt.">
-            <a:extLst xmlns:a="http://schemas.openxmlformats.org/drawingml/2006/main">
-              <a:ext uri="{FF2B5EF4-FFF2-40B4-BE49-F238E27FC236}">
-                <a16:creationId xmlns:a16="http://schemas.microsoft.com/office/drawing/2014/main" id="{1CABE0AA-CE04-43C5-88D7-FCC8594A37D3}"/>
+          <p:cNvPr id="7" name="Winst: verschil tussen totalen. GTK: kosten per fiets.">
+            <a:extLst xmlns:a="http://schemas.openxmlformats.org/drawingml/2006/main">
+              <a:ext uri="{FF2B5EF4-FFF2-40B4-BE49-F238E27FC236}">
+                <a16:creationId xmlns:a16="http://schemas.microsoft.com/office/drawing/2014/main" id="{AC7DF3F7-154F-477E-874A-95AC2386D826}"/>
               </a:ext>
             </a:extLst>
           </p:cNvPr>
@@ -21118,7 +21214,7 @@
                 <a:ea typeface="Arial"/>
                 <a:cs typeface="Arial"/>
               </a:rPr>
-              <a:t>Winst is een totaalverschil. GTK is een bedrag per shirt.</a:t>
+              <a:t>Winst: verschil tussen totalen. GTK: kosten per fiets.</a:t>
             </a:r>
           </a:p>
         </p:txBody>
@@ -21126,7 +21222,7 @@
     </p:spTree>
     <p:extLst>
       <p:ext uri="{BB962C8B-B14F-4D97-AF65-F5344CB8AC3E}">
-        <p14:creationId xmlns:p14="http://schemas.microsoft.com/office/powerpoint/2010/main" val="1137698100"/>
+        <p14:creationId xmlns:p14="http://schemas.microsoft.com/office/powerpoint/2010/main" val="1845549815"/>
       </p:ext>
     </p:extLst>
   </p:cSld>
@@ -21154,10 +21250,10 @@
       </p:grpSpPr>
       <p:sp>
         <p:nvSpPr>
-          <p:cNvPr id="14" name="ShirtSprint: break-even">
-            <a:extLst xmlns:a="http://schemas.openxmlformats.org/drawingml/2006/main">
-              <a:ext uri="{FF2B5EF4-FFF2-40B4-BE49-F238E27FC236}">
-                <a16:creationId xmlns:a16="http://schemas.microsoft.com/office/drawing/2014/main" id="{4034F66B-3580-4AED-B4E5-49E967A94B34}"/>
+          <p:cNvPr id="14" name="FietsWas: break-even">
+            <a:extLst xmlns:a="http://schemas.openxmlformats.org/drawingml/2006/main">
+              <a:ext uri="{FF2B5EF4-FFF2-40B4-BE49-F238E27FC236}">
+                <a16:creationId xmlns:a16="http://schemas.microsoft.com/office/drawing/2014/main" id="{96C1308C-B92B-4AEB-B08C-BCC4A247B834}"/>
               </a:ext>
             </a:extLst>
           </p:cNvPr>
@@ -21204,7 +21300,7 @@
                 <a:ea typeface="Arial"/>
                 <a:cs typeface="Arial"/>
               </a:rPr>
-              <a:t>ShirtSprint: break-even</a:t>
+              <a:t>FietsWas: break-even</a:t>
             </a:r>
           </a:p>
         </p:txBody>
@@ -21214,7 +21310,7 @@
           <p:cNvPr id="2" name="">
             <a:extLst xmlns:a="http://schemas.openxmlformats.org/drawingml/2006/main">
               <a:ext uri="{FF2B5EF4-FFF2-40B4-BE49-F238E27FC236}">
-                <a16:creationId xmlns:a16="http://schemas.microsoft.com/office/drawing/2014/main" id="{EA1EA760-B677-4399-99B7-573BDFA012F0}"/>
+                <a16:creationId xmlns:a16="http://schemas.microsoft.com/office/drawing/2014/main" id="{730EB23F-1B9E-4C30-806E-067F98A22DDE}"/>
               </a:ext>
             </a:extLst>
           </p:cNvPr>
@@ -21240,10 +21336,10 @@
       </p:sp>
       <p:sp>
         <p:nvSpPr>
-          <p:cNvPr id="3" name="§2.1.4 Gemengde opgaven">
-            <a:extLst xmlns:a="http://schemas.openxmlformats.org/drawingml/2006/main">
-              <a:ext uri="{FF2B5EF4-FFF2-40B4-BE49-F238E27FC236}">
-                <a16:creationId xmlns:a16="http://schemas.microsoft.com/office/drawing/2014/main" id="{5381825E-B7BC-4324-B281-9267E9028DED}"/>
+          <p:cNvPr id="3" name="§2.1.4 Gemengde opgaven · Uitlegvoorbeeld — niet uit het boe">
+            <a:extLst xmlns:a="http://schemas.openxmlformats.org/drawingml/2006/main">
+              <a:ext uri="{FF2B5EF4-FFF2-40B4-BE49-F238E27FC236}">
+                <a16:creationId xmlns:a16="http://schemas.microsoft.com/office/drawing/2014/main" id="{F52C7347-AE2D-45DD-A6FF-D792E796EF95}"/>
               </a:ext>
             </a:extLst>
           </p:cNvPr>
@@ -21290,7 +21386,7 @@
                 <a:ea typeface="Arial"/>
                 <a:cs typeface="Arial"/>
               </a:rPr>
-              <a:t>§2.1.4 Gemengde opgaven</a:t>
+              <a:t>§2.1.4 Gemengde opgaven · Uitlegvoorbeeld — niet uit het boek</a:t>
             </a:r>
           </a:p>
         </p:txBody>
@@ -21300,7 +21396,7 @@
           <p:cNvPr id="4" name="slide-number">
             <a:extLst xmlns:a="http://schemas.openxmlformats.org/drawingml/2006/main">
               <a:ext uri="{FF2B5EF4-FFF2-40B4-BE49-F238E27FC236}">
-                <a16:creationId xmlns:a16="http://schemas.microsoft.com/office/drawing/2014/main" id="{20772BC7-5F8E-4986-863E-998A684D6CAF}"/>
+                <a16:creationId xmlns:a16="http://schemas.microsoft.com/office/drawing/2014/main" id="{07131D79-8BEA-4343-8CF0-87E9152E61E1}"/>
               </a:ext>
             </a:extLst>
           </p:cNvPr>
@@ -21357,7 +21453,7 @@
           <p:cNvPr id="5" name="TO = TK">
             <a:extLst xmlns:a="http://schemas.openxmlformats.org/drawingml/2006/main">
               <a:ext uri="{FF2B5EF4-FFF2-40B4-BE49-F238E27FC236}">
-                <a16:creationId xmlns:a16="http://schemas.microsoft.com/office/drawing/2014/main" id="{E74E7CDB-C14B-4CFE-9E62-66B91A7E285B}"/>
+                <a16:creationId xmlns:a16="http://schemas.microsoft.com/office/drawing/2014/main" id="{AAE03145-97A7-44EE-8EE8-7517B459502C}"/>
               </a:ext>
             </a:extLst>
           </p:cNvPr>
@@ -21414,7 +21510,7 @@
           <p:cNvPr id="6" name="Opbrengst dekt alle kosten">
             <a:extLst xmlns:a="http://schemas.openxmlformats.org/drawingml/2006/main">
               <a:ext uri="{FF2B5EF4-FFF2-40B4-BE49-F238E27FC236}">
-                <a16:creationId xmlns:a16="http://schemas.microsoft.com/office/drawing/2014/main" id="{64E2A61B-63B5-4EDB-9D7D-EC391D0567E6}"/>
+                <a16:creationId xmlns:a16="http://schemas.microsoft.com/office/drawing/2014/main" id="{FC1A0685-87FF-48C3-A8D8-821B4B69F9B8}"/>
               </a:ext>
             </a:extLst>
           </p:cNvPr>
@@ -21468,10 +21564,10 @@
       </p:sp>
       <p:sp>
         <p:nvSpPr>
-          <p:cNvPr id="7" name="11Q = 600 + 5Q">
-            <a:extLst xmlns:a="http://schemas.openxmlformats.org/drawingml/2006/main">
-              <a:ext uri="{FF2B5EF4-FFF2-40B4-BE49-F238E27FC236}">
-                <a16:creationId xmlns:a16="http://schemas.microsoft.com/office/drawing/2014/main" id="{56A03CEB-502A-4F87-BD21-6D07AF1F66EA}"/>
+          <p:cNvPr id="7" name="5Q = 36 + 2Q">
+            <a:extLst xmlns:a="http://schemas.openxmlformats.org/drawingml/2006/main">
+              <a:ext uri="{FF2B5EF4-FFF2-40B4-BE49-F238E27FC236}">
+                <a16:creationId xmlns:a16="http://schemas.microsoft.com/office/drawing/2014/main" id="{E0A5EAA8-83AA-461E-88C2-C1C901E618EA}"/>
               </a:ext>
             </a:extLst>
           </p:cNvPr>
@@ -21518,7 +21614,7 @@
                 <a:ea typeface="Arial"/>
                 <a:cs typeface="Arial"/>
               </a:rPr>
-              <a:t>11Q = 600 + 5Q</a:t>
+              <a:t>5Q = 36 + 2Q</a:t>
             </a:r>
           </a:p>
         </p:txBody>
@@ -21528,7 +21624,7 @@
           <p:cNvPr id="8" name="Functies invullen">
             <a:extLst xmlns:a="http://schemas.openxmlformats.org/drawingml/2006/main">
               <a:ext uri="{FF2B5EF4-FFF2-40B4-BE49-F238E27FC236}">
-                <a16:creationId xmlns:a16="http://schemas.microsoft.com/office/drawing/2014/main" id="{9906F149-9193-4301-BD93-F2AC238D0F63}"/>
+                <a16:creationId xmlns:a16="http://schemas.microsoft.com/office/drawing/2014/main" id="{2E52048D-B921-4B94-922D-D58A2A91DD47}"/>
               </a:ext>
             </a:extLst>
           </p:cNvPr>
@@ -21582,10 +21678,10 @@
       </p:sp>
       <p:sp>
         <p:nvSpPr>
-          <p:cNvPr id="9" name="6Q = 600">
-            <a:extLst xmlns:a="http://schemas.openxmlformats.org/drawingml/2006/main">
-              <a:ext uri="{FF2B5EF4-FFF2-40B4-BE49-F238E27FC236}">
-                <a16:creationId xmlns:a16="http://schemas.microsoft.com/office/drawing/2014/main" id="{9A7BC7F5-3BCA-48D1-9212-65BBC0B01936}"/>
+          <p:cNvPr id="9" name="3Q = 36">
+            <a:extLst xmlns:a="http://schemas.openxmlformats.org/drawingml/2006/main">
+              <a:ext uri="{FF2B5EF4-FFF2-40B4-BE49-F238E27FC236}">
+                <a16:creationId xmlns:a16="http://schemas.microsoft.com/office/drawing/2014/main" id="{75C7FDD2-C543-47DC-8746-F90616ECE86C}"/>
               </a:ext>
             </a:extLst>
           </p:cNvPr>
@@ -21632,17 +21728,17 @@
                 <a:ea typeface="Arial"/>
                 <a:cs typeface="Arial"/>
               </a:rPr>
-              <a:t>6Q = 600</a:t>
-            </a:r>
-          </a:p>
-        </p:txBody>
-      </p:sp>
-      <p:sp>
-        <p:nvSpPr>
-          <p:cNvPr id="10" name="Aan beide kanten 5Q aftrekken">
-            <a:extLst xmlns:a="http://schemas.openxmlformats.org/drawingml/2006/main">
-              <a:ext uri="{FF2B5EF4-FFF2-40B4-BE49-F238E27FC236}">
-                <a16:creationId xmlns:a16="http://schemas.microsoft.com/office/drawing/2014/main" id="{D96F5BF2-E710-4516-A0DF-CC9C9317F147}"/>
+              <a:t>3Q = 36</a:t>
+            </a:r>
+          </a:p>
+        </p:txBody>
+      </p:sp>
+      <p:sp>
+        <p:nvSpPr>
+          <p:cNvPr id="10" name="Aan beide kanten 2Q aftrekken">
+            <a:extLst xmlns:a="http://schemas.openxmlformats.org/drawingml/2006/main">
+              <a:ext uri="{FF2B5EF4-FFF2-40B4-BE49-F238E27FC236}">
+                <a16:creationId xmlns:a16="http://schemas.microsoft.com/office/drawing/2014/main" id="{E13E4942-293B-471C-8766-83337936D79C}"/>
               </a:ext>
             </a:extLst>
           </p:cNvPr>
@@ -21689,17 +21785,17 @@
                 <a:ea typeface="Arial"/>
                 <a:cs typeface="Arial"/>
               </a:rPr>
-              <a:t>Aan beide kanten 5Q aftrekken</a:t>
-            </a:r>
-          </a:p>
-        </p:txBody>
-      </p:sp>
-      <p:sp>
-        <p:nvSpPr>
-          <p:cNvPr id="11" name="Q = 600 / 6 = 100 shirts">
-            <a:extLst xmlns:a="http://schemas.openxmlformats.org/drawingml/2006/main">
-              <a:ext uri="{FF2B5EF4-FFF2-40B4-BE49-F238E27FC236}">
-                <a16:creationId xmlns:a16="http://schemas.microsoft.com/office/drawing/2014/main" id="{9B6E874C-AFA0-434C-9D1B-C9D4FE5B9DA0}"/>
+              <a:t>Aan beide kanten 2Q aftrekken</a:t>
+            </a:r>
+          </a:p>
+        </p:txBody>
+      </p:sp>
+      <p:sp>
+        <p:nvSpPr>
+          <p:cNvPr id="11" name="Q = 36 / 3 = 12">
+            <a:extLst xmlns:a="http://schemas.openxmlformats.org/drawingml/2006/main">
+              <a:ext uri="{FF2B5EF4-FFF2-40B4-BE49-F238E27FC236}">
+                <a16:creationId xmlns:a16="http://schemas.microsoft.com/office/drawing/2014/main" id="{9BB42723-6DFA-45A8-9C94-7EA5D73EFD33}"/>
               </a:ext>
             </a:extLst>
           </p:cNvPr>
@@ -21746,17 +21842,17 @@
                 <a:ea typeface="Arial"/>
                 <a:cs typeface="Arial"/>
               </a:rPr>
-              <a:t>Q = 600 / 6 = 100 shirts</a:t>
-            </a:r>
-          </a:p>
-        </p:txBody>
-      </p:sp>
-      <p:sp>
-        <p:nvSpPr>
-          <p:cNvPr id="12" name="Delen door 6">
-            <a:extLst xmlns:a="http://schemas.openxmlformats.org/drawingml/2006/main">
-              <a:ext uri="{FF2B5EF4-FFF2-40B4-BE49-F238E27FC236}">
-                <a16:creationId xmlns:a16="http://schemas.microsoft.com/office/drawing/2014/main" id="{DA7965EE-6ED2-4A1F-A963-E4F69AC2826E}"/>
+              <a:t>Q = 36 / 3 = 12</a:t>
+            </a:r>
+          </a:p>
+        </p:txBody>
+      </p:sp>
+      <p:sp>
+        <p:nvSpPr>
+          <p:cNvPr id="12" name="Fietsen per dag">
+            <a:extLst xmlns:a="http://schemas.openxmlformats.org/drawingml/2006/main">
+              <a:ext uri="{FF2B5EF4-FFF2-40B4-BE49-F238E27FC236}">
+                <a16:creationId xmlns:a16="http://schemas.microsoft.com/office/drawing/2014/main" id="{6758AFCC-CB6C-4501-B3B3-13CE5D4A579B}"/>
               </a:ext>
             </a:extLst>
           </p:cNvPr>
@@ -21803,17 +21899,17 @@
                 <a:ea typeface="Arial"/>
                 <a:cs typeface="Arial"/>
               </a:rPr>
-              <a:t>Delen door 6</a:t>
-            </a:r>
-          </a:p>
-        </p:txBody>
-      </p:sp>
-      <p:sp>
-        <p:nvSpPr>
-          <p:cNvPr id="13" name="Controle: TO = TK = € 1.100 voor het feest. Winst = € 0.">
-            <a:extLst xmlns:a="http://schemas.openxmlformats.org/drawingml/2006/main">
-              <a:ext uri="{FF2B5EF4-FFF2-40B4-BE49-F238E27FC236}">
-                <a16:creationId xmlns:a16="http://schemas.microsoft.com/office/drawing/2014/main" id="{27672A5D-D9E6-47F8-AE80-A11C030A9610}"/>
+              <a:t>Fietsen per dag</a:t>
+            </a:r>
+          </a:p>
+        </p:txBody>
+      </p:sp>
+      <p:sp>
+        <p:nvSpPr>
+          <p:cNvPr id="13" name="Controle: TO = TK = € 60 per dag. Winst = € 0.">
+            <a:extLst xmlns:a="http://schemas.openxmlformats.org/drawingml/2006/main">
+              <a:ext uri="{FF2B5EF4-FFF2-40B4-BE49-F238E27FC236}">
+                <a16:creationId xmlns:a16="http://schemas.microsoft.com/office/drawing/2014/main" id="{8EF038A8-C929-429B-A7B1-32192F056A86}"/>
               </a:ext>
             </a:extLst>
           </p:cNvPr>
@@ -21860,7 +21956,7 @@
                 <a:ea typeface="Arial"/>
                 <a:cs typeface="Arial"/>
               </a:rPr>
-              <a:t>Controle: TO = TK = € 1.100 voor het feest. Winst = € 0.</a:t>
+              <a:t>Controle: TO = TK = € 60 per dag. Winst = € 0.</a:t>
             </a:r>
           </a:p>
         </p:txBody>
@@ -21868,7 +21964,7 @@
     </p:spTree>
     <p:extLst>
       <p:ext uri="{BB962C8B-B14F-4D97-AF65-F5344CB8AC3E}">
-        <p14:creationId xmlns:p14="http://schemas.microsoft.com/office/powerpoint/2010/main" val="1583722893"/>
+        <p14:creationId xmlns:p14="http://schemas.microsoft.com/office/powerpoint/2010/main" val="1455229448"/>
       </p:ext>
     </p:extLst>
   </p:cSld>
@@ -21896,10 +21992,10 @@
       </p:grpSpPr>
       <p:sp>
         <p:nvSpPr>
-          <p:cNvPr id="10" name="Marginale bedragen: verschillen delen">
-            <a:extLst xmlns:a="http://schemas.openxmlformats.org/drawingml/2006/main">
-              <a:ext uri="{FF2B5EF4-FFF2-40B4-BE49-F238E27FC236}">
-                <a16:creationId xmlns:a16="http://schemas.microsoft.com/office/drawing/2014/main" id="{0E425B46-0059-4A60-A869-FA028E9267AD}"/>
+          <p:cNvPr id="10" name="FietsWas: marginale bedragen">
+            <a:extLst xmlns:a="http://schemas.openxmlformats.org/drawingml/2006/main">
+              <a:ext uri="{FF2B5EF4-FFF2-40B4-BE49-F238E27FC236}">
+                <a16:creationId xmlns:a16="http://schemas.microsoft.com/office/drawing/2014/main" id="{87284370-9DD6-4FBD-BE31-D8CCEE96F5AF}"/>
               </a:ext>
             </a:extLst>
           </p:cNvPr>
@@ -21946,7 +22042,7 @@
                 <a:ea typeface="Arial"/>
                 <a:cs typeface="Arial"/>
               </a:rPr>
-              <a:t>Marginale bedragen: verschillen delen</a:t>
+              <a:t>FietsWas: marginale bedragen</a:t>
             </a:r>
           </a:p>
         </p:txBody>
@@ -21956,7 +22052,7 @@
           <p:cNvPr id="2" name="">
             <a:extLst xmlns:a="http://schemas.openxmlformats.org/drawingml/2006/main">
               <a:ext uri="{FF2B5EF4-FFF2-40B4-BE49-F238E27FC236}">
-                <a16:creationId xmlns:a16="http://schemas.microsoft.com/office/drawing/2014/main" id="{7C1BFB91-F0B0-4B36-941A-712BFEA29A98}"/>
+                <a16:creationId xmlns:a16="http://schemas.microsoft.com/office/drawing/2014/main" id="{593F9A6B-9F95-43CF-B574-F9A98F17A7C0}"/>
               </a:ext>
             </a:extLst>
           </p:cNvPr>
@@ -21982,10 +22078,10 @@
       </p:sp>
       <p:sp>
         <p:nvSpPr>
-          <p:cNvPr id="3" name="§2.1.4 Gemengde opgaven">
-            <a:extLst xmlns:a="http://schemas.openxmlformats.org/drawingml/2006/main">
-              <a:ext uri="{FF2B5EF4-FFF2-40B4-BE49-F238E27FC236}">
-                <a16:creationId xmlns:a16="http://schemas.microsoft.com/office/drawing/2014/main" id="{9CEB01D9-541B-4992-8E22-19FBAA05CF82}"/>
+          <p:cNvPr id="3" name="§2.1.4 Gemengde opgaven · Uitlegvoorbeeld — niet uit het boe">
+            <a:extLst xmlns:a="http://schemas.openxmlformats.org/drawingml/2006/main">
+              <a:ext uri="{FF2B5EF4-FFF2-40B4-BE49-F238E27FC236}">
+                <a16:creationId xmlns:a16="http://schemas.microsoft.com/office/drawing/2014/main" id="{E7DC9FB1-6125-447A-8971-C78A10B97269}"/>
               </a:ext>
             </a:extLst>
           </p:cNvPr>
@@ -22032,7 +22128,7 @@
                 <a:ea typeface="Arial"/>
                 <a:cs typeface="Arial"/>
               </a:rPr>
-              <a:t>§2.1.4 Gemengde opgaven</a:t>
+              <a:t>§2.1.4 Gemengde opgaven · Uitlegvoorbeeld — niet uit het boek</a:t>
             </a:r>
           </a:p>
         </p:txBody>
@@ -22042,7 +22138,7 @@
           <p:cNvPr id="4" name="slide-number">
             <a:extLst xmlns:a="http://schemas.openxmlformats.org/drawingml/2006/main">
               <a:ext uri="{FF2B5EF4-FFF2-40B4-BE49-F238E27FC236}">
-                <a16:creationId xmlns:a16="http://schemas.microsoft.com/office/drawing/2014/main" id="{768CDF2A-B757-417D-AEC9-32AFC5E3B91D}"/>
+                <a16:creationId xmlns:a16="http://schemas.microsoft.com/office/drawing/2014/main" id="{685C09E6-A49F-476F-95BC-1F7A9164C365}"/>
               </a:ext>
             </a:extLst>
           </p:cNvPr>
@@ -22096,10 +22192,10 @@
       </p:sp>
       <p:sp>
         <p:nvSpPr>
-          <p:cNvPr id="5" name="SkateService · Opgave 4 · Eén stap uit de tabel">
-            <a:extLst xmlns:a="http://schemas.openxmlformats.org/drawingml/2006/main">
-              <a:ext uri="{FF2B5EF4-FFF2-40B4-BE49-F238E27FC236}">
-                <a16:creationId xmlns:a16="http://schemas.microsoft.com/office/drawing/2014/main" id="{F64A6336-575A-44C3-A59A-EB9F07E6C667}"/>
+          <p:cNvPr id="5" name="Van 20 naar 25 fietsen per dag">
+            <a:extLst xmlns:a="http://schemas.openxmlformats.org/drawingml/2006/main">
+              <a:ext uri="{FF2B5EF4-FFF2-40B4-BE49-F238E27FC236}">
+                <a16:creationId xmlns:a16="http://schemas.microsoft.com/office/drawing/2014/main" id="{C420B95E-E4DF-4472-999B-B4BA0F691D6C}"/>
               </a:ext>
             </a:extLst>
           </p:cNvPr>
@@ -22146,7 +22242,7 @@
                 <a:ea typeface="Arial"/>
                 <a:cs typeface="Arial"/>
               </a:rPr>
-              <a:t>SkateService · Opgave 4 · Eén stap uit de tabel</a:t>
+              <a:t>Van 20 naar 25 fietsen per dag</a:t>
             </a:r>
           </a:p>
         </p:txBody>
@@ -22185,7 +22281,7 @@
                           <a:ea typeface="Arial"/>
                           <a:cs typeface="Arial"/>
                         </a:rPr>
-                        <a:t>Q (beurten per week)</a:t>
+                        <a:t>Q (fietsen per dag)</a:t>
                       </a:r>
                     </a:p>
                   </a:txBody>
@@ -22209,7 +22305,7 @@
                           <a:ea typeface="Arial"/>
                           <a:cs typeface="Arial"/>
                         </a:rPr>
-                        <a:t>TK (€ per week)</a:t>
+                        <a:t>TK (€ per dag)</a:t>
                       </a:r>
                     </a:p>
                   </a:txBody>
@@ -22233,7 +22329,7 @@
                           <a:ea typeface="Arial"/>
                           <a:cs typeface="Arial"/>
                         </a:rPr>
-                        <a:t>TO (€ per week)</a:t>
+                        <a:t>TO (€ per dag)</a:t>
                       </a:r>
                     </a:p>
                   </a:txBody>
@@ -22259,7 +22355,7 @@
                           <a:ea typeface="Arial"/>
                           <a:cs typeface="Arial"/>
                         </a:rPr>
-                        <a:t>10</a:t>
+                        <a:t>20</a:t>
                       </a:r>
                     </a:p>
                   </a:txBody>
@@ -22283,7 +22379,7 @@
                           <a:ea typeface="Arial"/>
                           <a:cs typeface="Arial"/>
                         </a:rPr>
-                        <a:t>260</a:t>
+                        <a:t>76</a:t>
                       </a:r>
                     </a:p>
                   </a:txBody>
@@ -22307,7 +22403,7 @@
                           <a:ea typeface="Arial"/>
                           <a:cs typeface="Arial"/>
                         </a:rPr>
-                        <a:t>400</a:t>
+                        <a:t>100</a:t>
                       </a:r>
                     </a:p>
                   </a:txBody>
@@ -22333,7 +22429,7 @@
                           <a:ea typeface="Arial"/>
                           <a:cs typeface="Arial"/>
                         </a:rPr>
-                        <a:t>20</a:t>
+                        <a:t>25</a:t>
                       </a:r>
                     </a:p>
                   </a:txBody>
@@ -22357,7 +22453,7 @@
                           <a:ea typeface="Arial"/>
                           <a:cs typeface="Arial"/>
                         </a:rPr>
-                        <a:t>320</a:t>
+                        <a:t>86</a:t>
                       </a:r>
                     </a:p>
                   </a:txBody>
@@ -22381,7 +22477,7 @@
                           <a:ea typeface="Arial"/>
                           <a:cs typeface="Arial"/>
                         </a:rPr>
-                        <a:t>800</a:t>
+                        <a:t>125</a:t>
                       </a:r>
                     </a:p>
                   </a:txBody>
@@ -22398,10 +22494,10 @@
       </p:graphicFrame>
       <p:sp>
         <p:nvSpPr>
-          <p:cNvPr id="7" name="MK = ΔTK / ΔQ = (320 − 260) / (20 − 10) = € 6">
-            <a:extLst xmlns:a="http://schemas.openxmlformats.org/drawingml/2006/main">
-              <a:ext uri="{FF2B5EF4-FFF2-40B4-BE49-F238E27FC236}">
-                <a16:creationId xmlns:a16="http://schemas.microsoft.com/office/drawing/2014/main" id="{C3AA1D5F-F90B-43E6-95D4-4973830D9AF8}"/>
+          <p:cNvPr id="7" name="MK = ΔTK / ΔQ = (86 − 76) / (25 − 20) = € 2">
+            <a:extLst xmlns:a="http://schemas.openxmlformats.org/drawingml/2006/main">
+              <a:ext uri="{FF2B5EF4-FFF2-40B4-BE49-F238E27FC236}">
+                <a16:creationId xmlns:a16="http://schemas.microsoft.com/office/drawing/2014/main" id="{234B5252-A82E-4CE5-8617-591BA33092B4}"/>
               </a:ext>
             </a:extLst>
           </p:cNvPr>
@@ -22448,17 +22544,17 @@
                 <a:ea typeface="Arial"/>
                 <a:cs typeface="Arial"/>
               </a:rPr>
-              <a:t>MK = ΔTK / ΔQ = (320 − 260) / (20 − 10) = € 6</a:t>
-            </a:r>
-          </a:p>
-        </p:txBody>
-      </p:sp>
-      <p:sp>
-        <p:nvSpPr>
-          <p:cNvPr id="8" name="MO = ΔTO / ΔQ = (800 − 400) / (20 − 10) = € 40">
-            <a:extLst xmlns:a="http://schemas.openxmlformats.org/drawingml/2006/main">
-              <a:ext uri="{FF2B5EF4-FFF2-40B4-BE49-F238E27FC236}">
-                <a16:creationId xmlns:a16="http://schemas.microsoft.com/office/drawing/2014/main" id="{6078B20F-8928-47AF-802D-C4BA8D7986A4}"/>
+              <a:t>MK = ΔTK / ΔQ = (86 − 76) / (25 − 20) = € 2</a:t>
+            </a:r>
+          </a:p>
+        </p:txBody>
+      </p:sp>
+      <p:sp>
+        <p:nvSpPr>
+          <p:cNvPr id="8" name="MO = ΔTO / ΔQ = (125 − 100) / (25 − 20) = € 5">
+            <a:extLst xmlns:a="http://schemas.openxmlformats.org/drawingml/2006/main">
+              <a:ext uri="{FF2B5EF4-FFF2-40B4-BE49-F238E27FC236}">
+                <a16:creationId xmlns:a16="http://schemas.microsoft.com/office/drawing/2014/main" id="{A5657A78-55D0-4A9C-97D5-7FDF71352C70}"/>
               </a:ext>
             </a:extLst>
           </p:cNvPr>
@@ -22505,17 +22601,17 @@
                 <a:ea typeface="Arial"/>
                 <a:cs typeface="Arial"/>
               </a:rPr>
-              <a:t>MO = ΔTO / ΔQ = (800 − 400) / (20 − 10) = € 40</a:t>
-            </a:r>
-          </a:p>
-        </p:txBody>
-      </p:sp>
-      <p:sp>
-        <p:nvSpPr>
-          <p:cNvPr id="9" name="Beide bedragen zijn per extra onderhoudsbeurt.">
-            <a:extLst xmlns:a="http://schemas.openxmlformats.org/drawingml/2006/main">
-              <a:ext uri="{FF2B5EF4-FFF2-40B4-BE49-F238E27FC236}">
-                <a16:creationId xmlns:a16="http://schemas.microsoft.com/office/drawing/2014/main" id="{46A9B29C-4B4E-4098-B355-239258884224}"/>
+              <a:t>MO = ΔTO / ΔQ = (125 − 100) / (25 − 20) = € 5</a:t>
+            </a:r>
+          </a:p>
+        </p:txBody>
+      </p:sp>
+      <p:sp>
+        <p:nvSpPr>
+          <p:cNvPr id="9" name="Deel door de 5 extra fietsen. Bedragen: € per extra fiets.">
+            <a:extLst xmlns:a="http://schemas.openxmlformats.org/drawingml/2006/main">
+              <a:ext uri="{FF2B5EF4-FFF2-40B4-BE49-F238E27FC236}">
+                <a16:creationId xmlns:a16="http://schemas.microsoft.com/office/drawing/2014/main" id="{947AC13C-9CA1-47F7-876C-68984CC41AE0}"/>
               </a:ext>
             </a:extLst>
           </p:cNvPr>
@@ -22544,25 +22640,25 @@
           <a:lstStyle xmlns:a="http://schemas.openxmlformats.org/drawingml/2006/main"/>
           <a:p xmlns:a="http://schemas.openxmlformats.org/drawingml/2006/main">
             <a:pPr algn="l">
-              <a:defRPr sz="2700" b="0">
-                <a:solidFill>
-                  <a:srgbClr val="183247"/>
-                </a:solidFill>
-                <a:latin typeface="Arial"/>
-                <a:ea typeface="Arial"/>
-                <a:cs typeface="Arial"/>
-              </a:defRPr>
-            </a:pPr>
-            <a:r>
-              <a:rPr sz="2700" b="0">
-                <a:solidFill>
-                  <a:srgbClr val="183247"/>
-                </a:solidFill>
-                <a:latin typeface="Arial"/>
-                <a:ea typeface="Arial"/>
-                <a:cs typeface="Arial"/>
-              </a:rPr>
-              <a:t>Beide bedragen zijn per extra onderhoudsbeurt.</a:t>
+              <a:defRPr sz="2550" b="0">
+                <a:solidFill>
+                  <a:srgbClr val="183247"/>
+                </a:solidFill>
+                <a:latin typeface="Arial"/>
+                <a:ea typeface="Arial"/>
+                <a:cs typeface="Arial"/>
+              </a:defRPr>
+            </a:pPr>
+            <a:r>
+              <a:rPr sz="2550" b="0">
+                <a:solidFill>
+                  <a:srgbClr val="183247"/>
+                </a:solidFill>
+                <a:latin typeface="Arial"/>
+                <a:ea typeface="Arial"/>
+                <a:cs typeface="Arial"/>
+              </a:rPr>
+              <a:t>Deel door de 5 extra fietsen. Bedragen: € per extra fiets.</a:t>
             </a:r>
           </a:p>
         </p:txBody>
@@ -22570,7 +22666,7 @@
     </p:spTree>
     <p:extLst>
       <p:ext uri="{BB962C8B-B14F-4D97-AF65-F5344CB8AC3E}">
-        <p14:creationId xmlns:p14="http://schemas.microsoft.com/office/powerpoint/2010/main" val="2120659910"/>
+        <p14:creationId xmlns:p14="http://schemas.microsoft.com/office/powerpoint/2010/main" val="1482505921"/>
       </p:ext>
     </p:extLst>
   </p:cSld>
@@ -22598,10 +22694,10 @@
       </p:grpSpPr>
       <p:sp>
         <p:nvSpPr>
-          <p:cNvPr id="10" name="FotoFun: winst is een verticale afstand">
-            <a:extLst xmlns:a="http://schemas.openxmlformats.org/drawingml/2006/main">
-              <a:ext uri="{FF2B5EF4-FFF2-40B4-BE49-F238E27FC236}">
-                <a16:creationId xmlns:a16="http://schemas.microsoft.com/office/drawing/2014/main" id="{2D2012B4-389F-49B9-BA6C-DFF209ACE62C}"/>
+          <p:cNvPr id="10" name="FietsWas: break-even en winst in de grafiek">
+            <a:extLst xmlns:a="http://schemas.openxmlformats.org/drawingml/2006/main">
+              <a:ext uri="{FF2B5EF4-FFF2-40B4-BE49-F238E27FC236}">
+                <a16:creationId xmlns:a16="http://schemas.microsoft.com/office/drawing/2014/main" id="{938A015C-CCC4-4AAE-BA8B-F8745D60E516}"/>
               </a:ext>
             </a:extLst>
           </p:cNvPr>
@@ -22648,7 +22744,7 @@
                 <a:ea typeface="Arial"/>
                 <a:cs typeface="Arial"/>
               </a:rPr>
-              <a:t>FotoFun: winst is een verticale afstand</a:t>
+              <a:t>FietsWas: break-even en winst in de grafiek</a:t>
             </a:r>
           </a:p>
         </p:txBody>
@@ -22658,7 +22754,7 @@
           <p:cNvPr id="2" name="">
             <a:extLst xmlns:a="http://schemas.openxmlformats.org/drawingml/2006/main">
               <a:ext uri="{FF2B5EF4-FFF2-40B4-BE49-F238E27FC236}">
-                <a16:creationId xmlns:a16="http://schemas.microsoft.com/office/drawing/2014/main" id="{11F22E4F-76ED-486D-B10F-44BBF769A8AE}"/>
+                <a16:creationId xmlns:a16="http://schemas.microsoft.com/office/drawing/2014/main" id="{B6BAEED5-A631-434E-A630-6DCBCE2FDB39}"/>
               </a:ext>
             </a:extLst>
           </p:cNvPr>
@@ -22684,10 +22780,10 @@
       </p:sp>
       <p:sp>
         <p:nvSpPr>
-          <p:cNvPr id="3" name="§2.1.4 Gemengde opgaven">
-            <a:extLst xmlns:a="http://schemas.openxmlformats.org/drawingml/2006/main">
-              <a:ext uri="{FF2B5EF4-FFF2-40B4-BE49-F238E27FC236}">
-                <a16:creationId xmlns:a16="http://schemas.microsoft.com/office/drawing/2014/main" id="{7D084F96-9687-4ADE-97F0-5CBBA7BEA81C}"/>
+          <p:cNvPr id="3" name="§2.1.4 Gemengde opgaven · Uitlegvoorbeeld — niet uit het boe">
+            <a:extLst xmlns:a="http://schemas.openxmlformats.org/drawingml/2006/main">
+              <a:ext uri="{FF2B5EF4-FFF2-40B4-BE49-F238E27FC236}">
+                <a16:creationId xmlns:a16="http://schemas.microsoft.com/office/drawing/2014/main" id="{37625C63-1A34-4593-906F-662414E91847}"/>
               </a:ext>
             </a:extLst>
           </p:cNvPr>
@@ -22734,7 +22830,7 @@
                 <a:ea typeface="Arial"/>
                 <a:cs typeface="Arial"/>
               </a:rPr>
-              <a:t>§2.1.4 Gemengde opgaven</a:t>
+              <a:t>§2.1.4 Gemengde opgaven · Uitlegvoorbeeld — niet uit het boek</a:t>
             </a:r>
           </a:p>
         </p:txBody>
@@ -22744,7 +22840,7 @@
           <p:cNvPr id="4" name="slide-number">
             <a:extLst xmlns:a="http://schemas.openxmlformats.org/drawingml/2006/main">
               <a:ext uri="{FF2B5EF4-FFF2-40B4-BE49-F238E27FC236}">
-                <a16:creationId xmlns:a16="http://schemas.microsoft.com/office/drawing/2014/main" id="{A6F82DC7-DC73-4EA6-A9A0-5C18E14D598B}"/>
+                <a16:creationId xmlns:a16="http://schemas.microsoft.com/office/drawing/2014/main" id="{FCA1B2B4-EB41-4261-8E6C-E37095DC4C3C}"/>
               </a:ext>
             </a:extLst>
           </p:cNvPr>
@@ -22808,16 +22904,16 @@
         </p:xfrm>
         <a:graphic xmlns:a="http://schemas.openxmlformats.org/drawingml/2006/main">
           <a:graphicData uri="http://schemas.openxmlformats.org/drawingml/2006/chart">
-            <c:chart xmlns:r="http://schemas.openxmlformats.org/officeDocument/2006/relationships" xmlns:c="http://schemas.openxmlformats.org/drawingml/2006/chart" r:id="Rd71d6a5492d14315"/>
+            <c:chart xmlns:r="http://schemas.openxmlformats.org/officeDocument/2006/relationships" xmlns:c="http://schemas.openxmlformats.org/drawingml/2006/chart" r:id="R8a54b48c6bda4d8c"/>
           </a:graphicData>
         </a:graphic>
       </p:graphicFrame>
       <p:sp>
         <p:nvSpPr>
-          <p:cNvPr id="6" name="Bij Q = 90">
-            <a:extLst xmlns:a="http://schemas.openxmlformats.org/drawingml/2006/main">
-              <a:ext uri="{FF2B5EF4-FFF2-40B4-BE49-F238E27FC236}">
-                <a16:creationId xmlns:a16="http://schemas.microsoft.com/office/drawing/2014/main" id="{42CA32CF-F719-4699-B6B7-B04F9817D262}"/>
+          <p:cNvPr id="6" name="Break-even:&#10;(12; 60)">
+            <a:extLst xmlns:a="http://schemas.openxmlformats.org/drawingml/2006/main">
+              <a:ext uri="{FF2B5EF4-FFF2-40B4-BE49-F238E27FC236}">
+                <a16:creationId xmlns:a16="http://schemas.microsoft.com/office/drawing/2014/main" id="{7A260FC7-D189-4DA4-8AB6-EF9C3DDED7CB}"/>
               </a:ext>
             </a:extLst>
           </p:cNvPr>
@@ -22829,7 +22925,7 @@
         <p:spPr>
           <a:xfrm xmlns:a="http://schemas.openxmlformats.org/drawingml/2006/main">
             <a:off x="11334750" y="2219325"/>
-            <a:ext cx="3333750" cy="571500"/>
+            <a:ext cx="3333750" cy="1009650"/>
           </a:xfrm>
           <a:prstGeom xmlns:a="http://schemas.openxmlformats.org/drawingml/2006/main" prst="rect">
             <a:avLst/>
@@ -22864,29 +22960,52 @@
                 <a:ea typeface="Arial"/>
                 <a:cs typeface="Arial"/>
               </a:rPr>
-              <a:t>Bij Q = 90</a:t>
-            </a:r>
-          </a:p>
-        </p:txBody>
-      </p:sp>
-      <p:sp>
-        <p:nvSpPr>
-          <p:cNvPr id="7" name="TO = € 540&#10;TK = € 420">
-            <a:extLst xmlns:a="http://schemas.openxmlformats.org/drawingml/2006/main">
-              <a:ext uri="{FF2B5EF4-FFF2-40B4-BE49-F238E27FC236}">
-                <a16:creationId xmlns:a16="http://schemas.microsoft.com/office/drawing/2014/main" id="{3828C7E7-8934-4D48-A886-6C90DF3A6FBE}"/>
-              </a:ext>
-            </a:extLst>
-          </p:cNvPr>
-          <p:cNvSpPr>
-            <a:spLocks xmlns:a="http://schemas.openxmlformats.org/drawingml/2006/main" noGrp="1"/>
-          </p:cNvSpPr>
-          <p:nvPr/>
-        </p:nvSpPr>
-        <p:spPr>
-          <a:xfrm xmlns:a="http://schemas.openxmlformats.org/drawingml/2006/main">
-            <a:off x="11334750" y="3248025"/>
-            <a:ext cx="3333750" cy="1257300"/>
+              <a:t>Break-even:</a:t>
+            </a:r>
+          </a:p>
+          <a:p xmlns:a="http://schemas.openxmlformats.org/drawingml/2006/main">
+            <a:pPr algn="l">
+              <a:defRPr sz="2625" b="1">
+                <a:solidFill>
+                  <a:srgbClr val="183247"/>
+                </a:solidFill>
+                <a:latin typeface="Arial"/>
+                <a:ea typeface="Arial"/>
+                <a:cs typeface="Arial"/>
+              </a:defRPr>
+            </a:pPr>
+            <a:r>
+              <a:rPr sz="2625" b="1">
+                <a:solidFill>
+                  <a:srgbClr val="183247"/>
+                </a:solidFill>
+                <a:latin typeface="Arial"/>
+                <a:ea typeface="Arial"/>
+                <a:cs typeface="Arial"/>
+              </a:rPr>
+              <a:t>(12; 60)</a:t>
+            </a:r>
+          </a:p>
+        </p:txBody>
+      </p:sp>
+      <p:sp>
+        <p:nvSpPr>
+          <p:cNvPr id="7" name="Bij Q = 20:&#10;TO = € 100&#10;TK = € 76">
+            <a:extLst xmlns:a="http://schemas.openxmlformats.org/drawingml/2006/main">
+              <a:ext uri="{FF2B5EF4-FFF2-40B4-BE49-F238E27FC236}">
+                <a16:creationId xmlns:a16="http://schemas.microsoft.com/office/drawing/2014/main" id="{B3279F62-FA85-4B0C-8E0E-A5C3D370A1AD}"/>
+              </a:ext>
+            </a:extLst>
+          </p:cNvPr>
+          <p:cNvSpPr>
+            <a:spLocks xmlns:a="http://schemas.openxmlformats.org/drawingml/2006/main" noGrp="1"/>
+          </p:cNvSpPr>
+          <p:nvPr/>
+        </p:nvSpPr>
+        <p:spPr>
+          <a:xfrm xmlns:a="http://schemas.openxmlformats.org/drawingml/2006/main">
+            <a:off x="11334750" y="3581400"/>
+            <a:ext cx="3333750" cy="1476375"/>
           </a:xfrm>
           <a:prstGeom xmlns:a="http://schemas.openxmlformats.org/drawingml/2006/main" prst="rect">
             <a:avLst/>
@@ -22921,7 +23040,7 @@
                 <a:ea typeface="Arial"/>
                 <a:cs typeface="Arial"/>
               </a:rPr>
-              <a:t>TO = € 540</a:t>
+              <a:t>Bij Q = 20:</a:t>
             </a:r>
           </a:p>
           <a:p xmlns:a="http://schemas.openxmlformats.org/drawingml/2006/main">
@@ -22944,29 +23063,52 @@
                 <a:ea typeface="Arial"/>
                 <a:cs typeface="Arial"/>
               </a:rPr>
-              <a:t>TK = € 420</a:t>
-            </a:r>
-          </a:p>
-        </p:txBody>
-      </p:sp>
-      <p:sp>
-        <p:nvSpPr>
-          <p:cNvPr id="8" name="Winst = € 120&#10;per feest">
-            <a:extLst xmlns:a="http://schemas.openxmlformats.org/drawingml/2006/main">
-              <a:ext uri="{FF2B5EF4-FFF2-40B4-BE49-F238E27FC236}">
-                <a16:creationId xmlns:a16="http://schemas.microsoft.com/office/drawing/2014/main" id="{726BC9C8-6F0A-4AE5-8DC4-EA47CD0166F5}"/>
-              </a:ext>
-            </a:extLst>
-          </p:cNvPr>
-          <p:cNvSpPr>
-            <a:spLocks xmlns:a="http://schemas.openxmlformats.org/drawingml/2006/main" noGrp="1"/>
-          </p:cNvSpPr>
-          <p:nvPr/>
-        </p:nvSpPr>
-        <p:spPr>
-          <a:xfrm xmlns:a="http://schemas.openxmlformats.org/drawingml/2006/main">
-            <a:off x="11334750" y="4848225"/>
-            <a:ext cx="3333750" cy="1238250"/>
+              <a:t>TO = € 100</a:t>
+            </a:r>
+          </a:p>
+          <a:p xmlns:a="http://schemas.openxmlformats.org/drawingml/2006/main">
+            <a:pPr algn="l">
+              <a:defRPr sz="2550" b="0">
+                <a:solidFill>
+                  <a:srgbClr val="183247"/>
+                </a:solidFill>
+                <a:latin typeface="Arial"/>
+                <a:ea typeface="Arial"/>
+                <a:cs typeface="Arial"/>
+              </a:defRPr>
+            </a:pPr>
+            <a:r>
+              <a:rPr sz="2550" b="0">
+                <a:solidFill>
+                  <a:srgbClr val="183247"/>
+                </a:solidFill>
+                <a:latin typeface="Arial"/>
+                <a:ea typeface="Arial"/>
+                <a:cs typeface="Arial"/>
+              </a:rPr>
+              <a:t>TK = € 76</a:t>
+            </a:r>
+          </a:p>
+        </p:txBody>
+      </p:sp>
+      <p:sp>
+        <p:nvSpPr>
+          <p:cNvPr id="8" name="Winst = € 24&#10;per dag">
+            <a:extLst xmlns:a="http://schemas.openxmlformats.org/drawingml/2006/main">
+              <a:ext uri="{FF2B5EF4-FFF2-40B4-BE49-F238E27FC236}">
+                <a16:creationId xmlns:a16="http://schemas.microsoft.com/office/drawing/2014/main" id="{65E0DC26-B78A-42D5-AD3F-6DE7D2931B19}"/>
+              </a:ext>
+            </a:extLst>
+          </p:cNvPr>
+          <p:cNvSpPr>
+            <a:spLocks xmlns:a="http://schemas.openxmlformats.org/drawingml/2006/main" noGrp="1"/>
+          </p:cNvSpPr>
+          <p:nvPr/>
+        </p:nvSpPr>
+        <p:spPr>
+          <a:xfrm xmlns:a="http://schemas.openxmlformats.org/drawingml/2006/main">
+            <a:off x="11334750" y="5410200"/>
+            <a:ext cx="3333750" cy="1104900"/>
           </a:xfrm>
           <a:prstGeom xmlns:a="http://schemas.openxmlformats.org/drawingml/2006/main" prst="rect">
             <a:avLst/>
@@ -23001,7 +23143,7 @@
                 <a:ea typeface="Arial"/>
                 <a:cs typeface="Arial"/>
               </a:rPr>
-              <a:t>Winst = € 120</a:t>
+              <a:t>Winst = € 24</a:t>
             </a:r>
           </a:p>
           <a:p xmlns:a="http://schemas.openxmlformats.org/drawingml/2006/main">
@@ -23024,29 +23166,29 @@
                 <a:ea typeface="Arial"/>
                 <a:cs typeface="Arial"/>
               </a:rPr>
-              <a:t>per feest</a:t>
-            </a:r>
-          </a:p>
-        </p:txBody>
-      </p:sp>
-      <p:sp>
-        <p:nvSpPr>
-          <p:cNvPr id="9" name="Dezelfde Q,&#10;twee lijnhoogten.">
-            <a:extLst xmlns:a="http://schemas.openxmlformats.org/drawingml/2006/main">
-              <a:ext uri="{FF2B5EF4-FFF2-40B4-BE49-F238E27FC236}">
-                <a16:creationId xmlns:a16="http://schemas.microsoft.com/office/drawing/2014/main" id="{118E2654-4A2E-4461-9916-15E08A4B3150}"/>
-              </a:ext>
-            </a:extLst>
-          </p:cNvPr>
-          <p:cNvSpPr>
-            <a:spLocks xmlns:a="http://schemas.openxmlformats.org/drawingml/2006/main" noGrp="1"/>
-          </p:cNvSpPr>
-          <p:nvPr/>
-        </p:nvSpPr>
-        <p:spPr>
-          <a:xfrm xmlns:a="http://schemas.openxmlformats.org/drawingml/2006/main">
-            <a:off x="11334750" y="6753225"/>
-            <a:ext cx="3333750" cy="914400"/>
+              <a:t>per dag</a:t>
+            </a:r>
+          </a:p>
+        </p:txBody>
+      </p:sp>
+      <p:sp>
+        <p:nvSpPr>
+          <p:cNvPr id="9" name="Capaciteit:&#10;40 fietsen per dag">
+            <a:extLst xmlns:a="http://schemas.openxmlformats.org/drawingml/2006/main">
+              <a:ext uri="{FF2B5EF4-FFF2-40B4-BE49-F238E27FC236}">
+                <a16:creationId xmlns:a16="http://schemas.microsoft.com/office/drawing/2014/main" id="{85E414E1-C92A-4079-86A9-8EC39A9DDD2B}"/>
+              </a:ext>
+            </a:extLst>
+          </p:cNvPr>
+          <p:cNvSpPr>
+            <a:spLocks xmlns:a="http://schemas.openxmlformats.org/drawingml/2006/main" noGrp="1"/>
+          </p:cNvSpPr>
+          <p:nvPr/>
+        </p:nvSpPr>
+        <p:spPr>
+          <a:xfrm xmlns:a="http://schemas.openxmlformats.org/drawingml/2006/main">
+            <a:off x="11334750" y="6915150"/>
+            <a:ext cx="3333750" cy="876300"/>
           </a:xfrm>
           <a:prstGeom xmlns:a="http://schemas.openxmlformats.org/drawingml/2006/main" prst="rect">
             <a:avLst/>
@@ -23081,7 +23223,7 @@
                 <a:ea typeface="Arial"/>
                 <a:cs typeface="Arial"/>
               </a:rPr>
-              <a:t>Dezelfde Q,</a:t>
+              <a:t>Capaciteit:</a:t>
             </a:r>
           </a:p>
           <a:p xmlns:a="http://schemas.openxmlformats.org/drawingml/2006/main">
@@ -23104,7 +23246,7 @@
                 <a:ea typeface="Arial"/>
                 <a:cs typeface="Arial"/>
               </a:rPr>
-              <a:t>twee lijnhoogten.</a:t>
+              <a:t>40 fietsen per dag</a:t>
             </a:r>
           </a:p>
         </p:txBody>
@@ -23112,7 +23254,7 @@
     </p:spTree>
     <p:extLst>
       <p:ext uri="{BB962C8B-B14F-4D97-AF65-F5344CB8AC3E}">
-        <p14:creationId xmlns:p14="http://schemas.microsoft.com/office/powerpoint/2010/main" val="1732259981"/>
+        <p14:creationId xmlns:p14="http://schemas.microsoft.com/office/powerpoint/2010/main" val="1365175230"/>
       </p:ext>
     </p:extLst>
   </p:cSld>
@@ -23143,7 +23285,7 @@
           <p:cNvPr id="29" name="Deze les: §2.1.4 Gemengde opgaven">
             <a:extLst xmlns:a="http://schemas.openxmlformats.org/drawingml/2006/main">
               <a:ext uri="{FF2B5EF4-FFF2-40B4-BE49-F238E27FC236}">
-                <a16:creationId xmlns:a16="http://schemas.microsoft.com/office/drawing/2014/main" id="{A8FEACF7-8D75-4907-95C6-D0C1FA8A479C}"/>
+                <a16:creationId xmlns:a16="http://schemas.microsoft.com/office/drawing/2014/main" id="{E891D6C8-5780-4136-9633-E7C29F578473}"/>
               </a:ext>
             </a:extLst>
           </p:cNvPr>
@@ -23200,7 +23342,7 @@
           <p:cNvPr id="2" name="">
             <a:extLst xmlns:a="http://schemas.openxmlformats.org/drawingml/2006/main">
               <a:ext uri="{FF2B5EF4-FFF2-40B4-BE49-F238E27FC236}">
-                <a16:creationId xmlns:a16="http://schemas.microsoft.com/office/drawing/2014/main" id="{8B9544A5-F305-4E5F-97CB-D27953A6477B}"/>
+                <a16:creationId xmlns:a16="http://schemas.microsoft.com/office/drawing/2014/main" id="{9F80653E-D916-4B7C-8F8F-87B04014B757}"/>
               </a:ext>
             </a:extLst>
           </p:cNvPr>
@@ -23229,7 +23371,7 @@
           <p:cNvPr id="3" name="§2.1.4 Gemengde opgaven">
             <a:extLst xmlns:a="http://schemas.openxmlformats.org/drawingml/2006/main">
               <a:ext uri="{FF2B5EF4-FFF2-40B4-BE49-F238E27FC236}">
-                <a16:creationId xmlns:a16="http://schemas.microsoft.com/office/drawing/2014/main" id="{EA8C21F8-B75E-4802-94D7-EAA9AB59E218}"/>
+                <a16:creationId xmlns:a16="http://schemas.microsoft.com/office/drawing/2014/main" id="{FE59196E-A839-4019-8BAC-DA225E865F49}"/>
               </a:ext>
             </a:extLst>
           </p:cNvPr>
@@ -23286,7 +23428,7 @@
           <p:cNvPr id="4" name="slide-number">
             <a:extLst xmlns:a="http://schemas.openxmlformats.org/drawingml/2006/main">
               <a:ext uri="{FF2B5EF4-FFF2-40B4-BE49-F238E27FC236}">
-                <a16:creationId xmlns:a16="http://schemas.microsoft.com/office/drawing/2014/main" id="{E8E971BA-7EDD-4FA4-B67C-77051FA1FA9B}"/>
+                <a16:creationId xmlns:a16="http://schemas.microsoft.com/office/drawing/2014/main" id="{1F0A0999-EEAE-4DEE-9B1F-17BB1AB26F30}"/>
               </a:ext>
             </a:extLst>
           </p:cNvPr>
@@ -23343,7 +23485,7 @@
           <p:cNvPr id="5" name="phase">
             <a:extLst xmlns:a="http://schemas.openxmlformats.org/drawingml/2006/main">
               <a:ext uri="{FF2B5EF4-FFF2-40B4-BE49-F238E27FC236}">
-                <a16:creationId xmlns:a16="http://schemas.microsoft.com/office/drawing/2014/main" id="{463B04E0-83C8-4899-A996-BF11910FCA22}"/>
+                <a16:creationId xmlns:a16="http://schemas.microsoft.com/office/drawing/2014/main" id="{42926869-A6AF-4225-A831-532CA627C683}"/>
               </a:ext>
             </a:extLst>
           </p:cNvPr>
@@ -23400,7 +23542,7 @@
           <p:cNvPr id="6" name="Lesroute">
             <a:extLst xmlns:a="http://schemas.openxmlformats.org/drawingml/2006/main">
               <a:ext uri="{FF2B5EF4-FFF2-40B4-BE49-F238E27FC236}">
-                <a16:creationId xmlns:a16="http://schemas.microsoft.com/office/drawing/2014/main" id="{CCE152F7-7F33-41A0-A3D3-92054E8B9C7F}"/>
+                <a16:creationId xmlns:a16="http://schemas.microsoft.com/office/drawing/2014/main" id="{B0AD8E24-4CA7-409A-80FF-AE7EFEBACAF8}"/>
               </a:ext>
             </a:extLst>
           </p:cNvPr>
@@ -23457,7 +23599,7 @@
           <p:cNvPr id="7" name="route-number-1">
             <a:extLst xmlns:a="http://schemas.openxmlformats.org/drawingml/2006/main">
               <a:ext uri="{FF2B5EF4-FFF2-40B4-BE49-F238E27FC236}">
-                <a16:creationId xmlns:a16="http://schemas.microsoft.com/office/drawing/2014/main" id="{6B934F3B-CAD0-4865-BF22-1525F3D7959A}"/>
+                <a16:creationId xmlns:a16="http://schemas.microsoft.com/office/drawing/2014/main" id="{55C77D9E-F28D-4327-A8F6-D16C3E7F32B8}"/>
               </a:ext>
             </a:extLst>
           </p:cNvPr>
@@ -23514,7 +23656,7 @@
           <p:cNvPr id="8" name="route-1">
             <a:extLst xmlns:a="http://schemas.openxmlformats.org/drawingml/2006/main">
               <a:ext uri="{FF2B5EF4-FFF2-40B4-BE49-F238E27FC236}">
-                <a16:creationId xmlns:a16="http://schemas.microsoft.com/office/drawing/2014/main" id="{28C7970D-8818-40EC-A59E-69E02D047B2B}"/>
+                <a16:creationId xmlns:a16="http://schemas.microsoft.com/office/drawing/2014/main" id="{A88B7AE7-F2DF-4BDA-AAA5-6E4A7E678546}"/>
               </a:ext>
             </a:extLst>
           </p:cNvPr>
@@ -23571,7 +23713,7 @@
           <p:cNvPr id="9" name="route-number-2">
             <a:extLst xmlns:a="http://schemas.openxmlformats.org/drawingml/2006/main">
               <a:ext uri="{FF2B5EF4-FFF2-40B4-BE49-F238E27FC236}">
-                <a16:creationId xmlns:a16="http://schemas.microsoft.com/office/drawing/2014/main" id="{2589826B-0914-4477-858B-69C77D70EC76}"/>
+                <a16:creationId xmlns:a16="http://schemas.microsoft.com/office/drawing/2014/main" id="{DB5D2B54-F665-40EC-B293-EDAFAFA9F80E}"/>
               </a:ext>
             </a:extLst>
           </p:cNvPr>
@@ -23628,7 +23770,7 @@
           <p:cNvPr id="10" name="route-2">
             <a:extLst xmlns:a="http://schemas.openxmlformats.org/drawingml/2006/main">
               <a:ext uri="{FF2B5EF4-FFF2-40B4-BE49-F238E27FC236}">
-                <a16:creationId xmlns:a16="http://schemas.microsoft.com/office/drawing/2014/main" id="{55892546-41CC-4509-ADCE-899DE94D9CCA}"/>
+                <a16:creationId xmlns:a16="http://schemas.microsoft.com/office/drawing/2014/main" id="{25ACE029-DA14-4EF4-A390-EC939BF7382C}"/>
               </a:ext>
             </a:extLst>
           </p:cNvPr>
@@ -23685,7 +23827,7 @@
           <p:cNvPr id="11" name="route-number-3">
             <a:extLst xmlns:a="http://schemas.openxmlformats.org/drawingml/2006/main">
               <a:ext uri="{FF2B5EF4-FFF2-40B4-BE49-F238E27FC236}">
-                <a16:creationId xmlns:a16="http://schemas.microsoft.com/office/drawing/2014/main" id="{E44CF8EA-FBAE-402D-B92C-2463D224341E}"/>
+                <a16:creationId xmlns:a16="http://schemas.microsoft.com/office/drawing/2014/main" id="{061CCD82-790B-4BE7-B942-1329F171C171}"/>
               </a:ext>
             </a:extLst>
           </p:cNvPr>
@@ -23742,7 +23884,7 @@
           <p:cNvPr id="12" name="route-3">
             <a:extLst xmlns:a="http://schemas.openxmlformats.org/drawingml/2006/main">
               <a:ext uri="{FF2B5EF4-FFF2-40B4-BE49-F238E27FC236}">
-                <a16:creationId xmlns:a16="http://schemas.microsoft.com/office/drawing/2014/main" id="{6E0E32D6-ED7A-48FE-A700-6BA8844AF3F9}"/>
+                <a16:creationId xmlns:a16="http://schemas.microsoft.com/office/drawing/2014/main" id="{656097EA-DF00-48E2-A12B-89C8A7017348}"/>
               </a:ext>
             </a:extLst>
           </p:cNvPr>
@@ -23799,7 +23941,7 @@
           <p:cNvPr id="13" name="route-number-4">
             <a:extLst xmlns:a="http://schemas.openxmlformats.org/drawingml/2006/main">
               <a:ext uri="{FF2B5EF4-FFF2-40B4-BE49-F238E27FC236}">
-                <a16:creationId xmlns:a16="http://schemas.microsoft.com/office/drawing/2014/main" id="{FA4D6843-E6A3-4A9A-ADB3-D5C703E91741}"/>
+                <a16:creationId xmlns:a16="http://schemas.microsoft.com/office/drawing/2014/main" id="{C7EFE596-2829-48C4-8C91-0000345BB1AC}"/>
               </a:ext>
             </a:extLst>
           </p:cNvPr>
@@ -23856,7 +23998,7 @@
           <p:cNvPr id="14" name="route-4">
             <a:extLst xmlns:a="http://schemas.openxmlformats.org/drawingml/2006/main">
               <a:ext uri="{FF2B5EF4-FFF2-40B4-BE49-F238E27FC236}">
-                <a16:creationId xmlns:a16="http://schemas.microsoft.com/office/drawing/2014/main" id="{B236B009-E917-41D9-8143-E25DF38F0C3B}"/>
+                <a16:creationId xmlns:a16="http://schemas.microsoft.com/office/drawing/2014/main" id="{ACD718E1-658D-4EE4-A141-E61EC4BB7848}"/>
               </a:ext>
             </a:extLst>
           </p:cNvPr>
@@ -23913,7 +24055,7 @@
           <p:cNvPr id="15" name="route-number-5">
             <a:extLst xmlns:a="http://schemas.openxmlformats.org/drawingml/2006/main">
               <a:ext uri="{FF2B5EF4-FFF2-40B4-BE49-F238E27FC236}">
-                <a16:creationId xmlns:a16="http://schemas.microsoft.com/office/drawing/2014/main" id="{1A5A3058-75E0-4385-8C0C-4B1AB47A5A9E}"/>
+                <a16:creationId xmlns:a16="http://schemas.microsoft.com/office/drawing/2014/main" id="{5C9AE63C-2FDB-4F4C-A5EB-ABC08C864D8F}"/>
               </a:ext>
             </a:extLst>
           </p:cNvPr>
@@ -23970,7 +24112,7 @@
           <p:cNvPr id="16" name="route-5">
             <a:extLst xmlns:a="http://schemas.openxmlformats.org/drawingml/2006/main">
               <a:ext uri="{FF2B5EF4-FFF2-40B4-BE49-F238E27FC236}">
-                <a16:creationId xmlns:a16="http://schemas.microsoft.com/office/drawing/2014/main" id="{8B8409B0-2FFB-414B-B7A7-C319F3D38C2B}"/>
+                <a16:creationId xmlns:a16="http://schemas.microsoft.com/office/drawing/2014/main" id="{9B395BF2-9AA1-4F78-8ECD-19C1961C2DB2}"/>
               </a:ext>
             </a:extLst>
           </p:cNvPr>
@@ -24027,7 +24169,7 @@
           <p:cNvPr id="17" name="route-number-6">
             <a:extLst xmlns:a="http://schemas.openxmlformats.org/drawingml/2006/main">
               <a:ext uri="{FF2B5EF4-FFF2-40B4-BE49-F238E27FC236}">
-                <a16:creationId xmlns:a16="http://schemas.microsoft.com/office/drawing/2014/main" id="{9C68D6F6-5DD5-4EA7-AD98-C48CC7EDDFDC}"/>
+                <a16:creationId xmlns:a16="http://schemas.microsoft.com/office/drawing/2014/main" id="{1B5EC767-EB30-407A-A5A8-70891875002E}"/>
               </a:ext>
             </a:extLst>
           </p:cNvPr>
@@ -24084,7 +24226,7 @@
           <p:cNvPr id="18" name="route-6">
             <a:extLst xmlns:a="http://schemas.openxmlformats.org/drawingml/2006/main">
               <a:ext uri="{FF2B5EF4-FFF2-40B4-BE49-F238E27FC236}">
-                <a16:creationId xmlns:a16="http://schemas.microsoft.com/office/drawing/2014/main" id="{772D52B8-875C-411F-A24E-B9C5B2DECA52}"/>
+                <a16:creationId xmlns:a16="http://schemas.microsoft.com/office/drawing/2014/main" id="{212DDCB4-64A2-4184-B2A9-BFA5D3369F0D}"/>
               </a:ext>
             </a:extLst>
           </p:cNvPr>
@@ -24141,7 +24283,7 @@
           <p:cNvPr id="19" name="route-number-7">
             <a:extLst xmlns:a="http://schemas.openxmlformats.org/drawingml/2006/main">
               <a:ext uri="{FF2B5EF4-FFF2-40B4-BE49-F238E27FC236}">
-                <a16:creationId xmlns:a16="http://schemas.microsoft.com/office/drawing/2014/main" id="{9E345E33-9555-406E-9275-0AFE32312257}"/>
+                <a16:creationId xmlns:a16="http://schemas.microsoft.com/office/drawing/2014/main" id="{A92165A2-B72D-449B-99B6-32A48CED34AB}"/>
               </a:ext>
             </a:extLst>
           </p:cNvPr>
@@ -24198,7 +24340,7 @@
           <p:cNvPr id="20" name="route-7">
             <a:extLst xmlns:a="http://schemas.openxmlformats.org/drawingml/2006/main">
               <a:ext uri="{FF2B5EF4-FFF2-40B4-BE49-F238E27FC236}">
-                <a16:creationId xmlns:a16="http://schemas.microsoft.com/office/drawing/2014/main" id="{E7347526-452F-4F51-8418-3615ECFE0C0F}"/>
+                <a16:creationId xmlns:a16="http://schemas.microsoft.com/office/drawing/2014/main" id="{404C48E0-D51E-4537-84F9-F46A44CCE06A}"/>
               </a:ext>
             </a:extLst>
           </p:cNvPr>
@@ -24255,7 +24397,7 @@
           <p:cNvPr id="21" name="Lesdoelen">
             <a:extLst xmlns:a="http://schemas.openxmlformats.org/drawingml/2006/main">
               <a:ext uri="{FF2B5EF4-FFF2-40B4-BE49-F238E27FC236}">
-                <a16:creationId xmlns:a16="http://schemas.microsoft.com/office/drawing/2014/main" id="{269368DD-F3D9-4740-8819-725345CC14CB}"/>
+                <a16:creationId xmlns:a16="http://schemas.microsoft.com/office/drawing/2014/main" id="{47C83DF2-B93B-41CF-8CB2-F08E72A8D1F2}"/>
               </a:ext>
             </a:extLst>
           </p:cNvPr>
@@ -24312,7 +24454,7 @@
           <p:cNvPr id="22" name="overview-goals">
             <a:extLst xmlns:a="http://schemas.openxmlformats.org/drawingml/2006/main">
               <a:ext uri="{FF2B5EF4-FFF2-40B4-BE49-F238E27FC236}">
-                <a16:creationId xmlns:a16="http://schemas.microsoft.com/office/drawing/2014/main" id="{21794FAA-74F5-484F-8581-ADE6B6CFB3C0}"/>
+                <a16:creationId xmlns:a16="http://schemas.microsoft.com/office/drawing/2014/main" id="{176F7D8F-9F23-480A-91E4-79CE6FCDC975}"/>
               </a:ext>
             </a:extLst>
           </p:cNvPr>
@@ -24415,7 +24557,7 @@
           <p:cNvPr id="23" name="">
             <a:extLst xmlns:a="http://schemas.openxmlformats.org/drawingml/2006/main">
               <a:ext uri="{FF2B5EF4-FFF2-40B4-BE49-F238E27FC236}">
-                <a16:creationId xmlns:a16="http://schemas.microsoft.com/office/drawing/2014/main" id="{1278FFB4-FFFA-4F18-B0B7-12F6EC7FEE22}"/>
+                <a16:creationId xmlns:a16="http://schemas.microsoft.com/office/drawing/2014/main" id="{E27BDD01-4FB0-4EA9-9E4F-6AD2E40C2AFD}"/>
               </a:ext>
             </a:extLst>
           </p:cNvPr>
@@ -24444,7 +24586,7 @@
           <p:cNvPr id="24" name="Startopdracht">
             <a:extLst xmlns:a="http://schemas.openxmlformats.org/drawingml/2006/main">
               <a:ext uri="{FF2B5EF4-FFF2-40B4-BE49-F238E27FC236}">
-                <a16:creationId xmlns:a16="http://schemas.microsoft.com/office/drawing/2014/main" id="{185D8102-63C1-4EB3-879F-AA823F50DC26}"/>
+                <a16:creationId xmlns:a16="http://schemas.microsoft.com/office/drawing/2014/main" id="{FD61B115-994F-40D5-A59F-2A39AEE781FC}"/>
               </a:ext>
             </a:extLst>
           </p:cNvPr>
@@ -24501,7 +24643,7 @@
           <p:cNvPr id="25" name="overview-start">
             <a:extLst xmlns:a="http://schemas.openxmlformats.org/drawingml/2006/main">
               <a:ext uri="{FF2B5EF4-FFF2-40B4-BE49-F238E27FC236}">
-                <a16:creationId xmlns:a16="http://schemas.microsoft.com/office/drawing/2014/main" id="{A81374DB-3BC5-48AC-B404-A2494D34AAC5}"/>
+                <a16:creationId xmlns:a16="http://schemas.microsoft.com/office/drawing/2014/main" id="{ABFAA1B7-DA64-4AAE-B224-F628723957CD}"/>
               </a:ext>
             </a:extLst>
           </p:cNvPr>
@@ -24581,7 +24723,7 @@
           <p:cNvPr id="26" name="">
             <a:extLst xmlns:a="http://schemas.openxmlformats.org/drawingml/2006/main">
               <a:ext uri="{FF2B5EF4-FFF2-40B4-BE49-F238E27FC236}">
-                <a16:creationId xmlns:a16="http://schemas.microsoft.com/office/drawing/2014/main" id="{231E2732-9408-4930-A660-B10FCBE1DCEF}"/>
+                <a16:creationId xmlns:a16="http://schemas.microsoft.com/office/drawing/2014/main" id="{E23647E1-6344-491E-85BE-1305C914AF0A}"/>
               </a:ext>
             </a:extLst>
           </p:cNvPr>
@@ -24610,7 +24752,7 @@
           <p:cNvPr id="27" name="Huiswerk">
             <a:extLst xmlns:a="http://schemas.openxmlformats.org/drawingml/2006/main">
               <a:ext uri="{FF2B5EF4-FFF2-40B4-BE49-F238E27FC236}">
-                <a16:creationId xmlns:a16="http://schemas.microsoft.com/office/drawing/2014/main" id="{BD6FA132-3995-4DD2-85DB-037DDB7B2D04}"/>
+                <a16:creationId xmlns:a16="http://schemas.microsoft.com/office/drawing/2014/main" id="{DD55CB86-9258-4072-ACA2-253A528961D0}"/>
               </a:ext>
             </a:extLst>
           </p:cNvPr>
@@ -24667,7 +24809,7 @@
           <p:cNvPr id="28" name="overview-homework">
             <a:extLst xmlns:a="http://schemas.openxmlformats.org/drawingml/2006/main">
               <a:ext uri="{FF2B5EF4-FFF2-40B4-BE49-F238E27FC236}">
-                <a16:creationId xmlns:a16="http://schemas.microsoft.com/office/drawing/2014/main" id="{5AA8D026-290E-45E4-8700-52C02209475E}"/>
+                <a16:creationId xmlns:a16="http://schemas.microsoft.com/office/drawing/2014/main" id="{E9C26179-DA3E-45C1-B96C-96624979E8CA}"/>
               </a:ext>
             </a:extLst>
           </p:cNvPr>
@@ -24814,7 +24956,7 @@
     </p:spTree>
     <p:extLst>
       <p:ext uri="{BB962C8B-B14F-4D97-AF65-F5344CB8AC3E}">
-        <p14:creationId xmlns:p14="http://schemas.microsoft.com/office/powerpoint/2010/main" val="849523286"/>
+        <p14:creationId xmlns:p14="http://schemas.microsoft.com/office/powerpoint/2010/main" val="368532537"/>
       </p:ext>
     </p:extLst>
   </p:cSld>
@@ -24845,7 +24987,7 @@
           <p:cNvPr id="9" name="Opgave 5 · SmoothBox">
             <a:extLst xmlns:a="http://schemas.openxmlformats.org/drawingml/2006/main">
               <a:ext uri="{FF2B5EF4-FFF2-40B4-BE49-F238E27FC236}">
-                <a16:creationId xmlns:a16="http://schemas.microsoft.com/office/drawing/2014/main" id="{F5EAC701-F168-46CD-8234-5D289C529D02}"/>
+                <a16:creationId xmlns:a16="http://schemas.microsoft.com/office/drawing/2014/main" id="{D5C6C587-05FB-4F4B-A96D-1C59A2F31D60}"/>
               </a:ext>
             </a:extLst>
           </p:cNvPr>
@@ -24902,7 +25044,7 @@
           <p:cNvPr id="2" name="">
             <a:extLst xmlns:a="http://schemas.openxmlformats.org/drawingml/2006/main">
               <a:ext uri="{FF2B5EF4-FFF2-40B4-BE49-F238E27FC236}">
-                <a16:creationId xmlns:a16="http://schemas.microsoft.com/office/drawing/2014/main" id="{F84119AA-BEF1-4709-9021-9BBD98D493FD}"/>
+                <a16:creationId xmlns:a16="http://schemas.microsoft.com/office/drawing/2014/main" id="{66EDFB57-7168-4D73-8022-7E2348D64CD0}"/>
               </a:ext>
             </a:extLst>
           </p:cNvPr>
@@ -24931,7 +25073,7 @@
           <p:cNvPr id="3" name="§2.1.4 Gemengde opgaven · Opgave 5 · Boekpagina 32–33">
             <a:extLst xmlns:a="http://schemas.openxmlformats.org/drawingml/2006/main">
               <a:ext uri="{FF2B5EF4-FFF2-40B4-BE49-F238E27FC236}">
-                <a16:creationId xmlns:a16="http://schemas.microsoft.com/office/drawing/2014/main" id="{74E5307D-FD7F-49E1-AC15-5699C788B501}"/>
+                <a16:creationId xmlns:a16="http://schemas.microsoft.com/office/drawing/2014/main" id="{38E802E2-D117-4ADC-ADAF-84E4D51FB8A7}"/>
               </a:ext>
             </a:extLst>
           </p:cNvPr>
@@ -24988,7 +25130,7 @@
           <p:cNvPr id="4" name="slide-number">
             <a:extLst xmlns:a="http://schemas.openxmlformats.org/drawingml/2006/main">
               <a:ext uri="{FF2B5EF4-FFF2-40B4-BE49-F238E27FC236}">
-                <a16:creationId xmlns:a16="http://schemas.microsoft.com/office/drawing/2014/main" id="{9F287EE4-E769-42F9-B0CE-7AFDEFE16547}"/>
+                <a16:creationId xmlns:a16="http://schemas.microsoft.com/office/drawing/2014/main" id="{A4BB6332-7C0C-4E6B-8E04-32346CF5711B}"/>
               </a:ext>
             </a:extLst>
           </p:cNvPr>
@@ -25045,7 +25187,7 @@
           <p:cNvPr id="5" name="Twee festivaldagen · Maximaal 1.000 lunchboxen per dag">
             <a:extLst xmlns:a="http://schemas.openxmlformats.org/drawingml/2006/main">
               <a:ext uri="{FF2B5EF4-FFF2-40B4-BE49-F238E27FC236}">
-                <a16:creationId xmlns:a16="http://schemas.microsoft.com/office/drawing/2014/main" id="{681EC735-5650-463C-82C8-A8DBB0868E15}"/>
+                <a16:creationId xmlns:a16="http://schemas.microsoft.com/office/drawing/2014/main" id="{09A65ED5-2816-4B7D-BFA5-41602B7B29CE}"/>
               </a:ext>
             </a:extLst>
           </p:cNvPr>
@@ -25102,7 +25244,7 @@
           <p:cNvPr id="6" name="Alle gemaakte lunchboxen worden voor € 5 per stuk verkocht. ">
             <a:extLst xmlns:a="http://schemas.openxmlformats.org/drawingml/2006/main">
               <a:ext uri="{FF2B5EF4-FFF2-40B4-BE49-F238E27FC236}">
-                <a16:creationId xmlns:a16="http://schemas.microsoft.com/office/drawing/2014/main" id="{CC64EB83-091C-4A7A-9437-55CF850CAE64}"/>
+                <a16:creationId xmlns:a16="http://schemas.microsoft.com/office/drawing/2014/main" id="{60A1133E-767C-4543-8BAF-4EA255761EC6}"/>
               </a:ext>
             </a:extLst>
           </p:cNvPr>
@@ -25159,7 +25301,7 @@
           <p:cNvPr id="7" name="Bron A · Vrijdag: het gewone menu">
             <a:extLst xmlns:a="http://schemas.openxmlformats.org/drawingml/2006/main">
               <a:ext uri="{FF2B5EF4-FFF2-40B4-BE49-F238E27FC236}">
-                <a16:creationId xmlns:a16="http://schemas.microsoft.com/office/drawing/2014/main" id="{F471F391-BAB7-4A4F-A4EC-072707054173}"/>
+                <a16:creationId xmlns:a16="http://schemas.microsoft.com/office/drawing/2014/main" id="{3EFFD584-726F-46C6-93A6-ECD1FBAF7F72}"/>
               </a:ext>
             </a:extLst>
           </p:cNvPr>
@@ -25436,7 +25578,7 @@
     </p:spTree>
     <p:extLst>
       <p:ext uri="{BB962C8B-B14F-4D97-AF65-F5344CB8AC3E}">
-        <p14:creationId xmlns:p14="http://schemas.microsoft.com/office/powerpoint/2010/main" val="1245276223"/>
+        <p14:creationId xmlns:p14="http://schemas.microsoft.com/office/powerpoint/2010/main" val="1768439386"/>
       </p:ext>
     </p:extLst>
   </p:cSld>

</xml_diff>